<commit_message>
literature. text for thread. pptx
</commit_message>
<xml_diff>
--- a/docs/starukhin_dissertation/magister_pres.pptx
+++ b/docs/starukhin_dissertation/magister_pres.pptx
@@ -149,7 +149,7 @@
       </p:grpSpPr>
       <p:sp>
         <p:nvSpPr>
-          <p:cNvPr id="1955735315" name="Верхний колонтитул 1"/>
+          <p:cNvPr id="378152317" name="Верхний колонтитул 1"/>
           <p:cNvSpPr>
             <a:spLocks noGrp="1"/>
           </p:cNvSpPr>
@@ -183,7 +183,7 @@
       </p:sp>
       <p:sp>
         <p:nvSpPr>
-          <p:cNvPr id="75313338" name="Дата 2"/>
+          <p:cNvPr id="1512979661" name="Дата 2"/>
           <p:cNvSpPr>
             <a:spLocks noGrp="1"/>
           </p:cNvSpPr>
@@ -221,7 +221,7 @@
       </p:sp>
       <p:sp>
         <p:nvSpPr>
-          <p:cNvPr id="1462071746" name="Образ слайда 3"/>
+          <p:cNvPr id="57264332" name="Образ слайда 3"/>
           <p:cNvSpPr>
             <a:spLocks noChangeAspect="1" noGrp="1" noRot="1"/>
           </p:cNvSpPr>
@@ -257,7 +257,7 @@
       </p:sp>
       <p:sp>
         <p:nvSpPr>
-          <p:cNvPr id="1029992306" name="Заметки 4"/>
+          <p:cNvPr id="41142498" name="Заметки 4"/>
           <p:cNvSpPr>
             <a:spLocks noGrp="1"/>
           </p:cNvSpPr>
@@ -331,7 +331,7 @@
       </p:sp>
       <p:sp>
         <p:nvSpPr>
-          <p:cNvPr id="2013086466" name="Нижний колонтитул 5"/>
+          <p:cNvPr id="1635327804" name="Нижний колонтитул 5"/>
           <p:cNvSpPr>
             <a:spLocks noGrp="1"/>
           </p:cNvSpPr>
@@ -365,7 +365,7 @@
       </p:sp>
       <p:sp>
         <p:nvSpPr>
-          <p:cNvPr id="777271291" name="Номер слайда 6"/>
+          <p:cNvPr id="1277181526" name="Номер слайда 6"/>
           <p:cNvSpPr>
             <a:spLocks noGrp="1"/>
           </p:cNvSpPr>
@@ -518,7 +518,7 @@
       </p:grpSpPr>
       <p:sp>
         <p:nvSpPr>
-          <p:cNvPr id="1111457970" name="Slide Image Placeholder 1"/>
+          <p:cNvPr id="648512038" name="Slide Image Placeholder 1"/>
           <p:cNvSpPr>
             <a:spLocks noChangeAspect="1" noGrp="1" noRot="1"/>
           </p:cNvSpPr>
@@ -530,7 +530,7 @@
       </p:sp>
       <p:sp>
         <p:nvSpPr>
-          <p:cNvPr id="1825404917" name="Notes Placeholder 2"/>
+          <p:cNvPr id="227306547" name="Notes Placeholder 2"/>
           <p:cNvSpPr>
             <a:spLocks noGrp="1"/>
           </p:cNvSpPr>
@@ -552,7 +552,7 @@
       </p:sp>
       <p:sp>
         <p:nvSpPr>
-          <p:cNvPr id="2129937924" name="Slide Number Placeholder 3"/>
+          <p:cNvPr id="1444462650" name="Slide Number Placeholder 3"/>
           <p:cNvSpPr>
             <a:spLocks noGrp="1"/>
           </p:cNvSpPr>
@@ -603,7 +603,7 @@
       </p:grpSpPr>
       <p:sp>
         <p:nvSpPr>
-          <p:cNvPr id="3946966" name="Slide Image Placeholder 1"/>
+          <p:cNvPr id="2005682416" name="Slide Image Placeholder 1"/>
           <p:cNvSpPr>
             <a:spLocks noChangeAspect="1" noGrp="1" noRot="1"/>
           </p:cNvSpPr>
@@ -615,7 +615,7 @@
       </p:sp>
       <p:sp>
         <p:nvSpPr>
-          <p:cNvPr id="474051137" name="Notes Placeholder 2"/>
+          <p:cNvPr id="573031710" name="Notes Placeholder 2"/>
           <p:cNvSpPr>
             <a:spLocks noGrp="1"/>
           </p:cNvSpPr>
@@ -637,7 +637,7 @@
       </p:sp>
       <p:sp>
         <p:nvSpPr>
-          <p:cNvPr id="1818038476" name="Slide Number Placeholder 3"/>
+          <p:cNvPr id="1333981905" name="Slide Number Placeholder 3"/>
           <p:cNvSpPr>
             <a:spLocks noGrp="1"/>
           </p:cNvSpPr>
@@ -688,7 +688,7 @@
       </p:grpSpPr>
       <p:sp>
         <p:nvSpPr>
-          <p:cNvPr id="314302593" name="Slide Image Placeholder 1"/>
+          <p:cNvPr id="130361602" name="Slide Image Placeholder 1"/>
           <p:cNvSpPr>
             <a:spLocks noChangeAspect="1" noGrp="1" noRot="1"/>
           </p:cNvSpPr>
@@ -700,7 +700,7 @@
       </p:sp>
       <p:sp>
         <p:nvSpPr>
-          <p:cNvPr id="1824163988" name="Notes Placeholder 2"/>
+          <p:cNvPr id="1892395812" name="Notes Placeholder 2"/>
           <p:cNvSpPr>
             <a:spLocks noGrp="1"/>
           </p:cNvSpPr>
@@ -722,7 +722,7 @@
       </p:sp>
       <p:sp>
         <p:nvSpPr>
-          <p:cNvPr id="1476792029" name="Slide Number Placeholder 3"/>
+          <p:cNvPr id="841219195" name="Slide Number Placeholder 3"/>
           <p:cNvSpPr>
             <a:spLocks noGrp="1"/>
           </p:cNvSpPr>
@@ -773,7 +773,7 @@
       </p:grpSpPr>
       <p:sp>
         <p:nvSpPr>
-          <p:cNvPr id="889820135" name="Slide Image Placeholder 1"/>
+          <p:cNvPr id="1906292594" name="Slide Image Placeholder 1"/>
           <p:cNvSpPr>
             <a:spLocks noChangeAspect="1" noGrp="1" noRot="1"/>
           </p:cNvSpPr>
@@ -785,7 +785,7 @@
       </p:sp>
       <p:sp>
         <p:nvSpPr>
-          <p:cNvPr id="535589936" name="Notes Placeholder 2"/>
+          <p:cNvPr id="800672914" name="Notes Placeholder 2"/>
           <p:cNvSpPr>
             <a:spLocks noGrp="1"/>
           </p:cNvSpPr>
@@ -807,7 +807,7 @@
       </p:sp>
       <p:sp>
         <p:nvSpPr>
-          <p:cNvPr id="2073365242" name="Slide Number Placeholder 3"/>
+          <p:cNvPr id="746027177" name="Slide Number Placeholder 3"/>
           <p:cNvSpPr>
             <a:spLocks noGrp="1"/>
           </p:cNvSpPr>
@@ -858,7 +858,7 @@
       </p:grpSpPr>
       <p:sp>
         <p:nvSpPr>
-          <p:cNvPr id="527662197" name="Slide Image Placeholder 1"/>
+          <p:cNvPr id="1679470708" name="Slide Image Placeholder 1"/>
           <p:cNvSpPr>
             <a:spLocks noChangeAspect="1" noGrp="1" noRot="1"/>
           </p:cNvSpPr>
@@ -870,7 +870,7 @@
       </p:sp>
       <p:sp>
         <p:nvSpPr>
-          <p:cNvPr id="421782712" name="Notes Placeholder 2"/>
+          <p:cNvPr id="1954097245" name="Notes Placeholder 2"/>
           <p:cNvSpPr>
             <a:spLocks noGrp="1"/>
           </p:cNvSpPr>
@@ -892,7 +892,7 @@
       </p:sp>
       <p:sp>
         <p:nvSpPr>
-          <p:cNvPr id="183687219" name="Slide Number Placeholder 3"/>
+          <p:cNvPr id="466385429" name="Slide Number Placeholder 3"/>
           <p:cNvSpPr>
             <a:spLocks noGrp="1"/>
           </p:cNvSpPr>
@@ -943,7 +943,7 @@
       </p:grpSpPr>
       <p:sp>
         <p:nvSpPr>
-          <p:cNvPr id="1123376815" name="Slide Image Placeholder 1"/>
+          <p:cNvPr id="2067722888" name="Slide Image Placeholder 1"/>
           <p:cNvSpPr>
             <a:spLocks noChangeAspect="1" noGrp="1" noRot="1"/>
           </p:cNvSpPr>
@@ -955,7 +955,7 @@
       </p:sp>
       <p:sp>
         <p:nvSpPr>
-          <p:cNvPr id="226207624" name="Notes Placeholder 2"/>
+          <p:cNvPr id="1647924168" name="Notes Placeholder 2"/>
           <p:cNvSpPr>
             <a:spLocks noGrp="1"/>
           </p:cNvSpPr>
@@ -977,7 +977,7 @@
       </p:sp>
       <p:sp>
         <p:nvSpPr>
-          <p:cNvPr id="576575404" name="Slide Number Placeholder 3"/>
+          <p:cNvPr id="238480203" name="Slide Number Placeholder 3"/>
           <p:cNvSpPr>
             <a:spLocks noGrp="1"/>
           </p:cNvSpPr>
@@ -1028,7 +1028,7 @@
       </p:grpSpPr>
       <p:sp>
         <p:nvSpPr>
-          <p:cNvPr id="966879587" name="Slide Image Placeholder 1"/>
+          <p:cNvPr id="1420294490" name="Slide Image Placeholder 1"/>
           <p:cNvSpPr>
             <a:spLocks noChangeAspect="1" noGrp="1" noRot="1"/>
           </p:cNvSpPr>
@@ -1040,7 +1040,7 @@
       </p:sp>
       <p:sp>
         <p:nvSpPr>
-          <p:cNvPr id="1794322228" name="Notes Placeholder 2"/>
+          <p:cNvPr id="1562437981" name="Notes Placeholder 2"/>
           <p:cNvSpPr>
             <a:spLocks noGrp="1"/>
           </p:cNvSpPr>
@@ -1062,7 +1062,7 @@
       </p:sp>
       <p:sp>
         <p:nvSpPr>
-          <p:cNvPr id="16873417" name="Slide Number Placeholder 3"/>
+          <p:cNvPr id="1772592446" name="Slide Number Placeholder 3"/>
           <p:cNvSpPr>
             <a:spLocks noGrp="1"/>
           </p:cNvSpPr>
@@ -1113,7 +1113,7 @@
       </p:grpSpPr>
       <p:sp>
         <p:nvSpPr>
-          <p:cNvPr id="1703238532" name="Slide Image Placeholder 1"/>
+          <p:cNvPr id="1660077007" name="Slide Image Placeholder 1"/>
           <p:cNvSpPr>
             <a:spLocks noChangeAspect="1" noGrp="1" noRot="1"/>
           </p:cNvSpPr>
@@ -1125,7 +1125,7 @@
       </p:sp>
       <p:sp>
         <p:nvSpPr>
-          <p:cNvPr id="1088565514" name="Notes Placeholder 2"/>
+          <p:cNvPr id="1617119750" name="Notes Placeholder 2"/>
           <p:cNvSpPr>
             <a:spLocks noGrp="1"/>
           </p:cNvSpPr>
@@ -1147,7 +1147,7 @@
       </p:sp>
       <p:sp>
         <p:nvSpPr>
-          <p:cNvPr id="815814546" name="Slide Number Placeholder 3"/>
+          <p:cNvPr id="1295409349" name="Slide Number Placeholder 3"/>
           <p:cNvSpPr>
             <a:spLocks noGrp="1"/>
           </p:cNvSpPr>
@@ -1198,7 +1198,7 @@
       </p:grpSpPr>
       <p:sp>
         <p:nvSpPr>
-          <p:cNvPr id="36414649" name="Slide Image Placeholder 1"/>
+          <p:cNvPr id="1115521371" name="Slide Image Placeholder 1"/>
           <p:cNvSpPr>
             <a:spLocks noChangeAspect="1" noGrp="1" noRot="1"/>
           </p:cNvSpPr>
@@ -1210,7 +1210,7 @@
       </p:sp>
       <p:sp>
         <p:nvSpPr>
-          <p:cNvPr id="1925784116" name="Notes Placeholder 2"/>
+          <p:cNvPr id="1638792018" name="Notes Placeholder 2"/>
           <p:cNvSpPr>
             <a:spLocks noGrp="1"/>
           </p:cNvSpPr>
@@ -1232,7 +1232,7 @@
       </p:sp>
       <p:sp>
         <p:nvSpPr>
-          <p:cNvPr id="137985884" name="Slide Number Placeholder 3"/>
+          <p:cNvPr id="1906447812" name="Slide Number Placeholder 3"/>
           <p:cNvSpPr>
             <a:spLocks noGrp="1"/>
           </p:cNvSpPr>
@@ -1283,7 +1283,7 @@
       </p:grpSpPr>
       <p:sp>
         <p:nvSpPr>
-          <p:cNvPr id="1305798050" name="Slide Image Placeholder 1"/>
+          <p:cNvPr id="1663655987" name="Slide Image Placeholder 1"/>
           <p:cNvSpPr>
             <a:spLocks noChangeAspect="1" noGrp="1" noRot="1"/>
           </p:cNvSpPr>
@@ -1295,7 +1295,7 @@
       </p:sp>
       <p:sp>
         <p:nvSpPr>
-          <p:cNvPr id="2062024955" name="Notes Placeholder 2"/>
+          <p:cNvPr id="107266559" name="Notes Placeholder 2"/>
           <p:cNvSpPr>
             <a:spLocks noGrp="1"/>
           </p:cNvSpPr>
@@ -1317,7 +1317,7 @@
       </p:sp>
       <p:sp>
         <p:nvSpPr>
-          <p:cNvPr id="2041553537" name="Slide Number Placeholder 3"/>
+          <p:cNvPr id="1481685124" name="Slide Number Placeholder 3"/>
           <p:cNvSpPr>
             <a:spLocks noGrp="1"/>
           </p:cNvSpPr>
@@ -1368,7 +1368,7 @@
       </p:grpSpPr>
       <p:sp>
         <p:nvSpPr>
-          <p:cNvPr id="1380656609" name="Slide Image Placeholder 1"/>
+          <p:cNvPr id="887483382" name="Slide Image Placeholder 1"/>
           <p:cNvSpPr>
             <a:spLocks noChangeAspect="1" noGrp="1" noRot="1"/>
           </p:cNvSpPr>
@@ -1380,7 +1380,7 @@
       </p:sp>
       <p:sp>
         <p:nvSpPr>
-          <p:cNvPr id="581201666" name="Notes Placeholder 2"/>
+          <p:cNvPr id="765902535" name="Notes Placeholder 2"/>
           <p:cNvSpPr>
             <a:spLocks noGrp="1"/>
           </p:cNvSpPr>
@@ -1402,7 +1402,7 @@
       </p:sp>
       <p:sp>
         <p:nvSpPr>
-          <p:cNvPr id="116745701" name="Slide Number Placeholder 3"/>
+          <p:cNvPr id="1237751632" name="Slide Number Placeholder 3"/>
           <p:cNvSpPr>
             <a:spLocks noGrp="1"/>
           </p:cNvSpPr>
@@ -1453,7 +1453,7 @@
       </p:grpSpPr>
       <p:sp>
         <p:nvSpPr>
-          <p:cNvPr id="973489607" name="Slide Image Placeholder 1"/>
+          <p:cNvPr id="635839017" name="Slide Image Placeholder 1"/>
           <p:cNvSpPr>
             <a:spLocks noChangeAspect="1" noGrp="1" noRot="1"/>
           </p:cNvSpPr>
@@ -1465,7 +1465,7 @@
       </p:sp>
       <p:sp>
         <p:nvSpPr>
-          <p:cNvPr id="454305222" name="Notes Placeholder 2"/>
+          <p:cNvPr id="2038451647" name="Notes Placeholder 2"/>
           <p:cNvSpPr>
             <a:spLocks noGrp="1"/>
           </p:cNvSpPr>
@@ -1487,7 +1487,7 @@
       </p:sp>
       <p:sp>
         <p:nvSpPr>
-          <p:cNvPr id="480711839" name="Slide Number Placeholder 3"/>
+          <p:cNvPr id="656602091" name="Slide Number Placeholder 3"/>
           <p:cNvSpPr>
             <a:spLocks noGrp="1"/>
           </p:cNvSpPr>
@@ -1623,7 +1623,7 @@
       </p:grpSpPr>
       <p:sp>
         <p:nvSpPr>
-          <p:cNvPr id="296686697" name="Slide Image Placeholder 1"/>
+          <p:cNvPr id="141993073" name="Slide Image Placeholder 1"/>
           <p:cNvSpPr>
             <a:spLocks noChangeAspect="1" noGrp="1" noRot="1"/>
           </p:cNvSpPr>
@@ -1635,7 +1635,7 @@
       </p:sp>
       <p:sp>
         <p:nvSpPr>
-          <p:cNvPr id="680896614" name="Notes Placeholder 2"/>
+          <p:cNvPr id="1633962415" name="Notes Placeholder 2"/>
           <p:cNvSpPr>
             <a:spLocks noGrp="1"/>
           </p:cNvSpPr>
@@ -1657,7 +1657,7 @@
       </p:sp>
       <p:sp>
         <p:nvSpPr>
-          <p:cNvPr id="1756825596" name="Slide Number Placeholder 3"/>
+          <p:cNvPr id="1424971454" name="Slide Number Placeholder 3"/>
           <p:cNvSpPr>
             <a:spLocks noGrp="1"/>
           </p:cNvSpPr>
@@ -1708,7 +1708,7 @@
       </p:grpSpPr>
       <p:sp>
         <p:nvSpPr>
-          <p:cNvPr id="1502645111" name="Slide Image Placeholder 1"/>
+          <p:cNvPr id="627102878" name="Slide Image Placeholder 1"/>
           <p:cNvSpPr>
             <a:spLocks noChangeAspect="1" noGrp="1" noRot="1"/>
           </p:cNvSpPr>
@@ -1720,7 +1720,7 @@
       </p:sp>
       <p:sp>
         <p:nvSpPr>
-          <p:cNvPr id="762434863" name="Notes Placeholder 2"/>
+          <p:cNvPr id="1154629852" name="Notes Placeholder 2"/>
           <p:cNvSpPr>
             <a:spLocks noGrp="1"/>
           </p:cNvSpPr>
@@ -1742,7 +1742,7 @@
       </p:sp>
       <p:sp>
         <p:nvSpPr>
-          <p:cNvPr id="1898101853" name="Slide Number Placeholder 3"/>
+          <p:cNvPr id="1348789066" name="Slide Number Placeholder 3"/>
           <p:cNvSpPr>
             <a:spLocks noGrp="1"/>
           </p:cNvSpPr>
@@ -1793,7 +1793,7 @@
       </p:grpSpPr>
       <p:sp>
         <p:nvSpPr>
-          <p:cNvPr id="2078483540" name="Slide Image Placeholder 1"/>
+          <p:cNvPr id="8561268" name="Slide Image Placeholder 1"/>
           <p:cNvSpPr>
             <a:spLocks noChangeAspect="1" noGrp="1" noRot="1"/>
           </p:cNvSpPr>
@@ -1805,7 +1805,7 @@
       </p:sp>
       <p:sp>
         <p:nvSpPr>
-          <p:cNvPr id="888779382" name="Notes Placeholder 2"/>
+          <p:cNvPr id="2027030018" name="Notes Placeholder 2"/>
           <p:cNvSpPr>
             <a:spLocks noGrp="1"/>
           </p:cNvSpPr>
@@ -1827,7 +1827,7 @@
       </p:sp>
       <p:sp>
         <p:nvSpPr>
-          <p:cNvPr id="421356586" name="Slide Number Placeholder 3"/>
+          <p:cNvPr id="1178049777" name="Slide Number Placeholder 3"/>
           <p:cNvSpPr>
             <a:spLocks noGrp="1"/>
           </p:cNvSpPr>
@@ -1878,7 +1878,7 @@
       </p:grpSpPr>
       <p:sp>
         <p:nvSpPr>
-          <p:cNvPr id="140052192" name="Заголовок 1"/>
+          <p:cNvPr id="1373904706" name="Заголовок 1"/>
           <p:cNvSpPr>
             <a:spLocks noGrp="1"/>
           </p:cNvSpPr>
@@ -1913,7 +1913,7 @@
       </p:sp>
       <p:sp>
         <p:nvSpPr>
-          <p:cNvPr id="23376294" name="Подзаголовок 2"/>
+          <p:cNvPr id="1009674366" name="Подзаголовок 2"/>
           <p:cNvSpPr>
             <a:spLocks noGrp="1"/>
           </p:cNvSpPr>
@@ -1981,7 +1981,7 @@
       </p:sp>
       <p:sp>
         <p:nvSpPr>
-          <p:cNvPr id="1940400193" name="Дата 3"/>
+          <p:cNvPr id="544590494" name="Дата 3"/>
           <p:cNvSpPr>
             <a:spLocks noGrp="1"/>
           </p:cNvSpPr>
@@ -2007,7 +2007,7 @@
       </p:sp>
       <p:sp>
         <p:nvSpPr>
-          <p:cNvPr id="1686587003" name="Нижний колонтитул 4"/>
+          <p:cNvPr id="1521061760" name="Нижний колонтитул 4"/>
           <p:cNvSpPr>
             <a:spLocks noGrp="1"/>
           </p:cNvSpPr>
@@ -2029,7 +2029,7 @@
       </p:sp>
       <p:sp>
         <p:nvSpPr>
-          <p:cNvPr id="1957637731" name="Номер слайда 5"/>
+          <p:cNvPr id="780985378" name="Номер слайда 5"/>
           <p:cNvSpPr>
             <a:spLocks noGrp="1"/>
           </p:cNvSpPr>
@@ -2080,7 +2080,7 @@
       </p:grpSpPr>
       <p:sp>
         <p:nvSpPr>
-          <p:cNvPr id="1905576024" name="Заголовок 1"/>
+          <p:cNvPr id="1644056899" name="Заголовок 1"/>
           <p:cNvSpPr>
             <a:spLocks noGrp="1"/>
           </p:cNvSpPr>
@@ -2106,7 +2106,7 @@
       </p:sp>
       <p:sp>
         <p:nvSpPr>
-          <p:cNvPr id="1175242156" name="Вертикальный текст 2"/>
+          <p:cNvPr id="512398309" name="Вертикальный текст 2"/>
           <p:cNvSpPr>
             <a:spLocks noGrp="1"/>
           </p:cNvSpPr>
@@ -2172,7 +2172,7 @@
       </p:sp>
       <p:sp>
         <p:nvSpPr>
-          <p:cNvPr id="706822787" name="Дата 3"/>
+          <p:cNvPr id="679144038" name="Дата 3"/>
           <p:cNvSpPr>
             <a:spLocks noGrp="1"/>
           </p:cNvSpPr>
@@ -2198,7 +2198,7 @@
       </p:sp>
       <p:sp>
         <p:nvSpPr>
-          <p:cNvPr id="215753915" name="Нижний колонтитул 4"/>
+          <p:cNvPr id="452512991" name="Нижний колонтитул 4"/>
           <p:cNvSpPr>
             <a:spLocks noGrp="1"/>
           </p:cNvSpPr>
@@ -2220,7 +2220,7 @@
       </p:sp>
       <p:sp>
         <p:nvSpPr>
-          <p:cNvPr id="194376644" name="Номер слайда 5"/>
+          <p:cNvPr id="1542403309" name="Номер слайда 5"/>
           <p:cNvSpPr>
             <a:spLocks noGrp="1"/>
           </p:cNvSpPr>
@@ -2271,7 +2271,7 @@
       </p:grpSpPr>
       <p:sp>
         <p:nvSpPr>
-          <p:cNvPr id="1646293112" name="Вертикальный заголовок 1"/>
+          <p:cNvPr id="1421768297" name="Вертикальный заголовок 1"/>
           <p:cNvSpPr>
             <a:spLocks noGrp="1"/>
           </p:cNvSpPr>
@@ -2302,7 +2302,7 @@
       </p:sp>
       <p:sp>
         <p:nvSpPr>
-          <p:cNvPr id="629385852" name="Вертикальный текст 2"/>
+          <p:cNvPr id="701067690" name="Вертикальный текст 2"/>
           <p:cNvSpPr>
             <a:spLocks noGrp="1"/>
           </p:cNvSpPr>
@@ -2373,7 +2373,7 @@
       </p:sp>
       <p:sp>
         <p:nvSpPr>
-          <p:cNvPr id="989467152" name="Дата 3"/>
+          <p:cNvPr id="808753604" name="Дата 3"/>
           <p:cNvSpPr>
             <a:spLocks noGrp="1"/>
           </p:cNvSpPr>
@@ -2399,7 +2399,7 @@
       </p:sp>
       <p:sp>
         <p:nvSpPr>
-          <p:cNvPr id="1777267971" name="Нижний колонтитул 4"/>
+          <p:cNvPr id="1485421111" name="Нижний колонтитул 4"/>
           <p:cNvSpPr>
             <a:spLocks noGrp="1"/>
           </p:cNvSpPr>
@@ -2421,7 +2421,7 @@
       </p:sp>
       <p:sp>
         <p:nvSpPr>
-          <p:cNvPr id="691189460" name="Номер слайда 5"/>
+          <p:cNvPr id="226836088" name="Номер слайда 5"/>
           <p:cNvSpPr>
             <a:spLocks noGrp="1"/>
           </p:cNvSpPr>
@@ -2472,7 +2472,7 @@
       </p:grpSpPr>
       <p:pic>
         <p:nvPicPr>
-          <p:cNvPr id="717531628" name="Picture 6" descr="HD-ShadowLong.png"/>
+          <p:cNvPr id="1403881619" name="Picture 6" descr="HD-ShadowLong.png"/>
           <p:cNvPicPr>
             <a:picLocks noChangeAspect="1"/>
           </p:cNvPicPr>
@@ -2494,7 +2494,7 @@
       </p:pic>
       <p:pic>
         <p:nvPicPr>
-          <p:cNvPr id="822002329" name="Picture 7" descr="HD-ShadowShort.png"/>
+          <p:cNvPr id="2096148953" name="Picture 7" descr="HD-ShadowShort.png"/>
           <p:cNvPicPr>
             <a:picLocks noChangeAspect="1"/>
           </p:cNvPicPr>
@@ -2516,7 +2516,7 @@
       </p:pic>
       <p:sp>
         <p:nvSpPr>
-          <p:cNvPr id="1651184888" name="Rectangle 8"/>
+          <p:cNvPr id="1753135736" name="Rectangle 8"/>
           <p:cNvSpPr/>
           <p:nvPr/>
         </p:nvSpPr>
@@ -2557,7 +2557,7 @@
       </p:sp>
       <p:sp>
         <p:nvSpPr>
-          <p:cNvPr id="1060423919" name="Rectangle 9"/>
+          <p:cNvPr id="228288481" name="Rectangle 9"/>
           <p:cNvSpPr/>
           <p:nvPr/>
         </p:nvSpPr>
@@ -2595,7 +2595,7 @@
       </p:sp>
       <p:sp>
         <p:nvSpPr>
-          <p:cNvPr id="1677816805" name="Title 1"/>
+          <p:cNvPr id="562622277" name="Title 1"/>
           <p:cNvSpPr>
             <a:spLocks noGrp="1"/>
           </p:cNvSpPr>
@@ -2632,7 +2632,7 @@
       </p:sp>
       <p:sp>
         <p:nvSpPr>
-          <p:cNvPr id="1537135183" name="Subtitle 2"/>
+          <p:cNvPr id="1895641195" name="Subtitle 2"/>
           <p:cNvSpPr>
             <a:spLocks noGrp="1"/>
           </p:cNvSpPr>
@@ -2702,7 +2702,7 @@
       </p:sp>
       <p:sp>
         <p:nvSpPr>
-          <p:cNvPr id="1091790241" name="Date Placeholder 3"/>
+          <p:cNvPr id="1355832418" name="Date Placeholder 3"/>
           <p:cNvSpPr>
             <a:spLocks noGrp="1"/>
           </p:cNvSpPr>
@@ -2728,7 +2728,7 @@
       </p:sp>
       <p:sp>
         <p:nvSpPr>
-          <p:cNvPr id="730649976" name="Footer Placeholder 4"/>
+          <p:cNvPr id="194765017" name="Footer Placeholder 4"/>
           <p:cNvSpPr>
             <a:spLocks noGrp="1"/>
           </p:cNvSpPr>
@@ -2750,7 +2750,7 @@
       </p:sp>
       <p:sp>
         <p:nvSpPr>
-          <p:cNvPr id="178927716" name="Slide Number Placeholder 5"/>
+          <p:cNvPr id="1389313679" name="Slide Number Placeholder 5"/>
           <p:cNvSpPr>
             <a:spLocks noGrp="1"/>
           </p:cNvSpPr>
@@ -2806,7 +2806,7 @@
       </p:grpSpPr>
       <p:pic>
         <p:nvPicPr>
-          <p:cNvPr id="336166365" name="Picture 14" descr="HD-ShadowLong.png"/>
+          <p:cNvPr id="905243473" name="Picture 14" descr="HD-ShadowLong.png"/>
           <p:cNvPicPr>
             <a:picLocks noChangeAspect="1"/>
           </p:cNvPicPr>
@@ -2828,7 +2828,7 @@
       </p:pic>
       <p:pic>
         <p:nvPicPr>
-          <p:cNvPr id="1370824802" name="Picture 15" descr="HD-ShadowShort.png"/>
+          <p:cNvPr id="2117509437" name="Picture 15" descr="HD-ShadowShort.png"/>
           <p:cNvPicPr>
             <a:picLocks noChangeAspect="1"/>
           </p:cNvPicPr>
@@ -2850,7 +2850,7 @@
       </p:pic>
       <p:sp>
         <p:nvSpPr>
-          <p:cNvPr id="1136158675" name="Rectangle 16"/>
+          <p:cNvPr id="1476421852" name="Rectangle 16"/>
           <p:cNvSpPr/>
           <p:nvPr/>
         </p:nvSpPr>
@@ -2891,7 +2891,7 @@
       </p:sp>
       <p:sp>
         <p:nvSpPr>
-          <p:cNvPr id="63870765" name="Rectangle 17"/>
+          <p:cNvPr id="1725487788" name="Rectangle 17"/>
           <p:cNvSpPr/>
           <p:nvPr/>
         </p:nvSpPr>
@@ -2929,7 +2929,7 @@
       </p:sp>
       <p:sp>
         <p:nvSpPr>
-          <p:cNvPr id="594587615" name="Title 1"/>
+          <p:cNvPr id="873059702" name="Title 1"/>
           <p:cNvSpPr>
             <a:spLocks noGrp="1"/>
           </p:cNvSpPr>
@@ -2955,7 +2955,7 @@
       </p:sp>
       <p:sp>
         <p:nvSpPr>
-          <p:cNvPr id="766648908" name="Content Placeholder 2"/>
+          <p:cNvPr id="476412194" name="Content Placeholder 2"/>
           <p:cNvSpPr>
             <a:spLocks noGrp="1"/>
           </p:cNvSpPr>
@@ -3021,7 +3021,7 @@
       </p:sp>
       <p:sp>
         <p:nvSpPr>
-          <p:cNvPr id="1232498497" name="Date Placeholder 3"/>
+          <p:cNvPr id="1489004601" name="Date Placeholder 3"/>
           <p:cNvSpPr>
             <a:spLocks noGrp="1"/>
           </p:cNvSpPr>
@@ -3047,7 +3047,7 @@
       </p:sp>
       <p:sp>
         <p:nvSpPr>
-          <p:cNvPr id="613369088" name="Footer Placeholder 4"/>
+          <p:cNvPr id="1518259385" name="Footer Placeholder 4"/>
           <p:cNvSpPr>
             <a:spLocks noGrp="1"/>
           </p:cNvSpPr>
@@ -3069,7 +3069,7 @@
       </p:sp>
       <p:sp>
         <p:nvSpPr>
-          <p:cNvPr id="205946416" name="Slide Number Placeholder 5"/>
+          <p:cNvPr id="1500751933" name="Slide Number Placeholder 5"/>
           <p:cNvSpPr>
             <a:spLocks noGrp="1"/>
           </p:cNvSpPr>
@@ -3120,7 +3120,7 @@
       </p:grpSpPr>
       <p:pic>
         <p:nvPicPr>
-          <p:cNvPr id="353254116" name="Picture 6" descr="HD-ShadowLong.png"/>
+          <p:cNvPr id="1790036656" name="Picture 6" descr="HD-ShadowLong.png"/>
           <p:cNvPicPr>
             <a:picLocks noChangeAspect="1"/>
           </p:cNvPicPr>
@@ -3142,7 +3142,7 @@
       </p:pic>
       <p:pic>
         <p:nvPicPr>
-          <p:cNvPr id="1575720322" name="Picture 7" descr="HD-ShadowShort.png"/>
+          <p:cNvPr id="414040480" name="Picture 7" descr="HD-ShadowShort.png"/>
           <p:cNvPicPr>
             <a:picLocks noChangeAspect="1"/>
           </p:cNvPicPr>
@@ -3164,7 +3164,7 @@
       </p:pic>
       <p:sp>
         <p:nvSpPr>
-          <p:cNvPr id="778678633" name="Rectangle 8"/>
+          <p:cNvPr id="1894440177" name="Rectangle 8"/>
           <p:cNvSpPr/>
           <p:nvPr/>
         </p:nvSpPr>
@@ -3205,7 +3205,7 @@
       </p:sp>
       <p:sp>
         <p:nvSpPr>
-          <p:cNvPr id="1641099088" name="Rectangle 9"/>
+          <p:cNvPr id="650471797" name="Rectangle 9"/>
           <p:cNvSpPr/>
           <p:nvPr/>
         </p:nvSpPr>
@@ -3243,7 +3243,7 @@
       </p:sp>
       <p:sp>
         <p:nvSpPr>
-          <p:cNvPr id="460382468" name="Title 1"/>
+          <p:cNvPr id="875870215" name="Title 1"/>
           <p:cNvSpPr>
             <a:spLocks noGrp="1"/>
           </p:cNvSpPr>
@@ -3280,7 +3280,7 @@
       </p:sp>
       <p:sp>
         <p:nvSpPr>
-          <p:cNvPr id="44447529" name="Text Placeholder 2"/>
+          <p:cNvPr id="906931653" name="Text Placeholder 2"/>
           <p:cNvSpPr>
             <a:spLocks noGrp="1"/>
           </p:cNvSpPr>
@@ -3404,7 +3404,7 @@
       </p:sp>
       <p:sp>
         <p:nvSpPr>
-          <p:cNvPr id="363968583" name="Date Placeholder 3"/>
+          <p:cNvPr id="1019307359" name="Date Placeholder 3"/>
           <p:cNvSpPr>
             <a:spLocks noGrp="1"/>
           </p:cNvSpPr>
@@ -3430,7 +3430,7 @@
       </p:sp>
       <p:sp>
         <p:nvSpPr>
-          <p:cNvPr id="479633520" name="Footer Placeholder 4"/>
+          <p:cNvPr id="2103269541" name="Footer Placeholder 4"/>
           <p:cNvSpPr>
             <a:spLocks noGrp="1"/>
           </p:cNvSpPr>
@@ -3452,7 +3452,7 @@
       </p:sp>
       <p:sp>
         <p:nvSpPr>
-          <p:cNvPr id="1669262745" name="Slide Number Placeholder 5"/>
+          <p:cNvPr id="1499869823" name="Slide Number Placeholder 5"/>
           <p:cNvSpPr>
             <a:spLocks noGrp="1"/>
           </p:cNvSpPr>
@@ -3508,7 +3508,7 @@
       </p:grpSpPr>
       <p:pic>
         <p:nvPicPr>
-          <p:cNvPr id="818672249" name="Picture 7" descr="HD-ShadowLong.png"/>
+          <p:cNvPr id="1136653382" name="Picture 7" descr="HD-ShadowLong.png"/>
           <p:cNvPicPr>
             <a:picLocks noChangeAspect="1"/>
           </p:cNvPicPr>
@@ -3530,7 +3530,7 @@
       </p:pic>
       <p:pic>
         <p:nvPicPr>
-          <p:cNvPr id="986086892" name="Picture 8" descr="HD-ShadowShort.png"/>
+          <p:cNvPr id="336124619" name="Picture 8" descr="HD-ShadowShort.png"/>
           <p:cNvPicPr>
             <a:picLocks noChangeAspect="1"/>
           </p:cNvPicPr>
@@ -3552,7 +3552,7 @@
       </p:pic>
       <p:sp>
         <p:nvSpPr>
-          <p:cNvPr id="1005060902" name="Rectangle 9"/>
+          <p:cNvPr id="985293963" name="Rectangle 9"/>
           <p:cNvSpPr/>
           <p:nvPr/>
         </p:nvSpPr>
@@ -3593,7 +3593,7 @@
       </p:sp>
       <p:sp>
         <p:nvSpPr>
-          <p:cNvPr id="1176010605" name="Rectangle 10"/>
+          <p:cNvPr id="1434793917" name="Rectangle 10"/>
           <p:cNvSpPr/>
           <p:nvPr/>
         </p:nvSpPr>
@@ -3631,7 +3631,7 @@
       </p:sp>
       <p:sp>
         <p:nvSpPr>
-          <p:cNvPr id="1802100821" name="Title 1"/>
+          <p:cNvPr id="1902558729" name="Title 1"/>
           <p:cNvSpPr>
             <a:spLocks noGrp="1"/>
           </p:cNvSpPr>
@@ -3657,7 +3657,7 @@
       </p:sp>
       <p:sp>
         <p:nvSpPr>
-          <p:cNvPr id="1663097457" name="Content Placeholder 2"/>
+          <p:cNvPr id="1115954143" name="Content Placeholder 2"/>
           <p:cNvSpPr>
             <a:spLocks noGrp="1"/>
           </p:cNvSpPr>
@@ -3728,7 +3728,7 @@
       </p:sp>
       <p:sp>
         <p:nvSpPr>
-          <p:cNvPr id="150638092" name="Content Placeholder 3"/>
+          <p:cNvPr id="762798461" name="Content Placeholder 3"/>
           <p:cNvSpPr>
             <a:spLocks noGrp="1"/>
           </p:cNvSpPr>
@@ -3799,7 +3799,7 @@
       </p:sp>
       <p:sp>
         <p:nvSpPr>
-          <p:cNvPr id="1271690154" name="Date Placeholder 4"/>
+          <p:cNvPr id="1483676051" name="Date Placeholder 4"/>
           <p:cNvSpPr>
             <a:spLocks noGrp="1"/>
           </p:cNvSpPr>
@@ -3825,7 +3825,7 @@
       </p:sp>
       <p:sp>
         <p:nvSpPr>
-          <p:cNvPr id="1528028584" name="Footer Placeholder 5"/>
+          <p:cNvPr id="2057019045" name="Footer Placeholder 5"/>
           <p:cNvSpPr>
             <a:spLocks noGrp="1"/>
           </p:cNvSpPr>
@@ -3847,7 +3847,7 @@
       </p:sp>
       <p:sp>
         <p:nvSpPr>
-          <p:cNvPr id="1114449391" name="Slide Number Placeholder 6"/>
+          <p:cNvPr id="1121496567" name="Slide Number Placeholder 6"/>
           <p:cNvSpPr>
             <a:spLocks noGrp="1"/>
           </p:cNvSpPr>
@@ -3898,7 +3898,7 @@
       </p:grpSpPr>
       <p:pic>
         <p:nvPicPr>
-          <p:cNvPr id="831601874" name="Picture 9" descr="HD-ShadowLong.png"/>
+          <p:cNvPr id="453982463" name="Picture 9" descr="HD-ShadowLong.png"/>
           <p:cNvPicPr>
             <a:picLocks noChangeAspect="1"/>
           </p:cNvPicPr>
@@ -3920,7 +3920,7 @@
       </p:pic>
       <p:pic>
         <p:nvPicPr>
-          <p:cNvPr id="1537817575" name="Picture 10" descr="HD-ShadowShort.png"/>
+          <p:cNvPr id="2132784423" name="Picture 10" descr="HD-ShadowShort.png"/>
           <p:cNvPicPr>
             <a:picLocks noChangeAspect="1"/>
           </p:cNvPicPr>
@@ -3942,7 +3942,7 @@
       </p:pic>
       <p:sp>
         <p:nvSpPr>
-          <p:cNvPr id="780806100" name="Rectangle 11"/>
+          <p:cNvPr id="1364870304" name="Rectangle 11"/>
           <p:cNvSpPr/>
           <p:nvPr/>
         </p:nvSpPr>
@@ -3983,7 +3983,7 @@
       </p:sp>
       <p:sp>
         <p:nvSpPr>
-          <p:cNvPr id="91187196" name="Rectangle 12"/>
+          <p:cNvPr id="542537531" name="Rectangle 12"/>
           <p:cNvSpPr/>
           <p:nvPr/>
         </p:nvSpPr>
@@ -4021,7 +4021,7 @@
       </p:sp>
       <p:sp>
         <p:nvSpPr>
-          <p:cNvPr id="932373780" name="Title 1"/>
+          <p:cNvPr id="1293629978" name="Title 1"/>
           <p:cNvSpPr>
             <a:spLocks noGrp="1"/>
           </p:cNvSpPr>
@@ -4052,7 +4052,7 @@
       </p:sp>
       <p:sp>
         <p:nvSpPr>
-          <p:cNvPr id="1478895919" name="Text Placeholder 2"/>
+          <p:cNvPr id="2105650711" name="Text Placeholder 2"/>
           <p:cNvSpPr>
             <a:spLocks noGrp="1"/>
           </p:cNvSpPr>
@@ -4120,7 +4120,7 @@
       </p:sp>
       <p:sp>
         <p:nvSpPr>
-          <p:cNvPr id="1177602719" name="Content Placeholder 3"/>
+          <p:cNvPr id="1521909877" name="Content Placeholder 3"/>
           <p:cNvSpPr>
             <a:spLocks noGrp="1"/>
           </p:cNvSpPr>
@@ -4191,7 +4191,7 @@
       </p:sp>
       <p:sp>
         <p:nvSpPr>
-          <p:cNvPr id="799017585" name="Text Placeholder 4"/>
+          <p:cNvPr id="572521475" name="Text Placeholder 4"/>
           <p:cNvSpPr>
             <a:spLocks noGrp="1"/>
           </p:cNvSpPr>
@@ -4259,7 +4259,7 @@
       </p:sp>
       <p:sp>
         <p:nvSpPr>
-          <p:cNvPr id="89697077" name="Content Placeholder 5"/>
+          <p:cNvPr id="1040146684" name="Content Placeholder 5"/>
           <p:cNvSpPr>
             <a:spLocks noGrp="1"/>
           </p:cNvSpPr>
@@ -4330,7 +4330,7 @@
       </p:sp>
       <p:sp>
         <p:nvSpPr>
-          <p:cNvPr id="174384561" name="Date Placeholder 6"/>
+          <p:cNvPr id="1725398431" name="Date Placeholder 6"/>
           <p:cNvSpPr>
             <a:spLocks noGrp="1"/>
           </p:cNvSpPr>
@@ -4356,7 +4356,7 @@
       </p:sp>
       <p:sp>
         <p:nvSpPr>
-          <p:cNvPr id="290066173" name="Footer Placeholder 7"/>
+          <p:cNvPr id="1174561090" name="Footer Placeholder 7"/>
           <p:cNvSpPr>
             <a:spLocks noGrp="1"/>
           </p:cNvSpPr>
@@ -4378,7 +4378,7 @@
       </p:sp>
       <p:sp>
         <p:nvSpPr>
-          <p:cNvPr id="374292724" name="Slide Number Placeholder 8"/>
+          <p:cNvPr id="1869461782" name="Slide Number Placeholder 8"/>
           <p:cNvSpPr>
             <a:spLocks noGrp="1"/>
           </p:cNvSpPr>
@@ -4429,7 +4429,7 @@
       </p:grpSpPr>
       <p:pic>
         <p:nvPicPr>
-          <p:cNvPr id="1686801075" name="Picture 5" descr="HD-ShadowLong.png"/>
+          <p:cNvPr id="531131006" name="Picture 5" descr="HD-ShadowLong.png"/>
           <p:cNvPicPr>
             <a:picLocks noChangeAspect="1"/>
           </p:cNvPicPr>
@@ -4451,7 +4451,7 @@
       </p:pic>
       <p:pic>
         <p:nvPicPr>
-          <p:cNvPr id="2071491778" name="Picture 6" descr="HD-ShadowShort.png"/>
+          <p:cNvPr id="77008073" name="Picture 6" descr="HD-ShadowShort.png"/>
           <p:cNvPicPr>
             <a:picLocks noChangeAspect="1"/>
           </p:cNvPicPr>
@@ -4473,7 +4473,7 @@
       </p:pic>
       <p:sp>
         <p:nvSpPr>
-          <p:cNvPr id="1320681226" name="Rectangle 7"/>
+          <p:cNvPr id="1763575175" name="Rectangle 7"/>
           <p:cNvSpPr/>
           <p:nvPr/>
         </p:nvSpPr>
@@ -4514,7 +4514,7 @@
       </p:sp>
       <p:sp>
         <p:nvSpPr>
-          <p:cNvPr id="453781502" name="Rectangle 8"/>
+          <p:cNvPr id="1187585037" name="Rectangle 8"/>
           <p:cNvSpPr/>
           <p:nvPr/>
         </p:nvSpPr>
@@ -4552,7 +4552,7 @@
       </p:sp>
       <p:sp>
         <p:nvSpPr>
-          <p:cNvPr id="1117730881" name="Title 1"/>
+          <p:cNvPr id="1160365433" name="Title 1"/>
           <p:cNvSpPr>
             <a:spLocks noGrp="1"/>
           </p:cNvSpPr>
@@ -4578,7 +4578,7 @@
       </p:sp>
       <p:sp>
         <p:nvSpPr>
-          <p:cNvPr id="2077815952" name="Date Placeholder 2"/>
+          <p:cNvPr id="1884895854" name="Date Placeholder 2"/>
           <p:cNvSpPr>
             <a:spLocks noGrp="1"/>
           </p:cNvSpPr>
@@ -4604,7 +4604,7 @@
       </p:sp>
       <p:sp>
         <p:nvSpPr>
-          <p:cNvPr id="1760348163" name="Footer Placeholder 3"/>
+          <p:cNvPr id="2015138121" name="Footer Placeholder 3"/>
           <p:cNvSpPr>
             <a:spLocks noGrp="1"/>
           </p:cNvSpPr>
@@ -4626,7 +4626,7 @@
       </p:sp>
       <p:sp>
         <p:nvSpPr>
-          <p:cNvPr id="1230245292" name="Slide Number Placeholder 4"/>
+          <p:cNvPr id="656073657" name="Slide Number Placeholder 4"/>
           <p:cNvSpPr>
             <a:spLocks noGrp="1"/>
           </p:cNvSpPr>
@@ -4677,7 +4677,7 @@
       </p:grpSpPr>
       <p:pic>
         <p:nvPicPr>
-          <p:cNvPr id="1202468815" name="Picture 4" descr="HD-ShadowShort.png"/>
+          <p:cNvPr id="332825376" name="Picture 4" descr="HD-ShadowShort.png"/>
           <p:cNvPicPr>
             <a:picLocks noChangeAspect="1"/>
           </p:cNvPicPr>
@@ -4699,7 +4699,7 @@
       </p:pic>
       <p:sp>
         <p:nvSpPr>
-          <p:cNvPr id="1067466000" name="Rectangle 5"/>
+          <p:cNvPr id="134569681" name="Rectangle 5"/>
           <p:cNvSpPr/>
           <p:nvPr/>
         </p:nvSpPr>
@@ -4737,7 +4737,7 @@
       </p:sp>
       <p:sp>
         <p:nvSpPr>
-          <p:cNvPr id="697885031" name="Date Placeholder 1"/>
+          <p:cNvPr id="1368182467" name="Date Placeholder 1"/>
           <p:cNvSpPr>
             <a:spLocks noGrp="1"/>
           </p:cNvSpPr>
@@ -4763,7 +4763,7 @@
       </p:sp>
       <p:sp>
         <p:nvSpPr>
-          <p:cNvPr id="983342965" name="Footer Placeholder 2"/>
+          <p:cNvPr id="683034419" name="Footer Placeholder 2"/>
           <p:cNvSpPr>
             <a:spLocks noGrp="1"/>
           </p:cNvSpPr>
@@ -4785,7 +4785,7 @@
       </p:sp>
       <p:sp>
         <p:nvSpPr>
-          <p:cNvPr id="1413051605" name="Slide Number Placeholder 3"/>
+          <p:cNvPr id="1310934835" name="Slide Number Placeholder 3"/>
           <p:cNvSpPr>
             <a:spLocks noGrp="1"/>
           </p:cNvSpPr>
@@ -4836,7 +4836,7 @@
       </p:grpSpPr>
       <p:pic>
         <p:nvPicPr>
-          <p:cNvPr id="899832884" name="Picture 7" descr="HD-ShadowLong.png"/>
+          <p:cNvPr id="1081114685" name="Picture 7" descr="HD-ShadowLong.png"/>
           <p:cNvPicPr>
             <a:picLocks noChangeAspect="1"/>
           </p:cNvPicPr>
@@ -4858,7 +4858,7 @@
       </p:pic>
       <p:pic>
         <p:nvPicPr>
-          <p:cNvPr id="378975475" name="Picture 8" descr="HD-ShadowShort.png"/>
+          <p:cNvPr id="305940265" name="Picture 8" descr="HD-ShadowShort.png"/>
           <p:cNvPicPr>
             <a:picLocks noChangeAspect="1"/>
           </p:cNvPicPr>
@@ -4880,7 +4880,7 @@
       </p:pic>
       <p:sp>
         <p:nvSpPr>
-          <p:cNvPr id="770462109" name="Rectangle 9"/>
+          <p:cNvPr id="1562860586" name="Rectangle 9"/>
           <p:cNvSpPr/>
           <p:nvPr/>
         </p:nvSpPr>
@@ -4921,7 +4921,7 @@
       </p:sp>
       <p:sp>
         <p:nvSpPr>
-          <p:cNvPr id="1258624316" name="Rectangle 10"/>
+          <p:cNvPr id="1856307066" name="Rectangle 10"/>
           <p:cNvSpPr/>
           <p:nvPr/>
         </p:nvSpPr>
@@ -4959,7 +4959,7 @@
       </p:sp>
       <p:sp>
         <p:nvSpPr>
-          <p:cNvPr id="355281627" name="Title 1"/>
+          <p:cNvPr id="1576910892" name="Title 1"/>
           <p:cNvSpPr>
             <a:spLocks noGrp="1"/>
           </p:cNvSpPr>
@@ -4996,7 +4996,7 @@
       </p:sp>
       <p:sp>
         <p:nvSpPr>
-          <p:cNvPr id="740228987" name="Content Placeholder 2"/>
+          <p:cNvPr id="187148380" name="Content Placeholder 2"/>
           <p:cNvSpPr>
             <a:spLocks noGrp="1"/>
           </p:cNvSpPr>
@@ -5067,7 +5067,7 @@
       </p:sp>
       <p:sp>
         <p:nvSpPr>
-          <p:cNvPr id="885390208" name="Text Placeholder 3"/>
+          <p:cNvPr id="1275811826" name="Text Placeholder 3"/>
           <p:cNvSpPr>
             <a:spLocks noGrp="1"/>
           </p:cNvSpPr>
@@ -5135,7 +5135,7 @@
       </p:sp>
       <p:sp>
         <p:nvSpPr>
-          <p:cNvPr id="1610961616" name="Date Placeholder 4"/>
+          <p:cNvPr id="1026154535" name="Date Placeholder 4"/>
           <p:cNvSpPr>
             <a:spLocks noGrp="1"/>
           </p:cNvSpPr>
@@ -5161,7 +5161,7 @@
       </p:sp>
       <p:sp>
         <p:nvSpPr>
-          <p:cNvPr id="1415274404" name="Footer Placeholder 5"/>
+          <p:cNvPr id="457480428" name="Footer Placeholder 5"/>
           <p:cNvSpPr>
             <a:spLocks noGrp="1"/>
           </p:cNvSpPr>
@@ -5183,7 +5183,7 @@
       </p:sp>
       <p:sp>
         <p:nvSpPr>
-          <p:cNvPr id="1484157297" name="Slide Number Placeholder 6"/>
+          <p:cNvPr id="1631393079" name="Slide Number Placeholder 6"/>
           <p:cNvSpPr>
             <a:spLocks noGrp="1"/>
           </p:cNvSpPr>
@@ -5234,7 +5234,7 @@
       </p:grpSpPr>
       <p:sp>
         <p:nvSpPr>
-          <p:cNvPr id="1124047749" name="Заголовок 1"/>
+          <p:cNvPr id="1343928337" name="Заголовок 1"/>
           <p:cNvSpPr>
             <a:spLocks noGrp="1"/>
           </p:cNvSpPr>
@@ -5260,7 +5260,7 @@
       </p:sp>
       <p:sp>
         <p:nvSpPr>
-          <p:cNvPr id="927385587" name="Объект 2"/>
+          <p:cNvPr id="1638231810" name="Объект 2"/>
           <p:cNvSpPr>
             <a:spLocks noGrp="1"/>
           </p:cNvSpPr>
@@ -5326,7 +5326,7 @@
       </p:sp>
       <p:sp>
         <p:nvSpPr>
-          <p:cNvPr id="76557993" name="Дата 3"/>
+          <p:cNvPr id="877500364" name="Дата 3"/>
           <p:cNvSpPr>
             <a:spLocks noGrp="1"/>
           </p:cNvSpPr>
@@ -5352,7 +5352,7 @@
       </p:sp>
       <p:sp>
         <p:nvSpPr>
-          <p:cNvPr id="1178894900" name="Нижний колонтитул 4"/>
+          <p:cNvPr id="980377293" name="Нижний колонтитул 4"/>
           <p:cNvSpPr>
             <a:spLocks noGrp="1"/>
           </p:cNvSpPr>
@@ -5374,7 +5374,7 @@
       </p:sp>
       <p:sp>
         <p:nvSpPr>
-          <p:cNvPr id="1694752303" name="Номер слайда 5"/>
+          <p:cNvPr id="2121216910" name="Номер слайда 5"/>
           <p:cNvSpPr>
             <a:spLocks noGrp="1"/>
           </p:cNvSpPr>
@@ -5425,7 +5425,7 @@
       </p:grpSpPr>
       <p:pic>
         <p:nvPicPr>
-          <p:cNvPr id="619609788" name="Picture 7" descr="HD-ShadowLong.png"/>
+          <p:cNvPr id="1420974376" name="Picture 7" descr="HD-ShadowLong.png"/>
           <p:cNvPicPr>
             <a:picLocks noChangeAspect="1"/>
           </p:cNvPicPr>
@@ -5447,7 +5447,7 @@
       </p:pic>
       <p:pic>
         <p:nvPicPr>
-          <p:cNvPr id="137188809" name="Picture 8" descr="HD-ShadowShort.png"/>
+          <p:cNvPr id="865015418" name="Picture 8" descr="HD-ShadowShort.png"/>
           <p:cNvPicPr>
             <a:picLocks noChangeAspect="1"/>
           </p:cNvPicPr>
@@ -5469,7 +5469,7 @@
       </p:pic>
       <p:sp>
         <p:nvSpPr>
-          <p:cNvPr id="1170122928" name="Rectangle 9"/>
+          <p:cNvPr id="644822259" name="Rectangle 9"/>
           <p:cNvSpPr/>
           <p:nvPr/>
         </p:nvSpPr>
@@ -5510,7 +5510,7 @@
       </p:sp>
       <p:sp>
         <p:nvSpPr>
-          <p:cNvPr id="1945145742" name="Rectangle 10"/>
+          <p:cNvPr id="1021772991" name="Rectangle 10"/>
           <p:cNvSpPr/>
           <p:nvPr/>
         </p:nvSpPr>
@@ -5548,7 +5548,7 @@
       </p:sp>
       <p:sp>
         <p:nvSpPr>
-          <p:cNvPr id="416227685" name="Title 1"/>
+          <p:cNvPr id="921355218" name="Title 1"/>
           <p:cNvSpPr>
             <a:spLocks noGrp="1"/>
           </p:cNvSpPr>
@@ -5585,7 +5585,7 @@
       </p:sp>
       <p:sp>
         <p:nvSpPr>
-          <p:cNvPr id="1404055384" name="Picture Placeholder 2"/>
+          <p:cNvPr id="1697866201" name="Picture Placeholder 2"/>
           <p:cNvSpPr>
             <a:spLocks noChangeAspect="1" noGrp="1"/>
           </p:cNvSpPr>
@@ -5667,7 +5667,7 @@
       </p:sp>
       <p:sp>
         <p:nvSpPr>
-          <p:cNvPr id="933584001" name="Text Placeholder 3"/>
+          <p:cNvPr id="927457874" name="Text Placeholder 3"/>
           <p:cNvSpPr>
             <a:spLocks noGrp="1"/>
           </p:cNvSpPr>
@@ -5735,7 +5735,7 @@
       </p:sp>
       <p:sp>
         <p:nvSpPr>
-          <p:cNvPr id="280673709" name="Date Placeholder 4"/>
+          <p:cNvPr id="1916681737" name="Date Placeholder 4"/>
           <p:cNvSpPr>
             <a:spLocks noGrp="1"/>
           </p:cNvSpPr>
@@ -5761,7 +5761,7 @@
       </p:sp>
       <p:sp>
         <p:nvSpPr>
-          <p:cNvPr id="1459182335" name="Footer Placeholder 5"/>
+          <p:cNvPr id="1238205576" name="Footer Placeholder 5"/>
           <p:cNvSpPr>
             <a:spLocks noGrp="1"/>
           </p:cNvSpPr>
@@ -5783,7 +5783,7 @@
       </p:sp>
       <p:sp>
         <p:nvSpPr>
-          <p:cNvPr id="758059342" name="Slide Number Placeholder 6"/>
+          <p:cNvPr id="1309119975" name="Slide Number Placeholder 6"/>
           <p:cNvSpPr>
             <a:spLocks noGrp="1"/>
           </p:cNvSpPr>
@@ -5834,7 +5834,7 @@
       </p:grpSpPr>
       <p:pic>
         <p:nvPicPr>
-          <p:cNvPr id="1957269967" name="Picture 7" descr="HD-ShadowLong.png"/>
+          <p:cNvPr id="693462766" name="Picture 7" descr="HD-ShadowLong.png"/>
           <p:cNvPicPr>
             <a:picLocks noChangeAspect="1"/>
           </p:cNvPicPr>
@@ -5856,7 +5856,7 @@
       </p:pic>
       <p:pic>
         <p:nvPicPr>
-          <p:cNvPr id="1514993529" name="Picture 8" descr="HD-ShadowShort.png"/>
+          <p:cNvPr id="1209567020" name="Picture 8" descr="HD-ShadowShort.png"/>
           <p:cNvPicPr>
             <a:picLocks noChangeAspect="1"/>
           </p:cNvPicPr>
@@ -5878,7 +5878,7 @@
       </p:pic>
       <p:sp>
         <p:nvSpPr>
-          <p:cNvPr id="1561620832" name="Rectangle 9"/>
+          <p:cNvPr id="1664785485" name="Rectangle 9"/>
           <p:cNvSpPr/>
           <p:nvPr/>
         </p:nvSpPr>
@@ -5919,7 +5919,7 @@
       </p:sp>
       <p:sp>
         <p:nvSpPr>
-          <p:cNvPr id="1427071138" name="Rectangle 10"/>
+          <p:cNvPr id="2097152369" name="Rectangle 10"/>
           <p:cNvSpPr/>
           <p:nvPr/>
         </p:nvSpPr>
@@ -5957,7 +5957,7 @@
       </p:sp>
       <p:sp>
         <p:nvSpPr>
-          <p:cNvPr id="691470946" name="Title 1"/>
+          <p:cNvPr id="1866735379" name="Title 1"/>
           <p:cNvSpPr>
             <a:spLocks noGrp="1"/>
           </p:cNvSpPr>
@@ -5994,7 +5994,7 @@
       </p:sp>
       <p:sp>
         <p:nvSpPr>
-          <p:cNvPr id="77170769" name="Picture Placeholder 2"/>
+          <p:cNvPr id="417445502" name="Picture Placeholder 2"/>
           <p:cNvSpPr>
             <a:spLocks noChangeAspect="1" noGrp="1"/>
           </p:cNvSpPr>
@@ -6076,7 +6076,7 @@
       </p:sp>
       <p:sp>
         <p:nvSpPr>
-          <p:cNvPr id="659848925" name="Text Placeholder 3"/>
+          <p:cNvPr id="1301837205" name="Text Placeholder 3"/>
           <p:cNvSpPr>
             <a:spLocks noGrp="1"/>
           </p:cNvSpPr>
@@ -6144,7 +6144,7 @@
       </p:sp>
       <p:sp>
         <p:nvSpPr>
-          <p:cNvPr id="889160279" name="Date Placeholder 4"/>
+          <p:cNvPr id="1429598428" name="Date Placeholder 4"/>
           <p:cNvSpPr>
             <a:spLocks noGrp="1"/>
           </p:cNvSpPr>
@@ -6170,7 +6170,7 @@
       </p:sp>
       <p:sp>
         <p:nvSpPr>
-          <p:cNvPr id="2146702623" name="Footer Placeholder 5"/>
+          <p:cNvPr id="356251624" name="Footer Placeholder 5"/>
           <p:cNvSpPr>
             <a:spLocks noGrp="1"/>
           </p:cNvSpPr>
@@ -6192,7 +6192,7 @@
       </p:sp>
       <p:sp>
         <p:nvSpPr>
-          <p:cNvPr id="1704121005" name="Slide Number Placeholder 6"/>
+          <p:cNvPr id="295778713" name="Slide Number Placeholder 6"/>
           <p:cNvSpPr>
             <a:spLocks noGrp="1"/>
           </p:cNvSpPr>
@@ -6248,7 +6248,7 @@
       </p:grpSpPr>
       <p:pic>
         <p:nvPicPr>
-          <p:cNvPr id="170072089" name="Picture 7" descr="HD-ShadowLong.png"/>
+          <p:cNvPr id="1288989531" name="Picture 7" descr="HD-ShadowLong.png"/>
           <p:cNvPicPr>
             <a:picLocks noChangeAspect="1"/>
           </p:cNvPicPr>
@@ -6270,7 +6270,7 @@
       </p:pic>
       <p:pic>
         <p:nvPicPr>
-          <p:cNvPr id="1789534247" name="Picture 8" descr="HD-ShadowShort.png"/>
+          <p:cNvPr id="483064988" name="Picture 8" descr="HD-ShadowShort.png"/>
           <p:cNvPicPr>
             <a:picLocks noChangeAspect="1"/>
           </p:cNvPicPr>
@@ -6292,7 +6292,7 @@
       </p:pic>
       <p:sp>
         <p:nvSpPr>
-          <p:cNvPr id="674330875" name="Rectangle 9"/>
+          <p:cNvPr id="783222804" name="Rectangle 9"/>
           <p:cNvSpPr/>
           <p:nvPr/>
         </p:nvSpPr>
@@ -6333,7 +6333,7 @@
       </p:sp>
       <p:sp>
         <p:nvSpPr>
-          <p:cNvPr id="849616050" name="Rectangle 10"/>
+          <p:cNvPr id="1380693280" name="Rectangle 10"/>
           <p:cNvSpPr/>
           <p:nvPr/>
         </p:nvSpPr>
@@ -6371,7 +6371,7 @@
       </p:sp>
       <p:sp>
         <p:nvSpPr>
-          <p:cNvPr id="1610267981" name="Title 1"/>
+          <p:cNvPr id="623822411" name="Title 1"/>
           <p:cNvSpPr>
             <a:spLocks noGrp="1"/>
           </p:cNvSpPr>
@@ -6406,7 +6406,7 @@
       </p:sp>
       <p:sp>
         <p:nvSpPr>
-          <p:cNvPr id="1269433010" name="Text Placeholder 3"/>
+          <p:cNvPr id="1683745583" name="Text Placeholder 3"/>
           <p:cNvSpPr>
             <a:spLocks noGrp="1"/>
           </p:cNvSpPr>
@@ -6474,7 +6474,7 @@
       </p:sp>
       <p:sp>
         <p:nvSpPr>
-          <p:cNvPr id="851562375" name="Date Placeholder 4"/>
+          <p:cNvPr id="1212626459" name="Date Placeholder 4"/>
           <p:cNvSpPr>
             <a:spLocks noGrp="1"/>
           </p:cNvSpPr>
@@ -6500,7 +6500,7 @@
       </p:sp>
       <p:sp>
         <p:nvSpPr>
-          <p:cNvPr id="654204991" name="Footer Placeholder 5"/>
+          <p:cNvPr id="2005237670" name="Footer Placeholder 5"/>
           <p:cNvSpPr>
             <a:spLocks noGrp="1"/>
           </p:cNvSpPr>
@@ -6522,7 +6522,7 @@
       </p:sp>
       <p:sp>
         <p:nvSpPr>
-          <p:cNvPr id="1811007699" name="Slide Number Placeholder 6"/>
+          <p:cNvPr id="1939142324" name="Slide Number Placeholder 6"/>
           <p:cNvSpPr>
             <a:spLocks noGrp="1"/>
           </p:cNvSpPr>
@@ -6578,7 +6578,7 @@
       </p:grpSpPr>
       <p:pic>
         <p:nvPicPr>
-          <p:cNvPr id="410461835" name="Picture 10" descr="HD-ShadowLong.png"/>
+          <p:cNvPr id="360351157" name="Picture 10" descr="HD-ShadowLong.png"/>
           <p:cNvPicPr>
             <a:picLocks noChangeAspect="1"/>
           </p:cNvPicPr>
@@ -6600,7 +6600,7 @@
       </p:pic>
       <p:pic>
         <p:nvPicPr>
-          <p:cNvPr id="1214406087" name="Picture 12" descr="HD-ShadowShort.png"/>
+          <p:cNvPr id="116622883" name="Picture 12" descr="HD-ShadowShort.png"/>
           <p:cNvPicPr>
             <a:picLocks noChangeAspect="1"/>
           </p:cNvPicPr>
@@ -6622,7 +6622,7 @@
       </p:pic>
       <p:sp>
         <p:nvSpPr>
-          <p:cNvPr id="1195859113" name="Rectangle 13"/>
+          <p:cNvPr id="926575259" name="Rectangle 13"/>
           <p:cNvSpPr/>
           <p:nvPr/>
         </p:nvSpPr>
@@ -6663,7 +6663,7 @@
       </p:sp>
       <p:sp>
         <p:nvSpPr>
-          <p:cNvPr id="476953341" name="Rectangle 14"/>
+          <p:cNvPr id="1311358285" name="Rectangle 14"/>
           <p:cNvSpPr/>
           <p:nvPr/>
         </p:nvSpPr>
@@ -6701,7 +6701,7 @@
       </p:sp>
       <p:sp>
         <p:nvSpPr>
-          <p:cNvPr id="833815619" name="Title 1"/>
+          <p:cNvPr id="1303654178" name="Title 1"/>
           <p:cNvSpPr>
             <a:spLocks noGrp="1"/>
           </p:cNvSpPr>
@@ -6736,7 +6736,7 @@
       </p:sp>
       <p:sp>
         <p:nvSpPr>
-          <p:cNvPr id="605049749" name="Text Placeholder 3"/>
+          <p:cNvPr id="1949657302" name="Text Placeholder 3"/>
           <p:cNvSpPr>
             <a:spLocks noGrp="1"/>
           </p:cNvSpPr>
@@ -6806,7 +6806,7 @@
       </p:sp>
       <p:sp>
         <p:nvSpPr>
-          <p:cNvPr id="1639410339" name="Text Placeholder 3"/>
+          <p:cNvPr id="1147887821" name="Text Placeholder 3"/>
           <p:cNvSpPr>
             <a:spLocks noGrp="1"/>
           </p:cNvSpPr>
@@ -6876,7 +6876,7 @@
       </p:sp>
       <p:sp>
         <p:nvSpPr>
-          <p:cNvPr id="2124887498" name="Date Placeholder 4"/>
+          <p:cNvPr id="1442017006" name="Date Placeholder 4"/>
           <p:cNvSpPr>
             <a:spLocks noGrp="1"/>
           </p:cNvSpPr>
@@ -6902,7 +6902,7 @@
       </p:sp>
       <p:sp>
         <p:nvSpPr>
-          <p:cNvPr id="1953554786" name="Footer Placeholder 5"/>
+          <p:cNvPr id="1317648287" name="Footer Placeholder 5"/>
           <p:cNvSpPr>
             <a:spLocks noGrp="1"/>
           </p:cNvSpPr>
@@ -6924,7 +6924,7 @@
       </p:sp>
       <p:sp>
         <p:nvSpPr>
-          <p:cNvPr id="1974195899" name="Slide Number Placeholder 6"/>
+          <p:cNvPr id="2002095456" name="Slide Number Placeholder 6"/>
           <p:cNvSpPr>
             <a:spLocks noGrp="1"/>
           </p:cNvSpPr>
@@ -6955,7 +6955,7 @@
       </p:sp>
       <p:sp>
         <p:nvSpPr>
-          <p:cNvPr id="1118551304" name="TextBox 15"/>
+          <p:cNvPr id="1842168149" name="TextBox 15"/>
           <p:cNvSpPr txBox="1"/>
           <p:nvPr/>
         </p:nvSpPr>
@@ -7059,7 +7059,7 @@
       </p:sp>
       <p:sp>
         <p:nvSpPr>
-          <p:cNvPr id="19085042" name="TextBox 16"/>
+          <p:cNvPr id="1818684327" name="TextBox 16"/>
           <p:cNvSpPr txBox="1"/>
           <p:nvPr/>
         </p:nvSpPr>
@@ -7188,7 +7188,7 @@
       </p:grpSpPr>
       <p:pic>
         <p:nvPicPr>
-          <p:cNvPr id="439439821" name="Picture 8" descr="HD-ShadowLong.png"/>
+          <p:cNvPr id="281661447" name="Picture 8" descr="HD-ShadowLong.png"/>
           <p:cNvPicPr>
             <a:picLocks noChangeAspect="1"/>
           </p:cNvPicPr>
@@ -7210,7 +7210,7 @@
       </p:pic>
       <p:pic>
         <p:nvPicPr>
-          <p:cNvPr id="2143220445" name="Picture 9" descr="HD-ShadowShort.png"/>
+          <p:cNvPr id="2107729278" name="Picture 9" descr="HD-ShadowShort.png"/>
           <p:cNvPicPr>
             <a:picLocks noChangeAspect="1"/>
           </p:cNvPicPr>
@@ -7232,7 +7232,7 @@
       </p:pic>
       <p:sp>
         <p:nvSpPr>
-          <p:cNvPr id="1852080202" name="Rectangle 10"/>
+          <p:cNvPr id="1375911811" name="Rectangle 10"/>
           <p:cNvSpPr/>
           <p:nvPr/>
         </p:nvSpPr>
@@ -7273,7 +7273,7 @@
       </p:sp>
       <p:sp>
         <p:nvSpPr>
-          <p:cNvPr id="1660092420" name="Rectangle 11"/>
+          <p:cNvPr id="701274993" name="Rectangle 11"/>
           <p:cNvSpPr/>
           <p:nvPr/>
         </p:nvSpPr>
@@ -7311,7 +7311,7 @@
       </p:sp>
       <p:sp>
         <p:nvSpPr>
-          <p:cNvPr id="434024171" name="Title 1"/>
+          <p:cNvPr id="1633842903" name="Title 1"/>
           <p:cNvSpPr>
             <a:spLocks noGrp="1"/>
           </p:cNvSpPr>
@@ -7346,7 +7346,7 @@
       </p:sp>
       <p:sp>
         <p:nvSpPr>
-          <p:cNvPr id="352916657" name="Text Placeholder 3"/>
+          <p:cNvPr id="1893736794" name="Text Placeholder 3"/>
           <p:cNvSpPr>
             <a:spLocks noGrp="1"/>
           </p:cNvSpPr>
@@ -7414,7 +7414,7 @@
       </p:sp>
       <p:sp>
         <p:nvSpPr>
-          <p:cNvPr id="2030640302" name="Date Placeholder 4"/>
+          <p:cNvPr id="1144915242" name="Date Placeholder 4"/>
           <p:cNvSpPr>
             <a:spLocks noGrp="1"/>
           </p:cNvSpPr>
@@ -7440,7 +7440,7 @@
       </p:sp>
       <p:sp>
         <p:nvSpPr>
-          <p:cNvPr id="1445862396" name="Footer Placeholder 5"/>
+          <p:cNvPr id="830696756" name="Footer Placeholder 5"/>
           <p:cNvSpPr>
             <a:spLocks noGrp="1"/>
           </p:cNvSpPr>
@@ -7462,7 +7462,7 @@
       </p:sp>
       <p:sp>
         <p:nvSpPr>
-          <p:cNvPr id="2065516657" name="Slide Number Placeholder 6"/>
+          <p:cNvPr id="868949684" name="Slide Number Placeholder 6"/>
           <p:cNvSpPr>
             <a:spLocks noGrp="1"/>
           </p:cNvSpPr>
@@ -7518,7 +7518,7 @@
       </p:grpSpPr>
       <p:pic>
         <p:nvPicPr>
-          <p:cNvPr id="1373433772" name="Picture 12" descr="HD-ShadowLong.png"/>
+          <p:cNvPr id="1754865384" name="Picture 12" descr="HD-ShadowLong.png"/>
           <p:cNvPicPr>
             <a:picLocks noChangeAspect="1"/>
           </p:cNvPicPr>
@@ -7540,7 +7540,7 @@
       </p:pic>
       <p:pic>
         <p:nvPicPr>
-          <p:cNvPr id="391421276" name="Picture 13" descr="HD-ShadowShort.png"/>
+          <p:cNvPr id="1306463127" name="Picture 13" descr="HD-ShadowShort.png"/>
           <p:cNvPicPr>
             <a:picLocks noChangeAspect="1"/>
           </p:cNvPicPr>
@@ -7562,7 +7562,7 @@
       </p:pic>
       <p:sp>
         <p:nvSpPr>
-          <p:cNvPr id="1823159065" name="Rectangle 15"/>
+          <p:cNvPr id="674890538" name="Rectangle 15"/>
           <p:cNvSpPr/>
           <p:nvPr/>
         </p:nvSpPr>
@@ -7603,7 +7603,7 @@
       </p:sp>
       <p:sp>
         <p:nvSpPr>
-          <p:cNvPr id="1433636080" name="Rectangle 16"/>
+          <p:cNvPr id="952365648" name="Rectangle 16"/>
           <p:cNvSpPr/>
           <p:nvPr/>
         </p:nvSpPr>
@@ -7641,7 +7641,7 @@
       </p:sp>
       <p:sp>
         <p:nvSpPr>
-          <p:cNvPr id="568189381" name="Title 1"/>
+          <p:cNvPr id="32696837" name="Title 1"/>
           <p:cNvSpPr>
             <a:spLocks noGrp="1"/>
           </p:cNvSpPr>
@@ -7672,7 +7672,7 @@
       </p:sp>
       <p:sp>
         <p:nvSpPr>
-          <p:cNvPr id="1501304444" name="Text Placeholder 2"/>
+          <p:cNvPr id="1357535574" name="Text Placeholder 2"/>
           <p:cNvSpPr>
             <a:spLocks noGrp="1"/>
           </p:cNvSpPr>
@@ -7746,7 +7746,7 @@
       </p:sp>
       <p:sp>
         <p:nvSpPr>
-          <p:cNvPr id="1273684279" name="Text Placeholder 3"/>
+          <p:cNvPr id="188445988" name="Text Placeholder 3"/>
           <p:cNvSpPr>
             <a:spLocks noGrp="1"/>
           </p:cNvSpPr>
@@ -7816,7 +7816,7 @@
       </p:sp>
       <p:sp>
         <p:nvSpPr>
-          <p:cNvPr id="2023575008" name="Text Placeholder 4"/>
+          <p:cNvPr id="1489910517" name="Text Placeholder 4"/>
           <p:cNvSpPr>
             <a:spLocks noGrp="1"/>
           </p:cNvSpPr>
@@ -7890,7 +7890,7 @@
       </p:sp>
       <p:sp>
         <p:nvSpPr>
-          <p:cNvPr id="353765557" name="Text Placeholder 3"/>
+          <p:cNvPr id="693152476" name="Text Placeholder 3"/>
           <p:cNvSpPr>
             <a:spLocks noGrp="1"/>
           </p:cNvSpPr>
@@ -7960,7 +7960,7 @@
       </p:sp>
       <p:sp>
         <p:nvSpPr>
-          <p:cNvPr id="1139120142" name="Text Placeholder 4"/>
+          <p:cNvPr id="1899513800" name="Text Placeholder 4"/>
           <p:cNvSpPr>
             <a:spLocks noGrp="1"/>
           </p:cNvSpPr>
@@ -8034,7 +8034,7 @@
       </p:sp>
       <p:sp>
         <p:nvSpPr>
-          <p:cNvPr id="1300555518" name="Text Placeholder 3"/>
+          <p:cNvPr id="1593788033" name="Text Placeholder 3"/>
           <p:cNvSpPr>
             <a:spLocks noGrp="1"/>
           </p:cNvSpPr>
@@ -8104,7 +8104,7 @@
       </p:sp>
       <p:sp>
         <p:nvSpPr>
-          <p:cNvPr id="1656258156" name="Date Placeholder 2"/>
+          <p:cNvPr id="1085954339" name="Date Placeholder 2"/>
           <p:cNvSpPr>
             <a:spLocks noGrp="1"/>
           </p:cNvSpPr>
@@ -8130,7 +8130,7 @@
       </p:sp>
       <p:sp>
         <p:nvSpPr>
-          <p:cNvPr id="893253664" name="Footer Placeholder 3"/>
+          <p:cNvPr id="1633668894" name="Footer Placeholder 3"/>
           <p:cNvSpPr>
             <a:spLocks noGrp="1"/>
           </p:cNvSpPr>
@@ -8152,7 +8152,7 @@
       </p:sp>
       <p:sp>
         <p:nvSpPr>
-          <p:cNvPr id="976463983" name="Slide Number Placeholder 4"/>
+          <p:cNvPr id="909048052" name="Slide Number Placeholder 4"/>
           <p:cNvSpPr>
             <a:spLocks noGrp="1"/>
           </p:cNvSpPr>
@@ -8203,7 +8203,7 @@
       </p:grpSpPr>
       <p:pic>
         <p:nvPicPr>
-          <p:cNvPr id="832212926" name="Picture 14" descr="HD-ShadowLong.png"/>
+          <p:cNvPr id="1063118003" name="Picture 14" descr="HD-ShadowLong.png"/>
           <p:cNvPicPr>
             <a:picLocks noChangeAspect="1"/>
           </p:cNvPicPr>
@@ -8225,7 +8225,7 @@
       </p:pic>
       <p:pic>
         <p:nvPicPr>
-          <p:cNvPr id="2044796075" name="Picture 15" descr="HD-ShadowShort.png"/>
+          <p:cNvPr id="767657262" name="Picture 15" descr="HD-ShadowShort.png"/>
           <p:cNvPicPr>
             <a:picLocks noChangeAspect="1"/>
           </p:cNvPicPr>
@@ -8247,7 +8247,7 @@
       </p:pic>
       <p:sp>
         <p:nvSpPr>
-          <p:cNvPr id="1317858430" name="Rectangle 16"/>
+          <p:cNvPr id="560749345" name="Rectangle 16"/>
           <p:cNvSpPr/>
           <p:nvPr/>
         </p:nvSpPr>
@@ -8288,7 +8288,7 @@
       </p:sp>
       <p:sp>
         <p:nvSpPr>
-          <p:cNvPr id="1646377416" name="Rectangle 17"/>
+          <p:cNvPr id="98436754" name="Rectangle 17"/>
           <p:cNvSpPr/>
           <p:nvPr/>
         </p:nvSpPr>
@@ -8326,7 +8326,7 @@
       </p:sp>
       <p:sp>
         <p:nvSpPr>
-          <p:cNvPr id="1740352782" name="Title 1"/>
+          <p:cNvPr id="1244365783" name="Title 1"/>
           <p:cNvSpPr>
             <a:spLocks noGrp="1"/>
           </p:cNvSpPr>
@@ -8357,7 +8357,7 @@
       </p:sp>
       <p:sp>
         <p:nvSpPr>
-          <p:cNvPr id="1284689466" name="Text Placeholder 2"/>
+          <p:cNvPr id="1812491220" name="Text Placeholder 2"/>
           <p:cNvSpPr>
             <a:spLocks noGrp="1"/>
           </p:cNvSpPr>
@@ -8431,7 +8431,7 @@
       </p:sp>
       <p:sp>
         <p:nvSpPr>
-          <p:cNvPr id="293291533" name="Picture Placeholder 2"/>
+          <p:cNvPr id="631590052" name="Picture Placeholder 2"/>
           <p:cNvSpPr>
             <a:spLocks noChangeAspect="1" noGrp="1"/>
           </p:cNvSpPr>
@@ -8513,7 +8513,7 @@
       </p:sp>
       <p:sp>
         <p:nvSpPr>
-          <p:cNvPr id="1083128881" name="Text Placeholder 3"/>
+          <p:cNvPr id="404889681" name="Text Placeholder 3"/>
           <p:cNvSpPr>
             <a:spLocks noGrp="1"/>
           </p:cNvSpPr>
@@ -8583,7 +8583,7 @@
       </p:sp>
       <p:sp>
         <p:nvSpPr>
-          <p:cNvPr id="1117775818" name="Text Placeholder 4"/>
+          <p:cNvPr id="1998336575" name="Text Placeholder 4"/>
           <p:cNvSpPr>
             <a:spLocks noGrp="1"/>
           </p:cNvSpPr>
@@ -8657,7 +8657,7 @@
       </p:sp>
       <p:sp>
         <p:nvSpPr>
-          <p:cNvPr id="585204971" name="Picture Placeholder 2"/>
+          <p:cNvPr id="1390712538" name="Picture Placeholder 2"/>
           <p:cNvSpPr>
             <a:spLocks noChangeAspect="1" noGrp="1"/>
           </p:cNvSpPr>
@@ -8739,7 +8739,7 @@
       </p:sp>
       <p:sp>
         <p:nvSpPr>
-          <p:cNvPr id="245836772" name="Text Placeholder 3"/>
+          <p:cNvPr id="85841332" name="Text Placeholder 3"/>
           <p:cNvSpPr>
             <a:spLocks noGrp="1"/>
           </p:cNvSpPr>
@@ -8809,7 +8809,7 @@
       </p:sp>
       <p:sp>
         <p:nvSpPr>
-          <p:cNvPr id="219177922" name="Text Placeholder 4"/>
+          <p:cNvPr id="1721206876" name="Text Placeholder 4"/>
           <p:cNvSpPr>
             <a:spLocks noGrp="1"/>
           </p:cNvSpPr>
@@ -8883,7 +8883,7 @@
       </p:sp>
       <p:sp>
         <p:nvSpPr>
-          <p:cNvPr id="1186352940" name="Picture Placeholder 2"/>
+          <p:cNvPr id="133945264" name="Picture Placeholder 2"/>
           <p:cNvSpPr>
             <a:spLocks noChangeAspect="1" noGrp="1"/>
           </p:cNvSpPr>
@@ -8965,7 +8965,7 @@
       </p:sp>
       <p:sp>
         <p:nvSpPr>
-          <p:cNvPr id="787269023" name="Text Placeholder 3"/>
+          <p:cNvPr id="1873521340" name="Text Placeholder 3"/>
           <p:cNvSpPr>
             <a:spLocks noGrp="1"/>
           </p:cNvSpPr>
@@ -9035,7 +9035,7 @@
       </p:sp>
       <p:sp>
         <p:nvSpPr>
-          <p:cNvPr id="1915052551" name="Date Placeholder 2"/>
+          <p:cNvPr id="303693105" name="Date Placeholder 2"/>
           <p:cNvSpPr>
             <a:spLocks noGrp="1"/>
           </p:cNvSpPr>
@@ -9061,7 +9061,7 @@
       </p:sp>
       <p:sp>
         <p:nvSpPr>
-          <p:cNvPr id="1400066587" name="Footer Placeholder 3"/>
+          <p:cNvPr id="1801864571" name="Footer Placeholder 3"/>
           <p:cNvSpPr>
             <a:spLocks noGrp="1"/>
           </p:cNvSpPr>
@@ -9083,7 +9083,7 @@
       </p:sp>
       <p:sp>
         <p:nvSpPr>
-          <p:cNvPr id="843350949" name="Slide Number Placeholder 4"/>
+          <p:cNvPr id="1524930077" name="Slide Number Placeholder 4"/>
           <p:cNvSpPr>
             <a:spLocks noGrp="1"/>
           </p:cNvSpPr>
@@ -9134,7 +9134,7 @@
       </p:grpSpPr>
       <p:pic>
         <p:nvPicPr>
-          <p:cNvPr id="1023205717" name="Picture 6" descr="HD-ShadowLong.png"/>
+          <p:cNvPr id="1915313669" name="Picture 6" descr="HD-ShadowLong.png"/>
           <p:cNvPicPr>
             <a:picLocks noChangeAspect="1"/>
           </p:cNvPicPr>
@@ -9156,7 +9156,7 @@
       </p:pic>
       <p:pic>
         <p:nvPicPr>
-          <p:cNvPr id="1862895914" name="Picture 7" descr="HD-ShadowShort.png"/>
+          <p:cNvPr id="1964977553" name="Picture 7" descr="HD-ShadowShort.png"/>
           <p:cNvPicPr>
             <a:picLocks noChangeAspect="1"/>
           </p:cNvPicPr>
@@ -9178,7 +9178,7 @@
       </p:pic>
       <p:sp>
         <p:nvSpPr>
-          <p:cNvPr id="1123764253" name="Rectangle 8"/>
+          <p:cNvPr id="1373603433" name="Rectangle 8"/>
           <p:cNvSpPr/>
           <p:nvPr/>
         </p:nvSpPr>
@@ -9219,7 +9219,7 @@
       </p:sp>
       <p:sp>
         <p:nvSpPr>
-          <p:cNvPr id="1397553061" name="Rectangle 9"/>
+          <p:cNvPr id="1595398300" name="Rectangle 9"/>
           <p:cNvSpPr/>
           <p:nvPr/>
         </p:nvSpPr>
@@ -9257,7 +9257,7 @@
       </p:sp>
       <p:sp>
         <p:nvSpPr>
-          <p:cNvPr id="1859316454" name="Title 1"/>
+          <p:cNvPr id="1363267373" name="Title 1"/>
           <p:cNvSpPr>
             <a:spLocks noGrp="1"/>
           </p:cNvSpPr>
@@ -9287,7 +9287,7 @@
       </p:sp>
       <p:sp>
         <p:nvSpPr>
-          <p:cNvPr id="660013168" name="Vertical Text Placeholder 2"/>
+          <p:cNvPr id="479414662" name="Vertical Text Placeholder 2"/>
           <p:cNvSpPr>
             <a:spLocks noGrp="1"/>
           </p:cNvSpPr>
@@ -9353,7 +9353,7 @@
       </p:sp>
       <p:sp>
         <p:nvSpPr>
-          <p:cNvPr id="846614716" name="Date Placeholder 3"/>
+          <p:cNvPr id="1593329377" name="Date Placeholder 3"/>
           <p:cNvSpPr>
             <a:spLocks noGrp="1"/>
           </p:cNvSpPr>
@@ -9379,7 +9379,7 @@
       </p:sp>
       <p:sp>
         <p:nvSpPr>
-          <p:cNvPr id="2134072233" name="Footer Placeholder 4"/>
+          <p:cNvPr id="1096577487" name="Footer Placeholder 4"/>
           <p:cNvSpPr>
             <a:spLocks noGrp="1"/>
           </p:cNvSpPr>
@@ -9401,7 +9401,7 @@
       </p:sp>
       <p:sp>
         <p:nvSpPr>
-          <p:cNvPr id="1736433190" name="Slide Number Placeholder 5"/>
+          <p:cNvPr id="2127615889" name="Slide Number Placeholder 5"/>
           <p:cNvSpPr>
             <a:spLocks noGrp="1"/>
           </p:cNvSpPr>
@@ -9452,7 +9452,7 @@
       </p:grpSpPr>
       <p:sp>
         <p:nvSpPr>
-          <p:cNvPr id="513162208" name="Rectangle 6"/>
+          <p:cNvPr id="1625416766" name="Rectangle 6"/>
           <p:cNvSpPr/>
           <p:nvPr/>
         </p:nvSpPr>
@@ -9493,7 +9493,7 @@
       </p:sp>
       <p:sp>
         <p:nvSpPr>
-          <p:cNvPr id="1148693600" name="Rectangle 7"/>
+          <p:cNvPr id="1153215013" name="Rectangle 7"/>
           <p:cNvSpPr/>
           <p:nvPr/>
         </p:nvSpPr>
@@ -9531,7 +9531,7 @@
       </p:sp>
       <p:sp>
         <p:nvSpPr>
-          <p:cNvPr id="1548535692" name="Vertical Title 1"/>
+          <p:cNvPr id="1261967239" name="Vertical Title 1"/>
           <p:cNvSpPr>
             <a:spLocks noGrp="1"/>
           </p:cNvSpPr>
@@ -9562,7 +9562,7 @@
       </p:sp>
       <p:sp>
         <p:nvSpPr>
-          <p:cNvPr id="216795445" name="Vertical Text Placeholder 2"/>
+          <p:cNvPr id="1606844939" name="Vertical Text Placeholder 2"/>
           <p:cNvSpPr>
             <a:spLocks noGrp="1"/>
           </p:cNvSpPr>
@@ -9633,7 +9633,7 @@
       </p:sp>
       <p:sp>
         <p:nvSpPr>
-          <p:cNvPr id="330479020" name="Date Placeholder 3"/>
+          <p:cNvPr id="1319999356" name="Date Placeholder 3"/>
           <p:cNvSpPr>
             <a:spLocks noGrp="1"/>
           </p:cNvSpPr>
@@ -9664,7 +9664,7 @@
       </p:sp>
       <p:sp>
         <p:nvSpPr>
-          <p:cNvPr id="872347539" name="Footer Placeholder 4"/>
+          <p:cNvPr id="1993283807" name="Footer Placeholder 4"/>
           <p:cNvSpPr>
             <a:spLocks noGrp="1"/>
           </p:cNvSpPr>
@@ -9691,7 +9691,7 @@
       </p:sp>
       <p:sp>
         <p:nvSpPr>
-          <p:cNvPr id="101739470" name="Slide Number Placeholder 5"/>
+          <p:cNvPr id="466262420" name="Slide Number Placeholder 5"/>
           <p:cNvSpPr>
             <a:spLocks noGrp="1"/>
           </p:cNvSpPr>
@@ -9751,7 +9751,7 @@
       </p:grpSpPr>
       <p:sp>
         <p:nvSpPr>
-          <p:cNvPr id="242127255" name="Заголовок 1"/>
+          <p:cNvPr id="1167106336" name="Заголовок 1"/>
           <p:cNvSpPr>
             <a:spLocks noGrp="1"/>
           </p:cNvSpPr>
@@ -9786,7 +9786,7 @@
       </p:sp>
       <p:sp>
         <p:nvSpPr>
-          <p:cNvPr id="531372742" name="Текст 2"/>
+          <p:cNvPr id="1874945203" name="Текст 2"/>
           <p:cNvSpPr>
             <a:spLocks noGrp="1"/>
           </p:cNvSpPr>
@@ -9908,7 +9908,7 @@
       </p:sp>
       <p:sp>
         <p:nvSpPr>
-          <p:cNvPr id="368149412" name="Дата 3"/>
+          <p:cNvPr id="2127008943" name="Дата 3"/>
           <p:cNvSpPr>
             <a:spLocks noGrp="1"/>
           </p:cNvSpPr>
@@ -9934,7 +9934,7 @@
       </p:sp>
       <p:sp>
         <p:nvSpPr>
-          <p:cNvPr id="1593237903" name="Нижний колонтитул 4"/>
+          <p:cNvPr id="522681240" name="Нижний колонтитул 4"/>
           <p:cNvSpPr>
             <a:spLocks noGrp="1"/>
           </p:cNvSpPr>
@@ -9956,7 +9956,7 @@
       </p:sp>
       <p:sp>
         <p:nvSpPr>
-          <p:cNvPr id="1697357456" name="Номер слайда 5"/>
+          <p:cNvPr id="1071079241" name="Номер слайда 5"/>
           <p:cNvSpPr>
             <a:spLocks noGrp="1"/>
           </p:cNvSpPr>
@@ -10007,7 +10007,7 @@
       </p:grpSpPr>
       <p:sp>
         <p:nvSpPr>
-          <p:cNvPr id="1387713718" name="Заголовок 1"/>
+          <p:cNvPr id="1187047245" name="Заголовок 1"/>
           <p:cNvSpPr>
             <a:spLocks noGrp="1"/>
           </p:cNvSpPr>
@@ -10033,7 +10033,7 @@
       </p:sp>
       <p:sp>
         <p:nvSpPr>
-          <p:cNvPr id="1353203105" name="Объект 2"/>
+          <p:cNvPr id="1554156183" name="Объект 2"/>
           <p:cNvSpPr>
             <a:spLocks noGrp="1"/>
           </p:cNvSpPr>
@@ -10104,7 +10104,7 @@
       </p:sp>
       <p:sp>
         <p:nvSpPr>
-          <p:cNvPr id="673353767" name="Объект 3"/>
+          <p:cNvPr id="1074241464" name="Объект 3"/>
           <p:cNvSpPr>
             <a:spLocks noGrp="1"/>
           </p:cNvSpPr>
@@ -10175,7 +10175,7 @@
       </p:sp>
       <p:sp>
         <p:nvSpPr>
-          <p:cNvPr id="138128543" name="Дата 4"/>
+          <p:cNvPr id="28932297" name="Дата 4"/>
           <p:cNvSpPr>
             <a:spLocks noGrp="1"/>
           </p:cNvSpPr>
@@ -10201,7 +10201,7 @@
       </p:sp>
       <p:sp>
         <p:nvSpPr>
-          <p:cNvPr id="1048958698" name="Нижний колонтитул 5"/>
+          <p:cNvPr id="411817434" name="Нижний колонтитул 5"/>
           <p:cNvSpPr>
             <a:spLocks noGrp="1"/>
           </p:cNvSpPr>
@@ -10223,7 +10223,7 @@
       </p:sp>
       <p:sp>
         <p:nvSpPr>
-          <p:cNvPr id="43096411" name="Номер слайда 6"/>
+          <p:cNvPr id="1051211392" name="Номер слайда 6"/>
           <p:cNvSpPr>
             <a:spLocks noGrp="1"/>
           </p:cNvSpPr>
@@ -10274,7 +10274,7 @@
       </p:grpSpPr>
       <p:sp>
         <p:nvSpPr>
-          <p:cNvPr id="1834889782" name="Заголовок 1"/>
+          <p:cNvPr id="1223806280" name="Заголовок 1"/>
           <p:cNvSpPr>
             <a:spLocks noGrp="1"/>
           </p:cNvSpPr>
@@ -10305,7 +10305,7 @@
       </p:sp>
       <p:sp>
         <p:nvSpPr>
-          <p:cNvPr id="248536330" name="Текст 2"/>
+          <p:cNvPr id="464085853" name="Текст 2"/>
           <p:cNvSpPr>
             <a:spLocks noGrp="1"/>
           </p:cNvSpPr>
@@ -10373,7 +10373,7 @@
       </p:sp>
       <p:sp>
         <p:nvSpPr>
-          <p:cNvPr id="1681902612" name="Объект 3"/>
+          <p:cNvPr id="303151593" name="Объект 3"/>
           <p:cNvSpPr>
             <a:spLocks noGrp="1"/>
           </p:cNvSpPr>
@@ -10444,7 +10444,7 @@
       </p:sp>
       <p:sp>
         <p:nvSpPr>
-          <p:cNvPr id="1247811363" name="Текст 4"/>
+          <p:cNvPr id="468117293" name="Текст 4"/>
           <p:cNvSpPr>
             <a:spLocks noGrp="1"/>
           </p:cNvSpPr>
@@ -10512,7 +10512,7 @@
       </p:sp>
       <p:sp>
         <p:nvSpPr>
-          <p:cNvPr id="1648436480" name="Объект 5"/>
+          <p:cNvPr id="902572599" name="Объект 5"/>
           <p:cNvSpPr>
             <a:spLocks noGrp="1"/>
           </p:cNvSpPr>
@@ -10583,7 +10583,7 @@
       </p:sp>
       <p:sp>
         <p:nvSpPr>
-          <p:cNvPr id="463629396" name="Дата 6"/>
+          <p:cNvPr id="270180719" name="Дата 6"/>
           <p:cNvSpPr>
             <a:spLocks noGrp="1"/>
           </p:cNvSpPr>
@@ -10609,7 +10609,7 @@
       </p:sp>
       <p:sp>
         <p:nvSpPr>
-          <p:cNvPr id="806557814" name="Нижний колонтитул 7"/>
+          <p:cNvPr id="588029428" name="Нижний колонтитул 7"/>
           <p:cNvSpPr>
             <a:spLocks noGrp="1"/>
           </p:cNvSpPr>
@@ -10631,7 +10631,7 @@
       </p:sp>
       <p:sp>
         <p:nvSpPr>
-          <p:cNvPr id="1160479228" name="Номер слайда 8"/>
+          <p:cNvPr id="370260028" name="Номер слайда 8"/>
           <p:cNvSpPr>
             <a:spLocks noGrp="1"/>
           </p:cNvSpPr>
@@ -10682,7 +10682,7 @@
       </p:grpSpPr>
       <p:sp>
         <p:nvSpPr>
-          <p:cNvPr id="1281934812" name="Заголовок 1"/>
+          <p:cNvPr id="1393111412" name="Заголовок 1"/>
           <p:cNvSpPr>
             <a:spLocks noGrp="1"/>
           </p:cNvSpPr>
@@ -10708,7 +10708,7 @@
       </p:sp>
       <p:sp>
         <p:nvSpPr>
-          <p:cNvPr id="2046072064" name="Дата 2"/>
+          <p:cNvPr id="2144901511" name="Дата 2"/>
           <p:cNvSpPr>
             <a:spLocks noGrp="1"/>
           </p:cNvSpPr>
@@ -10734,7 +10734,7 @@
       </p:sp>
       <p:sp>
         <p:nvSpPr>
-          <p:cNvPr id="925760900" name="Нижний колонтитул 3"/>
+          <p:cNvPr id="1294565240" name="Нижний колонтитул 3"/>
           <p:cNvSpPr>
             <a:spLocks noGrp="1"/>
           </p:cNvSpPr>
@@ -10756,7 +10756,7 @@
       </p:sp>
       <p:sp>
         <p:nvSpPr>
-          <p:cNvPr id="1444299471" name="Номер слайда 4"/>
+          <p:cNvPr id="366437444" name="Номер слайда 4"/>
           <p:cNvSpPr>
             <a:spLocks noGrp="1"/>
           </p:cNvSpPr>
@@ -10807,7 +10807,7 @@
       </p:grpSpPr>
       <p:sp>
         <p:nvSpPr>
-          <p:cNvPr id="764410390" name="Дата 1"/>
+          <p:cNvPr id="412438151" name="Дата 1"/>
           <p:cNvSpPr>
             <a:spLocks noGrp="1"/>
           </p:cNvSpPr>
@@ -10833,7 +10833,7 @@
       </p:sp>
       <p:sp>
         <p:nvSpPr>
-          <p:cNvPr id="865070787" name="Нижний колонтитул 2"/>
+          <p:cNvPr id="1786187567" name="Нижний колонтитул 2"/>
           <p:cNvSpPr>
             <a:spLocks noGrp="1"/>
           </p:cNvSpPr>
@@ -10855,7 +10855,7 @@
       </p:sp>
       <p:sp>
         <p:nvSpPr>
-          <p:cNvPr id="1559032338" name="Номер слайда 3"/>
+          <p:cNvPr id="1379664793" name="Номер слайда 3"/>
           <p:cNvSpPr>
             <a:spLocks noGrp="1"/>
           </p:cNvSpPr>
@@ -10906,7 +10906,7 @@
       </p:grpSpPr>
       <p:sp>
         <p:nvSpPr>
-          <p:cNvPr id="2016402276" name="Заголовок 1"/>
+          <p:cNvPr id="366453477" name="Заголовок 1"/>
           <p:cNvSpPr>
             <a:spLocks noGrp="1"/>
           </p:cNvSpPr>
@@ -10941,7 +10941,7 @@
       </p:sp>
       <p:sp>
         <p:nvSpPr>
-          <p:cNvPr id="1548433965" name="Объект 2"/>
+          <p:cNvPr id="291626683" name="Объект 2"/>
           <p:cNvSpPr>
             <a:spLocks noGrp="1"/>
           </p:cNvSpPr>
@@ -11040,7 +11040,7 @@
       </p:sp>
       <p:sp>
         <p:nvSpPr>
-          <p:cNvPr id="1556658589" name="Текст 3"/>
+          <p:cNvPr id="2081632213" name="Текст 3"/>
           <p:cNvSpPr>
             <a:spLocks noGrp="1"/>
           </p:cNvSpPr>
@@ -11108,7 +11108,7 @@
       </p:sp>
       <p:sp>
         <p:nvSpPr>
-          <p:cNvPr id="950334942" name="Дата 4"/>
+          <p:cNvPr id="1354432165" name="Дата 4"/>
           <p:cNvSpPr>
             <a:spLocks noGrp="1"/>
           </p:cNvSpPr>
@@ -11134,7 +11134,7 @@
       </p:sp>
       <p:sp>
         <p:nvSpPr>
-          <p:cNvPr id="1072072449" name="Нижний колонтитул 5"/>
+          <p:cNvPr id="1245247655" name="Нижний колонтитул 5"/>
           <p:cNvSpPr>
             <a:spLocks noGrp="1"/>
           </p:cNvSpPr>
@@ -11156,7 +11156,7 @@
       </p:sp>
       <p:sp>
         <p:nvSpPr>
-          <p:cNvPr id="1295929803" name="Номер слайда 6"/>
+          <p:cNvPr id="1307926881" name="Номер слайда 6"/>
           <p:cNvSpPr>
             <a:spLocks noGrp="1"/>
           </p:cNvSpPr>
@@ -11207,7 +11207,7 @@
       </p:grpSpPr>
       <p:sp>
         <p:nvSpPr>
-          <p:cNvPr id="2114076230" name="Заголовок 1"/>
+          <p:cNvPr id="727784352" name="Заголовок 1"/>
           <p:cNvSpPr>
             <a:spLocks noGrp="1"/>
           </p:cNvSpPr>
@@ -11242,7 +11242,7 @@
       </p:sp>
       <p:sp>
         <p:nvSpPr>
-          <p:cNvPr id="894584814" name="Рисунок 2"/>
+          <p:cNvPr id="830316039" name="Рисунок 2"/>
           <p:cNvSpPr>
             <a:spLocks noGrp="1"/>
           </p:cNvSpPr>
@@ -11306,7 +11306,7 @@
       </p:sp>
       <p:sp>
         <p:nvSpPr>
-          <p:cNvPr id="2024400069" name="Текст 3"/>
+          <p:cNvPr id="328257174" name="Текст 3"/>
           <p:cNvSpPr>
             <a:spLocks noGrp="1"/>
           </p:cNvSpPr>
@@ -11374,7 +11374,7 @@
       </p:sp>
       <p:sp>
         <p:nvSpPr>
-          <p:cNvPr id="16561951" name="Дата 4"/>
+          <p:cNvPr id="657390116" name="Дата 4"/>
           <p:cNvSpPr>
             <a:spLocks noGrp="1"/>
           </p:cNvSpPr>
@@ -11400,7 +11400,7 @@
       </p:sp>
       <p:sp>
         <p:nvSpPr>
-          <p:cNvPr id="2023925822" name="Нижний колонтитул 5"/>
+          <p:cNvPr id="1064684142" name="Нижний колонтитул 5"/>
           <p:cNvSpPr>
             <a:spLocks noGrp="1"/>
           </p:cNvSpPr>
@@ -11422,7 +11422,7 @@
       </p:sp>
       <p:sp>
         <p:nvSpPr>
-          <p:cNvPr id="593445368" name="Номер слайда 6"/>
+          <p:cNvPr id="1195880777" name="Номер слайда 6"/>
           <p:cNvSpPr>
             <a:spLocks noGrp="1"/>
           </p:cNvSpPr>
@@ -11478,7 +11478,7 @@
       </p:grpSpPr>
       <p:sp>
         <p:nvSpPr>
-          <p:cNvPr id="272335625" name="Заголовок 1"/>
+          <p:cNvPr id="993938429" name="Заголовок 1"/>
           <p:cNvSpPr>
             <a:spLocks noGrp="1"/>
           </p:cNvSpPr>
@@ -11514,7 +11514,7 @@
       </p:sp>
       <p:sp>
         <p:nvSpPr>
-          <p:cNvPr id="1658935789" name="Текст 2"/>
+          <p:cNvPr id="398838772" name="Текст 2"/>
           <p:cNvSpPr>
             <a:spLocks noGrp="1"/>
           </p:cNvSpPr>
@@ -11590,7 +11590,7 @@
       </p:sp>
       <p:sp>
         <p:nvSpPr>
-          <p:cNvPr id="1220543865" name="Дата 3"/>
+          <p:cNvPr id="1380411619" name="Дата 3"/>
           <p:cNvSpPr>
             <a:spLocks noGrp="1"/>
           </p:cNvSpPr>
@@ -11634,7 +11634,7 @@
       </p:sp>
       <p:sp>
         <p:nvSpPr>
-          <p:cNvPr id="2135112438" name="Нижний колонтитул 4"/>
+          <p:cNvPr id="316686976" name="Нижний колонтитул 4"/>
           <p:cNvSpPr>
             <a:spLocks noGrp="1"/>
           </p:cNvSpPr>
@@ -11674,7 +11674,7 @@
       </p:sp>
       <p:sp>
         <p:nvSpPr>
-          <p:cNvPr id="265375742" name="Номер слайда 5"/>
+          <p:cNvPr id="1918571607" name="Номер слайда 5"/>
           <p:cNvSpPr>
             <a:spLocks noGrp="1"/>
           </p:cNvSpPr>
@@ -12085,7 +12085,7 @@
       </p:grpSpPr>
       <p:sp>
         <p:nvSpPr>
-          <p:cNvPr id="795241378" name="Прямоугольник 3"/>
+          <p:cNvPr id="2119498964" name="Прямоугольник 3"/>
           <p:cNvSpPr/>
           <p:nvPr/>
         </p:nvSpPr>
@@ -12135,7 +12135,7 @@
       </p:sp>
       <p:sp>
         <p:nvSpPr>
-          <p:cNvPr id="1378292442" name="Прямоугольник 4"/>
+          <p:cNvPr id="1765705191" name="Прямоугольник 4"/>
           <p:cNvSpPr/>
           <p:nvPr/>
         </p:nvSpPr>
@@ -12185,7 +12185,7 @@
       </p:sp>
       <p:sp>
         <p:nvSpPr>
-          <p:cNvPr id="591927687" name="Заголовок 1"/>
+          <p:cNvPr id="1148214580" name="Заголовок 1"/>
           <p:cNvSpPr>
             <a:spLocks noGrp="1"/>
           </p:cNvSpPr>
@@ -12226,7 +12226,7 @@
       </p:sp>
       <p:sp>
         <p:nvSpPr>
-          <p:cNvPr id="393143013" name="Подзаголовок 2"/>
+          <p:cNvPr id="905258746" name="Подзаголовок 2"/>
           <p:cNvSpPr>
             <a:spLocks noGrp="1"/>
           </p:cNvSpPr>
@@ -12371,7 +12371,7 @@
       </p:grpSpPr>
       <p:sp>
         <p:nvSpPr>
-          <p:cNvPr id="1102597146" name="Объект 2"/>
+          <p:cNvPr id="1668011248" name="Объект 2"/>
           <p:cNvSpPr>
             <a:spLocks noGrp="1"/>
           </p:cNvSpPr>
@@ -12450,7 +12450,7 @@
       </p:sp>
       <p:sp>
         <p:nvSpPr>
-          <p:cNvPr id="1420563746" name="Номер слайда 3"/>
+          <p:cNvPr id="1085215997" name="Номер слайда 3"/>
           <p:cNvSpPr>
             <a:spLocks noGrp="1"/>
           </p:cNvSpPr>
@@ -12491,7 +12491,7 @@
       </p:sp>
       <p:sp>
         <p:nvSpPr>
-          <p:cNvPr id="858570174" name="Прямоугольник 5"/>
+          <p:cNvPr id="553844427" name="Прямоугольник 5"/>
           <p:cNvSpPr/>
           <p:nvPr/>
         </p:nvSpPr>
@@ -12541,7 +12541,7 @@
       </p:sp>
       <p:sp>
         <p:nvSpPr>
-          <p:cNvPr id="19050207" name="Прямоугольник 6"/>
+          <p:cNvPr id="194605452" name="Прямоугольник 6"/>
           <p:cNvSpPr/>
           <p:nvPr/>
         </p:nvSpPr>
@@ -12591,7 +12591,7 @@
       </p:sp>
       <p:sp>
         <p:nvSpPr>
-          <p:cNvPr id="80862825" name="Заголовок 1"/>
+          <p:cNvPr id="1451586730" name="Заголовок 1"/>
           <p:cNvSpPr>
             <a:spLocks noGrp="1"/>
           </p:cNvSpPr>
@@ -12722,7 +12722,7 @@
       </p:grpSpPr>
       <p:sp>
         <p:nvSpPr>
-          <p:cNvPr id="910795611" name="Объект 2"/>
+          <p:cNvPr id="604735051" name="Объект 2"/>
           <p:cNvSpPr>
             <a:spLocks noGrp="1"/>
           </p:cNvSpPr>
@@ -12795,7 +12795,7 @@
       </p:sp>
       <p:sp>
         <p:nvSpPr>
-          <p:cNvPr id="845970412" name="Номер слайда 3"/>
+          <p:cNvPr id="1193862957" name="Номер слайда 3"/>
           <p:cNvSpPr>
             <a:spLocks noGrp="1"/>
           </p:cNvSpPr>
@@ -12836,7 +12836,7 @@
       </p:sp>
       <p:sp>
         <p:nvSpPr>
-          <p:cNvPr id="155104533" name="Прямоугольник 5"/>
+          <p:cNvPr id="1306721379" name="Прямоугольник 5"/>
           <p:cNvSpPr/>
           <p:nvPr/>
         </p:nvSpPr>
@@ -12886,7 +12886,7 @@
       </p:sp>
       <p:sp>
         <p:nvSpPr>
-          <p:cNvPr id="1889037058" name="Прямоугольник 6"/>
+          <p:cNvPr id="1210217771" name="Прямоугольник 6"/>
           <p:cNvSpPr/>
           <p:nvPr/>
         </p:nvSpPr>
@@ -12936,7 +12936,7 @@
       </p:sp>
       <p:sp>
         <p:nvSpPr>
-          <p:cNvPr id="1334745503" name="Заголовок 1"/>
+          <p:cNvPr id="1957287165" name="Заголовок 1"/>
           <p:cNvSpPr>
             <a:spLocks noGrp="1"/>
           </p:cNvSpPr>
@@ -13020,7 +13020,7 @@
       </p:sp>
       <p:pic>
         <p:nvPicPr>
-          <p:cNvPr id="1086724144" name=""/>
+          <p:cNvPr id="1035594074" name=""/>
           <p:cNvPicPr>
             <a:picLocks noChangeAspect="1"/>
           </p:cNvPicPr>
@@ -13038,8 +13038,8 @@
         </p:blipFill>
         <p:spPr bwMode="auto">
           <a:xfrm flipH="0" flipV="0">
-            <a:off x="6083555" y="1685925"/>
-            <a:ext cx="5527252" cy="4581524"/>
+            <a:off x="5534024" y="1452562"/>
+            <a:ext cx="5706450" cy="4769894"/>
           </a:xfrm>
           <a:prstGeom prst="rect">
             <a:avLst/>
@@ -13114,7 +13114,7 @@
       </p:grpSpPr>
       <p:sp>
         <p:nvSpPr>
-          <p:cNvPr id="444456525" name="Объект 2"/>
+          <p:cNvPr id="402041649" name="Объект 2"/>
           <p:cNvSpPr>
             <a:spLocks noGrp="1"/>
           </p:cNvSpPr>
@@ -13124,13 +13124,13 @@
         </p:nvSpPr>
         <p:spPr bwMode="auto">
           <a:xfrm>
-            <a:off x="680319" y="2336872"/>
+            <a:off x="604119" y="2041596"/>
             <a:ext cx="5044972" cy="3599316"/>
           </a:xfrm>
         </p:spPr>
         <p:txBody>
           <a:bodyPr vertOverflow="overflow" horzOverflow="overflow" vert="horz" wrap="square" lIns="91440" tIns="45720" rIns="91440" bIns="45720" numCol="1" spcCol="0" rtlCol="0" fromWordArt="0" anchor="t" anchorCtr="0" forceAA="0" upright="0" compatLnSpc="0">
-            <a:normAutofit fontScale="95000" lnSpcReduction="1000"/>
+            <a:normAutofit/>
           </a:bodyPr>
           <a:lstStyle/>
           <a:p>
@@ -13157,41 +13157,15 @@
             </a:r>
             <a:r>
               <a:rPr lang="ru-RU"/>
-              <a:t> – преобразование инструкций в структуры для передачи исполняемым блокам;</a:t>
+              <a:t> – преобразование инструкций в структуры для передачи исполняемым блокам.</a:t>
             </a:r>
             <a:endParaRPr/>
           </a:p>
-          <a:p>
-            <a:pPr>
-              <a:defRPr/>
-            </a:pPr>
-            <a:r>
-              <a:rPr lang="ru-RU"/>
-              <a:t>По программному счётчику </a:t>
-            </a:r>
-            <a:r>
-              <a:rPr lang="en-US"/>
-              <a:t>(PC)</a:t>
-            </a:r>
-            <a:r>
-              <a:rPr lang="ru-RU"/>
-              <a:t> </a:t>
-            </a:r>
-            <a:r>
-              <a:rPr lang="en-US"/>
-              <a:t>Fetcher</a:t>
-            </a:r>
-            <a:r>
-              <a:rPr lang="ru-RU"/>
-              <a:t> делает смещение по адресу и получает адрес.</a:t>
-            </a:r>
-            <a:endParaRPr/>
-          </a:p>
-        </p:txBody>
-      </p:sp>
-      <p:sp>
-        <p:nvSpPr>
-          <p:cNvPr id="1802770938" name="Номер слайда 3"/>
+        </p:txBody>
+      </p:sp>
+      <p:sp>
+        <p:nvSpPr>
+          <p:cNvPr id="1830861833" name="Номер слайда 3"/>
           <p:cNvSpPr>
             <a:spLocks noGrp="1"/>
           </p:cNvSpPr>
@@ -13232,7 +13206,7 @@
       </p:sp>
       <p:sp>
         <p:nvSpPr>
-          <p:cNvPr id="847998918" name="Прямоугольник 5"/>
+          <p:cNvPr id="2132542029" name="Прямоугольник 5"/>
           <p:cNvSpPr/>
           <p:nvPr/>
         </p:nvSpPr>
@@ -13282,7 +13256,7 @@
       </p:sp>
       <p:sp>
         <p:nvSpPr>
-          <p:cNvPr id="1126307737" name="Прямоугольник 6"/>
+          <p:cNvPr id="330258748" name="Прямоугольник 6"/>
           <p:cNvSpPr/>
           <p:nvPr/>
         </p:nvSpPr>
@@ -13332,7 +13306,7 @@
       </p:sp>
       <p:sp>
         <p:nvSpPr>
-          <p:cNvPr id="1969491247" name="Заголовок 1"/>
+          <p:cNvPr id="962595235" name="Заголовок 1"/>
           <p:cNvSpPr>
             <a:spLocks noGrp="1"/>
           </p:cNvSpPr>
@@ -13410,7 +13384,7 @@
         </p:blipFill>
         <p:spPr bwMode="auto">
           <a:xfrm flipH="0" flipV="0">
-            <a:off x="7420950" y="1624012"/>
+            <a:off x="7068524" y="1646902"/>
             <a:ext cx="3747112" cy="4845972"/>
           </a:xfrm>
           <a:prstGeom prst="rect">
@@ -13435,7 +13409,7 @@
 </file>
 
 <file path=ppt/slides/slide13.xml><?xml version="1.0" encoding="utf-8"?>
-<p:sld xmlns:a="http://schemas.openxmlformats.org/drawingml/2006/main" xmlns:r="http://schemas.openxmlformats.org/officeDocument/2006/relationships" xmlns:p="http://schemas.openxmlformats.org/presentationml/2006/main" xmlns:m="http://schemas.openxmlformats.org/officeDocument/2006/math" xmlns:w="http://schemas.openxmlformats.org/wordprocessingml/2006/main" xmlns:mc="http://schemas.openxmlformats.org/markup-compatibility/2006" showMasterPhAnim="0" showMasterSp="1" show="1">
+<p:sld xmlns:a="http://schemas.openxmlformats.org/drawingml/2006/main" xmlns:r="http://schemas.openxmlformats.org/officeDocument/2006/relationships" xmlns:p="http://schemas.openxmlformats.org/presentationml/2006/main" xmlns:m="http://schemas.openxmlformats.org/officeDocument/2006/math" xmlns:w="http://schemas.openxmlformats.org/wordprocessingml/2006/main" xmlns:mc="http://schemas.openxmlformats.org/markup-compatibility/2006" showMasterPhAnim="0" showMasterSp="1" show="0">
   <p:cSld name="">
     <p:bg>
       <p:bgPr shadeToTitle="0">
@@ -13486,7 +13460,7 @@
       </p:grpSpPr>
       <p:sp>
         <p:nvSpPr>
-          <p:cNvPr id="1496811791" name="Объект 2"/>
+          <p:cNvPr id="2043590722" name="Объект 2"/>
           <p:cNvSpPr>
             <a:spLocks noGrp="1"/>
           </p:cNvSpPr>
@@ -13609,7 +13583,7 @@
       </p:sp>
       <p:sp>
         <p:nvSpPr>
-          <p:cNvPr id="688327277" name="Номер слайда 3"/>
+          <p:cNvPr id="1941335714" name="Номер слайда 3"/>
           <p:cNvSpPr>
             <a:spLocks noGrp="1"/>
           </p:cNvSpPr>
@@ -13650,7 +13624,7 @@
       </p:sp>
       <p:sp>
         <p:nvSpPr>
-          <p:cNvPr id="345763988" name="Прямоугольник 5"/>
+          <p:cNvPr id="684204292" name="Прямоугольник 5"/>
           <p:cNvSpPr/>
           <p:nvPr/>
         </p:nvSpPr>
@@ -13700,7 +13674,7 @@
       </p:sp>
       <p:sp>
         <p:nvSpPr>
-          <p:cNvPr id="1600092281" name="Прямоугольник 6"/>
+          <p:cNvPr id="347670875" name="Прямоугольник 6"/>
           <p:cNvSpPr/>
           <p:nvPr/>
         </p:nvSpPr>
@@ -13750,7 +13724,7 @@
       </p:sp>
       <p:sp>
         <p:nvSpPr>
-          <p:cNvPr id="1277913887" name="Заголовок 1"/>
+          <p:cNvPr id="27212953" name="Заголовок 1"/>
           <p:cNvSpPr>
             <a:spLocks noGrp="1"/>
           </p:cNvSpPr>
@@ -13896,7 +13870,7 @@
       </p:grpSpPr>
       <p:sp>
         <p:nvSpPr>
-          <p:cNvPr id="2043887746" name="Объект 2"/>
+          <p:cNvPr id="2046775309" name="Объект 2"/>
           <p:cNvSpPr>
             <a:spLocks noGrp="1"/>
           </p:cNvSpPr>
@@ -13991,7 +13965,7 @@
       </p:sp>
       <p:sp>
         <p:nvSpPr>
-          <p:cNvPr id="1180608762" name="Номер слайда 3"/>
+          <p:cNvPr id="478779720" name="Номер слайда 3"/>
           <p:cNvSpPr>
             <a:spLocks noGrp="1"/>
           </p:cNvSpPr>
@@ -14032,7 +14006,7 @@
       </p:sp>
       <p:sp>
         <p:nvSpPr>
-          <p:cNvPr id="2106704317" name="Прямоугольник 4"/>
+          <p:cNvPr id="772204101" name="Прямоугольник 4"/>
           <p:cNvSpPr/>
           <p:nvPr/>
         </p:nvSpPr>
@@ -14082,7 +14056,7 @@
       </p:sp>
       <p:sp>
         <p:nvSpPr>
-          <p:cNvPr id="973952013" name="Прямоугольник 5"/>
+          <p:cNvPr id="587986942" name="Прямоугольник 5"/>
           <p:cNvSpPr/>
           <p:nvPr/>
         </p:nvSpPr>
@@ -14132,7 +14106,7 @@
       </p:sp>
       <p:sp>
         <p:nvSpPr>
-          <p:cNvPr id="2028995553" name="Заголовок 1"/>
+          <p:cNvPr id="219752888" name="Заголовок 1"/>
           <p:cNvSpPr>
             <a:spLocks noGrp="1"/>
           </p:cNvSpPr>
@@ -14237,7 +14211,7 @@
       </p:grpSpPr>
       <p:sp>
         <p:nvSpPr>
-          <p:cNvPr id="2095992934" name="Объект 2"/>
+          <p:cNvPr id="213781125" name="Объект 2"/>
           <p:cNvSpPr>
             <a:spLocks noGrp="1"/>
           </p:cNvSpPr>
@@ -14386,7 +14360,7 @@
       </p:sp>
       <p:sp>
         <p:nvSpPr>
-          <p:cNvPr id="133681853" name="Номер слайда 3"/>
+          <p:cNvPr id="1849573552" name="Номер слайда 3"/>
           <p:cNvSpPr>
             <a:spLocks noGrp="1"/>
           </p:cNvSpPr>
@@ -14427,7 +14401,7 @@
       </p:sp>
       <p:sp>
         <p:nvSpPr>
-          <p:cNvPr id="2047500724" name="Прямоугольник 4"/>
+          <p:cNvPr id="1247196733" name="Прямоугольник 4"/>
           <p:cNvSpPr/>
           <p:nvPr/>
         </p:nvSpPr>
@@ -14477,7 +14451,7 @@
       </p:sp>
       <p:sp>
         <p:nvSpPr>
-          <p:cNvPr id="712986061" name="Прямоугольник 5"/>
+          <p:cNvPr id="211312007" name="Прямоугольник 5"/>
           <p:cNvSpPr/>
           <p:nvPr/>
         </p:nvSpPr>
@@ -14527,7 +14501,7 @@
       </p:sp>
       <p:sp>
         <p:nvSpPr>
-          <p:cNvPr id="1943569084" name="Заголовок 1"/>
+          <p:cNvPr id="431674948" name="Заголовок 1"/>
           <p:cNvSpPr>
             <a:spLocks noGrp="1"/>
           </p:cNvSpPr>
@@ -14632,7 +14606,7 @@
       </p:grpSpPr>
       <p:sp>
         <p:nvSpPr>
-          <p:cNvPr id="780225731" name="Объект 2"/>
+          <p:cNvPr id="1674598459" name="Объект 2"/>
           <p:cNvSpPr>
             <a:spLocks noGrp="1"/>
           </p:cNvSpPr>
@@ -14658,7 +14632,7 @@
       </p:sp>
       <p:sp>
         <p:nvSpPr>
-          <p:cNvPr id="939329748" name="Номер слайда 3"/>
+          <p:cNvPr id="664510030" name="Номер слайда 3"/>
           <p:cNvSpPr>
             <a:spLocks noGrp="1"/>
           </p:cNvSpPr>
@@ -14699,7 +14673,7 @@
       </p:sp>
       <p:sp>
         <p:nvSpPr>
-          <p:cNvPr id="532143714" name="Прямоугольник 4"/>
+          <p:cNvPr id="1722892441" name="Прямоугольник 4"/>
           <p:cNvSpPr/>
           <p:nvPr/>
         </p:nvSpPr>
@@ -14749,7 +14723,7 @@
       </p:sp>
       <p:sp>
         <p:nvSpPr>
-          <p:cNvPr id="259117277" name="Прямоугольник 5"/>
+          <p:cNvPr id="1268552919" name="Прямоугольник 5"/>
           <p:cNvSpPr/>
           <p:nvPr/>
         </p:nvSpPr>
@@ -14799,7 +14773,7 @@
       </p:sp>
       <p:sp>
         <p:nvSpPr>
-          <p:cNvPr id="1718174798" name="Заголовок 1"/>
+          <p:cNvPr id="993902618" name="Заголовок 1"/>
           <p:cNvSpPr>
             <a:spLocks noGrp="1"/>
           </p:cNvSpPr>
@@ -14904,7 +14878,7 @@
       </p:grpSpPr>
       <p:sp>
         <p:nvSpPr>
-          <p:cNvPr id="1358834782" name="Прямоугольник 4"/>
+          <p:cNvPr id="540688655" name="Прямоугольник 4"/>
           <p:cNvSpPr/>
           <p:nvPr/>
         </p:nvSpPr>
@@ -14954,7 +14928,7 @@
       </p:sp>
       <p:sp>
         <p:nvSpPr>
-          <p:cNvPr id="1059084883" name="Заголовок 1"/>
+          <p:cNvPr id="869604524" name="Заголовок 1"/>
           <p:cNvSpPr>
             <a:spLocks noGrp="1"/>
           </p:cNvSpPr>
@@ -14993,7 +14967,7 @@
       </p:sp>
       <p:sp>
         <p:nvSpPr>
-          <p:cNvPr id="1174184765" name="Объект 2"/>
+          <p:cNvPr id="1390165828" name="Объект 2"/>
           <p:cNvSpPr>
             <a:spLocks noGrp="1"/>
           </p:cNvSpPr>
@@ -15067,7 +15041,7 @@
                   <a:schemeClr val="tx1"/>
                 </a:solidFill>
               </a:rPr>
-              <a:t>Основные поставщики графических ускорителей: </a:t>
+              <a:t>Основные компании-разработчики графических ускорителей: </a:t>
             </a:r>
             <a:r>
               <a:rPr lang="en-US">
@@ -15103,7 +15077,7 @@
       </p:sp>
       <p:sp>
         <p:nvSpPr>
-          <p:cNvPr id="1318068780" name="Номер слайда 3"/>
+          <p:cNvPr id="541650073" name="Номер слайда 3"/>
           <p:cNvSpPr>
             <a:spLocks noGrp="1"/>
           </p:cNvSpPr>
@@ -15144,7 +15118,7 @@
       </p:sp>
       <p:sp>
         <p:nvSpPr>
-          <p:cNvPr id="1904787699" name="Прямоугольник 5"/>
+          <p:cNvPr id="1643542223" name="Прямоугольник 5"/>
           <p:cNvSpPr/>
           <p:nvPr/>
         </p:nvSpPr>
@@ -15260,7 +15234,7 @@
       </p:grpSpPr>
       <p:sp>
         <p:nvSpPr>
-          <p:cNvPr id="1533329066" name="Объект 2"/>
+          <p:cNvPr id="926397687" name="Объект 2"/>
           <p:cNvSpPr>
             <a:spLocks noGrp="1"/>
           </p:cNvSpPr>
@@ -15373,7 +15347,7 @@
       </p:sp>
       <p:sp>
         <p:nvSpPr>
-          <p:cNvPr id="1033585347" name="Номер слайда 3"/>
+          <p:cNvPr id="2016395327" name="Номер слайда 3"/>
           <p:cNvSpPr>
             <a:spLocks noGrp="1"/>
           </p:cNvSpPr>
@@ -15414,7 +15388,7 @@
       </p:sp>
       <p:sp>
         <p:nvSpPr>
-          <p:cNvPr id="229186254" name="Прямоугольник 5"/>
+          <p:cNvPr id="726802362" name="Прямоугольник 5"/>
           <p:cNvSpPr/>
           <p:nvPr/>
         </p:nvSpPr>
@@ -15464,7 +15438,7 @@
       </p:sp>
       <p:sp>
         <p:nvSpPr>
-          <p:cNvPr id="1122392701" name="Заголовок 1"/>
+          <p:cNvPr id="1717735568" name="Заголовок 1"/>
           <p:cNvSpPr>
             <a:spLocks noGrp="1"/>
           </p:cNvSpPr>
@@ -15503,7 +15477,7 @@
       </p:sp>
       <p:sp>
         <p:nvSpPr>
-          <p:cNvPr id="374419691" name="Прямоугольник 6"/>
+          <p:cNvPr id="244443748" name="Прямоугольник 6"/>
           <p:cNvSpPr/>
           <p:nvPr/>
         </p:nvSpPr>
@@ -15619,7 +15593,7 @@
       </p:grpSpPr>
       <p:sp>
         <p:nvSpPr>
-          <p:cNvPr id="1660593969" name="Объект 2"/>
+          <p:cNvPr id="159789626" name="Объект 2"/>
           <p:cNvSpPr>
             <a:spLocks noGrp="1"/>
           </p:cNvSpPr>
@@ -15629,7 +15603,9 @@
         </p:nvSpPr>
         <p:spPr bwMode="auto"/>
         <p:txBody>
-          <a:bodyPr/>
+          <a:bodyPr vertOverflow="overflow" horzOverflow="overflow" vert="horz" wrap="square" lIns="91440" tIns="45720" rIns="91440" bIns="45720" numCol="1" spcCol="0" rtlCol="0" fromWordArt="0" anchor="t" anchorCtr="0" forceAA="0" upright="0" compatLnSpc="0">
+            <a:normAutofit fontScale="90000" lnSpcReduction="2000"/>
+          </a:bodyPr>
           <a:lstStyle/>
           <a:p>
             <a:pPr marL="0" indent="0">
@@ -15711,7 +15687,31 @@
                   <a:schemeClr val="tx1"/>
                 </a:solidFill>
               </a:rPr>
-              <a:t> На разработанной базе модели можно экспериментировать с различными техниками и способами, для получения их эмпирической эффективности в данной архитектуре.</a:t>
+              <a:t> На разработанной базе модели можно экспериментировать с различными техниками и способами</a:t>
+            </a:r>
+            <a:r>
+              <a:rPr lang="en-US">
+                <a:solidFill>
+                  <a:schemeClr val="tx1"/>
+                </a:solidFill>
+              </a:rPr>
+              <a:t> </a:t>
+            </a:r>
+            <a:r>
+              <a:rPr lang="ru-RU">
+                <a:solidFill>
+                  <a:schemeClr val="tx1"/>
+                </a:solidFill>
+              </a:rPr>
+              <a:t>в архитектуре процессорных систем</a:t>
+            </a:r>
+            <a:r>
+              <a:rPr>
+                <a:solidFill>
+                  <a:schemeClr val="tx1"/>
+                </a:solidFill>
+              </a:rPr>
+              <a:t>, для получения их эмпирической эффективности в данной архитектуре;</a:t>
             </a:r>
             <a:endParaRPr>
               <a:solidFill>
@@ -15719,11 +15719,31 @@
               </a:solidFill>
             </a:endParaRPr>
           </a:p>
-        </p:txBody>
-      </p:sp>
-      <p:sp>
-        <p:nvSpPr>
-          <p:cNvPr id="1588708495" name="Номер слайда 3"/>
+          <a:p>
+            <a:pPr>
+              <a:buFont typeface="Arial"/>
+              <a:buChar char="–"/>
+              <a:defRPr/>
+            </a:pPr>
+            <a:r>
+              <a:rPr>
+                <a:solidFill>
+                  <a:schemeClr val="tx1"/>
+                </a:solidFill>
+              </a:rPr>
+              <a:t> Приблизит к реализации полноценного графического ядра, а дальше – графического ускорителя.</a:t>
+            </a:r>
+            <a:endParaRPr>
+              <a:solidFill>
+                <a:schemeClr val="tx1"/>
+              </a:solidFill>
+            </a:endParaRPr>
+          </a:p>
+        </p:txBody>
+      </p:sp>
+      <p:sp>
+        <p:nvSpPr>
+          <p:cNvPr id="1605771366" name="Номер слайда 3"/>
           <p:cNvSpPr>
             <a:spLocks noGrp="1"/>
           </p:cNvSpPr>
@@ -15764,7 +15784,7 @@
       </p:sp>
       <p:sp>
         <p:nvSpPr>
-          <p:cNvPr id="280988965" name="Прямоугольник 4"/>
+          <p:cNvPr id="1121215079" name="Прямоугольник 4"/>
           <p:cNvSpPr/>
           <p:nvPr/>
         </p:nvSpPr>
@@ -15814,7 +15834,7 @@
       </p:sp>
       <p:sp>
         <p:nvSpPr>
-          <p:cNvPr id="1662314870" name="Заголовок 1"/>
+          <p:cNvPr id="1029657622" name="Заголовок 1"/>
           <p:cNvSpPr>
             <a:spLocks noGrp="1"/>
           </p:cNvSpPr>
@@ -15853,7 +15873,7 @@
       </p:sp>
       <p:sp>
         <p:nvSpPr>
-          <p:cNvPr id="1234798136" name="Прямоугольник 5"/>
+          <p:cNvPr id="1388606064" name="Прямоугольник 5"/>
           <p:cNvSpPr/>
           <p:nvPr/>
         </p:nvSpPr>
@@ -15969,7 +15989,7 @@
       </p:grpSpPr>
       <p:sp>
         <p:nvSpPr>
-          <p:cNvPr id="1923982345" name="Прямоугольник 9"/>
+          <p:cNvPr id="278519678" name="Прямоугольник 9"/>
           <p:cNvSpPr/>
           <p:nvPr/>
         </p:nvSpPr>
@@ -16019,7 +16039,7 @@
       </p:sp>
       <p:sp>
         <p:nvSpPr>
-          <p:cNvPr id="1005594784" name="Прямоугольник 10"/>
+          <p:cNvPr id="1067345400" name="Прямоугольник 10"/>
           <p:cNvSpPr/>
           <p:nvPr/>
         </p:nvSpPr>
@@ -16069,7 +16089,7 @@
       </p:sp>
       <p:sp>
         <p:nvSpPr>
-          <p:cNvPr id="858244658" name="Заголовок 1"/>
+          <p:cNvPr id="1785780863" name="Заголовок 1"/>
           <p:cNvSpPr>
             <a:spLocks noGrp="1"/>
           </p:cNvSpPr>
@@ -16116,7 +16136,7 @@
       </p:sp>
       <p:sp>
         <p:nvSpPr>
-          <p:cNvPr id="1448765701" name="Объект 2"/>
+          <p:cNvPr id="1671965891" name="Объект 2"/>
           <p:cNvSpPr>
             <a:spLocks noGrp="1"/>
           </p:cNvSpPr>
@@ -16171,7 +16191,7 @@
       </p:sp>
       <p:sp>
         <p:nvSpPr>
-          <p:cNvPr id="346900598" name="Номер слайда 3"/>
+          <p:cNvPr id="407468574" name="Номер слайда 3"/>
           <p:cNvSpPr>
             <a:spLocks noGrp="1"/>
           </p:cNvSpPr>
@@ -16212,7 +16232,7 @@
       </p:sp>
       <p:pic>
         <p:nvPicPr>
-          <p:cNvPr id="1785821000" name="Рисунок 7"/>
+          <p:cNvPr id="1177467375" name="Рисунок 7"/>
           <p:cNvPicPr>
             <a:picLocks noChangeAspect="1"/>
           </p:cNvPicPr>
@@ -16690,7 +16710,7 @@
       </p:grpSpPr>
       <p:sp>
         <p:nvSpPr>
-          <p:cNvPr id="782843311" name="Объект 2"/>
+          <p:cNvPr id="218480208" name="Объект 2"/>
           <p:cNvSpPr>
             <a:spLocks noGrp="1"/>
           </p:cNvSpPr>
@@ -16741,7 +16761,7 @@
       </p:sp>
       <p:sp>
         <p:nvSpPr>
-          <p:cNvPr id="840677090" name="Номер слайда 3"/>
+          <p:cNvPr id="689741051" name="Номер слайда 3"/>
           <p:cNvSpPr>
             <a:spLocks noGrp="1"/>
           </p:cNvSpPr>
@@ -16782,7 +16802,7 @@
       </p:sp>
       <p:pic>
         <p:nvPicPr>
-          <p:cNvPr id="1048005843" name="Рисунок 5"/>
+          <p:cNvPr id="1732777502" name="Рисунок 5"/>
           <p:cNvPicPr>
             <a:picLocks noChangeAspect="1"/>
           </p:cNvPicPr>
@@ -16812,7 +16832,7 @@
       </p:pic>
       <p:pic>
         <p:nvPicPr>
-          <p:cNvPr id="1990718543" name="Рисунок 1421075015"/>
+          <p:cNvPr id="1059245539" name="Рисунок 1421075015"/>
           <p:cNvPicPr>
             <a:picLocks noChangeAspect="1"/>
           </p:cNvPicPr>
@@ -16847,7 +16867,7 @@
       </p:pic>
       <p:sp>
         <p:nvSpPr>
-          <p:cNvPr id="782030701" name="Прямоугольник 10"/>
+          <p:cNvPr id="150001607" name="Прямоугольник 10"/>
           <p:cNvSpPr/>
           <p:nvPr/>
         </p:nvSpPr>
@@ -16897,7 +16917,7 @@
       </p:sp>
       <p:sp>
         <p:nvSpPr>
-          <p:cNvPr id="954627379" name="Прямоугольник 11"/>
+          <p:cNvPr id="1970930413" name="Прямоугольник 11"/>
           <p:cNvSpPr/>
           <p:nvPr/>
         </p:nvSpPr>
@@ -16947,7 +16967,7 @@
       </p:sp>
       <p:sp>
         <p:nvSpPr>
-          <p:cNvPr id="574792027" name="Заголовок 1"/>
+          <p:cNvPr id="1627979841" name="Заголовок 1"/>
           <p:cNvSpPr>
             <a:spLocks noGrp="1"/>
           </p:cNvSpPr>
@@ -16996,7 +17016,7 @@
       </p:sp>
       <p:pic>
         <p:nvPicPr>
-          <p:cNvPr id="2023348104" name="Рисунок 2"/>
+          <p:cNvPr id="1555268725" name="Рисунок 2"/>
           <p:cNvPicPr>
             <a:picLocks noChangeAspect="1"/>
           </p:cNvPicPr>
@@ -17120,7 +17140,7 @@
       </p:grpSpPr>
       <p:sp>
         <p:nvSpPr>
-          <p:cNvPr id="553398658" name="Объект 2"/>
+          <p:cNvPr id="1299174877" name="Объект 2"/>
           <p:cNvSpPr>
             <a:spLocks noGrp="1"/>
           </p:cNvSpPr>
@@ -17245,7 +17265,7 @@
       </p:sp>
       <p:sp>
         <p:nvSpPr>
-          <p:cNvPr id="1208465083" name="Номер слайда 3"/>
+          <p:cNvPr id="1636747347" name="Номер слайда 3"/>
           <p:cNvSpPr>
             <a:spLocks noGrp="1"/>
           </p:cNvSpPr>
@@ -17286,7 +17306,7 @@
       </p:sp>
       <p:sp>
         <p:nvSpPr>
-          <p:cNvPr id="1857069577" name="Прямоугольник 5"/>
+          <p:cNvPr id="534537205" name="Прямоугольник 5"/>
           <p:cNvSpPr/>
           <p:nvPr/>
         </p:nvSpPr>
@@ -17336,7 +17356,7 @@
       </p:sp>
       <p:sp>
         <p:nvSpPr>
-          <p:cNvPr id="1744765801" name="Прямоугольник 6"/>
+          <p:cNvPr id="1730040083" name="Прямоугольник 6"/>
           <p:cNvSpPr/>
           <p:nvPr/>
         </p:nvSpPr>
@@ -17386,7 +17406,7 @@
       </p:sp>
       <p:sp>
         <p:nvSpPr>
-          <p:cNvPr id="45281339" name="Заголовок 1"/>
+          <p:cNvPr id="1109080447" name="Заголовок 1"/>
           <p:cNvSpPr>
             <a:spLocks noGrp="1"/>
           </p:cNvSpPr>
@@ -17532,7 +17552,7 @@
       </p:grpSpPr>
       <p:sp>
         <p:nvSpPr>
-          <p:cNvPr id="883563393" name="Объект 2"/>
+          <p:cNvPr id="924604707" name="Объект 2"/>
           <p:cNvSpPr>
             <a:spLocks noGrp="1"/>
           </p:cNvSpPr>
@@ -17607,7 +17627,7 @@
       </p:sp>
       <p:sp>
         <p:nvSpPr>
-          <p:cNvPr id="1059568745" name="Номер слайда 3"/>
+          <p:cNvPr id="539439231" name="Номер слайда 3"/>
           <p:cNvSpPr>
             <a:spLocks noGrp="1"/>
           </p:cNvSpPr>
@@ -17648,7 +17668,7 @@
       </p:sp>
       <p:sp>
         <p:nvSpPr>
-          <p:cNvPr id="840929692" name="Прямоугольник 6"/>
+          <p:cNvPr id="522519587" name="Прямоугольник 6"/>
           <p:cNvSpPr/>
           <p:nvPr/>
         </p:nvSpPr>
@@ -17698,7 +17718,7 @@
       </p:sp>
       <p:sp>
         <p:nvSpPr>
-          <p:cNvPr id="482067498" name="Прямоугольник 7"/>
+          <p:cNvPr id="2088590454" name="Прямоугольник 7"/>
           <p:cNvSpPr/>
           <p:nvPr/>
         </p:nvSpPr>
@@ -17748,7 +17768,7 @@
       </p:sp>
       <p:sp>
         <p:nvSpPr>
-          <p:cNvPr id="1410570347" name="Заголовок 1"/>
+          <p:cNvPr id="1584440433" name="Заголовок 1"/>
           <p:cNvSpPr>
             <a:spLocks noGrp="1"/>
           </p:cNvSpPr>

</xml_diff>

<commit_message>
Update diploma and pptx
</commit_message>
<xml_diff>
--- a/docs/starukhin_dissertation/magister_pres.pptx
+++ b/docs/starukhin_dissertation/magister_pres.pptx
@@ -1,31 +1,31 @@
 
 <file path=ppt/presentation.xml><?xml version="1.0" encoding="utf-8"?>
-<p:presentation xmlns:a="http://schemas.openxmlformats.org/drawingml/2006/main" xmlns:r="http://schemas.openxmlformats.org/officeDocument/2006/relationships" xmlns:p="http://schemas.openxmlformats.org/presentationml/2006/main" xmlns:m="http://schemas.openxmlformats.org/officeDocument/2006/math" xmlns:w="http://schemas.openxmlformats.org/wordprocessingml/2006/main" saveSubsetFonts="1" showSpecialPlsOnTitleSld="0">
+<p:presentation xmlns:a="http://schemas.openxmlformats.org/drawingml/2006/main" xmlns:r="http://schemas.openxmlformats.org/officeDocument/2006/relationships" xmlns:p="http://schemas.openxmlformats.org/presentationml/2006/main" showSpecialPlsOnTitleSld="0" saveSubsetFonts="1">
   <p:sldMasterIdLst>
     <p:sldMasterId id="2147483648" r:id="rId1"/>
   </p:sldMasterIdLst>
   <p:notesMasterIdLst>
-    <p:notesMasterId r:id="rId22"/>
+    <p:notesMasterId r:id="rId20"/>
   </p:notesMasterIdLst>
   <p:sldIdLst>
-    <p:sldId id="256" r:id="rId4"/>
-    <p:sldId id="257" r:id="rId5"/>
-    <p:sldId id="258" r:id="rId6"/>
-    <p:sldId id="259" r:id="rId7"/>
-    <p:sldId id="260" r:id="rId8"/>
-    <p:sldId id="261" r:id="rId9"/>
-    <p:sldId id="262" r:id="rId10"/>
-    <p:sldId id="263" r:id="rId11"/>
-    <p:sldId id="264" r:id="rId12"/>
-    <p:sldId id="265" r:id="rId13"/>
-    <p:sldId id="266" r:id="rId14"/>
-    <p:sldId id="267" r:id="rId15"/>
-    <p:sldId id="268" r:id="rId16"/>
-    <p:sldId id="269" r:id="rId17"/>
-    <p:sldId id="270" r:id="rId18"/>
-    <p:sldId id="271" r:id="rId19"/>
-    <p:sldId id="272" r:id="rId20"/>
-    <p:sldId id="273" r:id="rId21"/>
+    <p:sldId id="256" r:id="rId2"/>
+    <p:sldId id="257" r:id="rId3"/>
+    <p:sldId id="258" r:id="rId4"/>
+    <p:sldId id="259" r:id="rId5"/>
+    <p:sldId id="260" r:id="rId6"/>
+    <p:sldId id="261" r:id="rId7"/>
+    <p:sldId id="262" r:id="rId8"/>
+    <p:sldId id="263" r:id="rId9"/>
+    <p:sldId id="264" r:id="rId10"/>
+    <p:sldId id="265" r:id="rId11"/>
+    <p:sldId id="266" r:id="rId12"/>
+    <p:sldId id="267" r:id="rId13"/>
+    <p:sldId id="268" r:id="rId14"/>
+    <p:sldId id="269" r:id="rId15"/>
+    <p:sldId id="270" r:id="rId16"/>
+    <p:sldId id="271" r:id="rId17"/>
+    <p:sldId id="272" r:id="rId18"/>
+    <p:sldId id="273" r:id="rId19"/>
   </p:sldIdLst>
   <p:sldSz cx="12192000" cy="6858000"/>
   <p:notesSz cx="6858000" cy="9144000"/>
@@ -124,12 +124,28 @@
       </a:defRPr>
     </a:lvl9pPr>
   </p:defaultTextStyle>
+  <p:extLst>
+    <p:ext uri="{EFAFB233-063F-42B5-8137-9DF3F51BA10A}">
+      <p15:sldGuideLst xmlns:p15="http://schemas.microsoft.com/office/powerpoint/2012/main">
+        <p15:guide id="1" pos="3840">
+          <p15:clr>
+            <a:srgbClr val="A4A3A4"/>
+          </p15:clr>
+        </p15:guide>
+        <p15:guide id="2" orient="horz" pos="2160">
+          <p15:clr>
+            <a:srgbClr val="A4A3A4"/>
+          </p15:clr>
+        </p15:guide>
+      </p15:sldGuideLst>
+    </p:ext>
+  </p:extLst>
 </p:presentation>
 </file>
 
 <file path=ppt/notesMasters/notesMaster1.xml><?xml version="1.0" encoding="utf-8"?>
 <p:notesMaster xmlns:a="http://schemas.openxmlformats.org/drawingml/2006/main" xmlns:r="http://schemas.openxmlformats.org/officeDocument/2006/relationships" xmlns:p="http://schemas.openxmlformats.org/presentationml/2006/main">
-  <p:cSld name="">
+  <p:cSld>
     <p:bg>
       <p:bgRef idx="1001">
         <a:schemeClr val="bg1"/>
@@ -215,7 +231,7 @@
             </a:pPr>
             <a:fld id="{0BF8B4CA-290A-45FF-AF47-6D7BC9CA84C9}" type="datetimeFigureOut">
               <a:rPr lang="ru-RU"/>
-              <a:t>02.06.2026</a:t>
+              <a:t>23.06.2026</a:t>
             </a:fld>
             <a:endParaRPr lang="ru-RU"/>
           </a:p>
@@ -225,7 +241,7 @@
         <p:nvSpPr>
           <p:cNvPr id="1006772333" name="Образ слайда 3"/>
           <p:cNvSpPr>
-            <a:spLocks noChangeAspect="1" noGrp="1" noRot="1"/>
+            <a:spLocks noGrp="1" noRot="1" noChangeAspect="1"/>
           </p:cNvSpPr>
           <p:nvPr>
             <p:ph type="sldImg" idx="2"/>
@@ -502,8 +518,8 @@
 </file>
 
 <file path=ppt/notesSlides/notesSlide1.xml><?xml version="1.0" encoding="utf-8"?>
-<p:notes xmlns:a="http://schemas.openxmlformats.org/drawingml/2006/main" xmlns:r="http://schemas.openxmlformats.org/officeDocument/2006/relationships" xmlns:p="http://schemas.openxmlformats.org/presentationml/2006/main" xmlns:m="http://schemas.openxmlformats.org/officeDocument/2006/math" xmlns:w="http://schemas.openxmlformats.org/wordprocessingml/2006/main">
-  <p:cSld name="">
+<p:notes xmlns:a="http://schemas.openxmlformats.org/drawingml/2006/main" xmlns:r="http://schemas.openxmlformats.org/officeDocument/2006/relationships" xmlns:p="http://schemas.openxmlformats.org/presentationml/2006/main">
+  <p:cSld>
     <p:spTree>
       <p:nvGrpSpPr>
         <p:cNvPr id="1" name=""/>
@@ -522,7 +538,7 @@
         <p:nvSpPr>
           <p:cNvPr id="2049855219" name="Slide Image Placeholder 1"/>
           <p:cNvSpPr>
-            <a:spLocks noChangeAspect="1" noGrp="1" noRot="1"/>
+            <a:spLocks noGrp="1" noRot="1" noChangeAspect="1"/>
           </p:cNvSpPr>
           <p:nvPr>
             <p:ph type="sldImg"/>
@@ -587,8 +603,8 @@
 </file>
 
 <file path=ppt/notesSlides/notesSlide10.xml><?xml version="1.0" encoding="utf-8"?>
-<p:notes xmlns:a="http://schemas.openxmlformats.org/drawingml/2006/main" xmlns:r="http://schemas.openxmlformats.org/officeDocument/2006/relationships" xmlns:p="http://schemas.openxmlformats.org/presentationml/2006/main" xmlns:m="http://schemas.openxmlformats.org/officeDocument/2006/math" xmlns:w="http://schemas.openxmlformats.org/wordprocessingml/2006/main">
-  <p:cSld name="">
+<p:notes xmlns:a="http://schemas.openxmlformats.org/drawingml/2006/main" xmlns:r="http://schemas.openxmlformats.org/officeDocument/2006/relationships" xmlns:p="http://schemas.openxmlformats.org/presentationml/2006/main">
+  <p:cSld>
     <p:spTree>
       <p:nvGrpSpPr>
         <p:cNvPr id="1" name=""/>
@@ -607,7 +623,7 @@
         <p:nvSpPr>
           <p:cNvPr id="546986335" name="Slide Image Placeholder 1"/>
           <p:cNvSpPr>
-            <a:spLocks noChangeAspect="1" noGrp="1" noRot="1"/>
+            <a:spLocks noGrp="1" noRot="1" noChangeAspect="1"/>
           </p:cNvSpPr>
           <p:nvPr>
             <p:ph type="sldImg"/>
@@ -657,7 +673,7 @@
             </a:pPr>
             <a:fld id="{E59DD143-F230-8BE5-DF47-2F712C202B39}" type="slidenum">
               <a:rPr/>
-              <a:t>8</a:t>
+              <a:t>10</a:t>
             </a:fld>
             <a:endParaRPr/>
           </a:p>
@@ -672,8 +688,8 @@
 </file>
 
 <file path=ppt/notesSlides/notesSlide11.xml><?xml version="1.0" encoding="utf-8"?>
-<p:notes xmlns:a="http://schemas.openxmlformats.org/drawingml/2006/main" xmlns:r="http://schemas.openxmlformats.org/officeDocument/2006/relationships" xmlns:p="http://schemas.openxmlformats.org/presentationml/2006/main" xmlns:m="http://schemas.openxmlformats.org/officeDocument/2006/math" xmlns:w="http://schemas.openxmlformats.org/wordprocessingml/2006/main">
-  <p:cSld name="">
+<p:notes xmlns:a="http://schemas.openxmlformats.org/drawingml/2006/main" xmlns:r="http://schemas.openxmlformats.org/officeDocument/2006/relationships" xmlns:p="http://schemas.openxmlformats.org/presentationml/2006/main">
+  <p:cSld>
     <p:spTree>
       <p:nvGrpSpPr>
         <p:cNvPr id="1" name=""/>
@@ -692,7 +708,7 @@
         <p:nvSpPr>
           <p:cNvPr id="1237585104" name="Slide Image Placeholder 1"/>
           <p:cNvSpPr>
-            <a:spLocks noChangeAspect="1" noGrp="1" noRot="1"/>
+            <a:spLocks noGrp="1" noRot="1" noChangeAspect="1"/>
           </p:cNvSpPr>
           <p:nvPr>
             <p:ph type="sldImg"/>
@@ -742,7 +758,7 @@
             </a:pPr>
             <a:fld id="{6478E094-64B7-2766-BCC3-6C48145F116B}" type="slidenum">
               <a:rPr/>
-              <a:t>9</a:t>
+              <a:t>11</a:t>
             </a:fld>
             <a:endParaRPr/>
           </a:p>
@@ -757,8 +773,8 @@
 </file>
 
 <file path=ppt/notesSlides/notesSlide12.xml><?xml version="1.0" encoding="utf-8"?>
-<p:notes xmlns:a="http://schemas.openxmlformats.org/drawingml/2006/main" xmlns:r="http://schemas.openxmlformats.org/officeDocument/2006/relationships" xmlns:p="http://schemas.openxmlformats.org/presentationml/2006/main" xmlns:m="http://schemas.openxmlformats.org/officeDocument/2006/math" xmlns:w="http://schemas.openxmlformats.org/wordprocessingml/2006/main">
-  <p:cSld name="">
+<p:notes xmlns:a="http://schemas.openxmlformats.org/drawingml/2006/main" xmlns:r="http://schemas.openxmlformats.org/officeDocument/2006/relationships" xmlns:p="http://schemas.openxmlformats.org/presentationml/2006/main">
+  <p:cSld>
     <p:spTree>
       <p:nvGrpSpPr>
         <p:cNvPr id="1" name=""/>
@@ -777,7 +793,7 @@
         <p:nvSpPr>
           <p:cNvPr id="1577987428" name="Slide Image Placeholder 1"/>
           <p:cNvSpPr>
-            <a:spLocks noChangeAspect="1" noGrp="1" noRot="1"/>
+            <a:spLocks noGrp="1" noRot="1" noChangeAspect="1"/>
           </p:cNvSpPr>
           <p:nvPr>
             <p:ph type="sldImg"/>
@@ -827,7 +843,7 @@
             </a:pPr>
             <a:fld id="{4A85B0B4-A097-EC80-6511-5CB349CFD099}" type="slidenum">
               <a:rPr/>
-              <a:t>10</a:t>
+              <a:t>12</a:t>
             </a:fld>
             <a:endParaRPr/>
           </a:p>
@@ -842,8 +858,8 @@
 </file>
 
 <file path=ppt/notesSlides/notesSlide13.xml><?xml version="1.0" encoding="utf-8"?>
-<p:notes xmlns:a="http://schemas.openxmlformats.org/drawingml/2006/main" xmlns:r="http://schemas.openxmlformats.org/officeDocument/2006/relationships" xmlns:p="http://schemas.openxmlformats.org/presentationml/2006/main" xmlns:m="http://schemas.openxmlformats.org/officeDocument/2006/math" xmlns:w="http://schemas.openxmlformats.org/wordprocessingml/2006/main">
-  <p:cSld name="">
+<p:notes xmlns:a="http://schemas.openxmlformats.org/drawingml/2006/main" xmlns:r="http://schemas.openxmlformats.org/officeDocument/2006/relationships" xmlns:p="http://schemas.openxmlformats.org/presentationml/2006/main">
+  <p:cSld>
     <p:spTree>
       <p:nvGrpSpPr>
         <p:cNvPr id="1" name=""/>
@@ -862,7 +878,7 @@
         <p:nvSpPr>
           <p:cNvPr id="1017504938" name="Slide Image Placeholder 1"/>
           <p:cNvSpPr>
-            <a:spLocks noChangeAspect="1" noGrp="1" noRot="1"/>
+            <a:spLocks noGrp="1" noRot="1" noChangeAspect="1"/>
           </p:cNvSpPr>
           <p:nvPr>
             <p:ph type="sldImg"/>
@@ -912,7 +928,7 @@
             </a:pPr>
             <a:fld id="{A4FE7883-973B-878E-357F-41AA8BFE4543}" type="slidenum">
               <a:rPr/>
-              <a:t>11</a:t>
+              <a:t>13</a:t>
             </a:fld>
             <a:endParaRPr/>
           </a:p>
@@ -927,8 +943,8 @@
 </file>
 
 <file path=ppt/notesSlides/notesSlide14.xml><?xml version="1.0" encoding="utf-8"?>
-<p:notes xmlns:a="http://schemas.openxmlformats.org/drawingml/2006/main" xmlns:r="http://schemas.openxmlformats.org/officeDocument/2006/relationships" xmlns:p="http://schemas.openxmlformats.org/presentationml/2006/main" xmlns:m="http://schemas.openxmlformats.org/officeDocument/2006/math" xmlns:w="http://schemas.openxmlformats.org/wordprocessingml/2006/main">
-  <p:cSld name="">
+<p:notes xmlns:a="http://schemas.openxmlformats.org/drawingml/2006/main" xmlns:r="http://schemas.openxmlformats.org/officeDocument/2006/relationships" xmlns:p="http://schemas.openxmlformats.org/presentationml/2006/main">
+  <p:cSld>
     <p:spTree>
       <p:nvGrpSpPr>
         <p:cNvPr id="1" name=""/>
@@ -947,7 +963,7 @@
         <p:nvSpPr>
           <p:cNvPr id="192314068" name="Slide Image Placeholder 1"/>
           <p:cNvSpPr>
-            <a:spLocks noChangeAspect="1" noGrp="1" noRot="1"/>
+            <a:spLocks noGrp="1" noRot="1" noChangeAspect="1"/>
           </p:cNvSpPr>
           <p:nvPr>
             <p:ph type="sldImg"/>
@@ -997,7 +1013,7 @@
             </a:pPr>
             <a:fld id="{463C25AB-F75B-ED55-9B43-2E895322D2B6}" type="slidenum">
               <a:rPr/>
-              <a:t>13</a:t>
+              <a:t>14</a:t>
             </a:fld>
             <a:endParaRPr/>
           </a:p>
@@ -1012,8 +1028,8 @@
 </file>
 
 <file path=ppt/notesSlides/notesSlide15.xml><?xml version="1.0" encoding="utf-8"?>
-<p:notes xmlns:a="http://schemas.openxmlformats.org/drawingml/2006/main" xmlns:r="http://schemas.openxmlformats.org/officeDocument/2006/relationships" xmlns:p="http://schemas.openxmlformats.org/presentationml/2006/main" xmlns:m="http://schemas.openxmlformats.org/officeDocument/2006/math" xmlns:w="http://schemas.openxmlformats.org/wordprocessingml/2006/main">
-  <p:cSld name="">
+<p:notes xmlns:a="http://schemas.openxmlformats.org/drawingml/2006/main" xmlns:r="http://schemas.openxmlformats.org/officeDocument/2006/relationships" xmlns:p="http://schemas.openxmlformats.org/presentationml/2006/main">
+  <p:cSld>
     <p:spTree>
       <p:nvGrpSpPr>
         <p:cNvPr id="1" name=""/>
@@ -1032,7 +1048,7 @@
         <p:nvSpPr>
           <p:cNvPr id="1554483612" name="Slide Image Placeholder 1"/>
           <p:cNvSpPr>
-            <a:spLocks noChangeAspect="1" noGrp="1" noRot="1"/>
+            <a:spLocks noGrp="1" noRot="1" noChangeAspect="1"/>
           </p:cNvSpPr>
           <p:nvPr>
             <p:ph type="sldImg"/>
@@ -1082,7 +1098,7 @@
             </a:pPr>
             <a:fld id="{0E3B1206-5BC8-D1E1-57C3-7D177AE62E15}" type="slidenum">
               <a:rPr/>
-              <a:t>14</a:t>
+              <a:t>15</a:t>
             </a:fld>
             <a:endParaRPr/>
           </a:p>
@@ -1097,8 +1113,8 @@
 </file>
 
 <file path=ppt/notesSlides/notesSlide16.xml><?xml version="1.0" encoding="utf-8"?>
-<p:notes xmlns:a="http://schemas.openxmlformats.org/drawingml/2006/main" xmlns:r="http://schemas.openxmlformats.org/officeDocument/2006/relationships" xmlns:p="http://schemas.openxmlformats.org/presentationml/2006/main" xmlns:m="http://schemas.openxmlformats.org/officeDocument/2006/math" xmlns:w="http://schemas.openxmlformats.org/wordprocessingml/2006/main">
-  <p:cSld name="">
+<p:notes xmlns:a="http://schemas.openxmlformats.org/drawingml/2006/main" xmlns:r="http://schemas.openxmlformats.org/officeDocument/2006/relationships" xmlns:p="http://schemas.openxmlformats.org/presentationml/2006/main">
+  <p:cSld>
     <p:spTree>
       <p:nvGrpSpPr>
         <p:cNvPr id="1" name=""/>
@@ -1117,7 +1133,7 @@
         <p:nvSpPr>
           <p:cNvPr id="1201975293" name="Slide Image Placeholder 1"/>
           <p:cNvSpPr>
-            <a:spLocks noChangeAspect="1" noGrp="1" noRot="1"/>
+            <a:spLocks noGrp="1" noRot="1" noChangeAspect="1"/>
           </p:cNvSpPr>
           <p:nvPr>
             <p:ph type="sldImg"/>
@@ -1167,7 +1183,7 @@
             </a:pPr>
             <a:fld id="{FF611C26-A18A-CE56-9368-8EAD053C4851}" type="slidenum">
               <a:rPr/>
-              <a:t>14</a:t>
+              <a:t>16</a:t>
             </a:fld>
             <a:endParaRPr/>
           </a:p>
@@ -1182,8 +1198,8 @@
 </file>
 
 <file path=ppt/notesSlides/notesSlide17.xml><?xml version="1.0" encoding="utf-8"?>
-<p:notes xmlns:a="http://schemas.openxmlformats.org/drawingml/2006/main" xmlns:r="http://schemas.openxmlformats.org/officeDocument/2006/relationships" xmlns:p="http://schemas.openxmlformats.org/presentationml/2006/main" xmlns:m="http://schemas.openxmlformats.org/officeDocument/2006/math" xmlns:w="http://schemas.openxmlformats.org/wordprocessingml/2006/main">
-  <p:cSld name="">
+<p:notes xmlns:a="http://schemas.openxmlformats.org/drawingml/2006/main" xmlns:r="http://schemas.openxmlformats.org/officeDocument/2006/relationships" xmlns:p="http://schemas.openxmlformats.org/presentationml/2006/main">
+  <p:cSld>
     <p:spTree>
       <p:nvGrpSpPr>
         <p:cNvPr id="1" name=""/>
@@ -1202,7 +1218,7 @@
         <p:nvSpPr>
           <p:cNvPr id="1225103498" name="Slide Image Placeholder 1"/>
           <p:cNvSpPr>
-            <a:spLocks noChangeAspect="1" noGrp="1" noRot="1"/>
+            <a:spLocks noGrp="1" noRot="1" noChangeAspect="1"/>
           </p:cNvSpPr>
           <p:nvPr>
             <p:ph type="sldImg"/>
@@ -1252,7 +1268,7 @@
             </a:pPr>
             <a:fld id="{188C1104-84A8-CC17-258A-A96B99F9A95E}" type="slidenum">
               <a:rPr/>
-              <a:t>15</a:t>
+              <a:t>17</a:t>
             </a:fld>
             <a:endParaRPr/>
           </a:p>
@@ -1267,8 +1283,8 @@
 </file>
 
 <file path=ppt/notesSlides/notesSlide18.xml><?xml version="1.0" encoding="utf-8"?>
-<p:notes xmlns:a="http://schemas.openxmlformats.org/drawingml/2006/main" xmlns:r="http://schemas.openxmlformats.org/officeDocument/2006/relationships" xmlns:p="http://schemas.openxmlformats.org/presentationml/2006/main" xmlns:m="http://schemas.openxmlformats.org/officeDocument/2006/math" xmlns:w="http://schemas.openxmlformats.org/wordprocessingml/2006/main">
-  <p:cSld name="">
+<p:notes xmlns:a="http://schemas.openxmlformats.org/drawingml/2006/main" xmlns:r="http://schemas.openxmlformats.org/officeDocument/2006/relationships" xmlns:p="http://schemas.openxmlformats.org/presentationml/2006/main">
+  <p:cSld>
     <p:spTree>
       <p:nvGrpSpPr>
         <p:cNvPr id="1" name=""/>
@@ -1287,7 +1303,7 @@
         <p:nvSpPr>
           <p:cNvPr id="1186598178" name="Slide Image Placeholder 1"/>
           <p:cNvSpPr>
-            <a:spLocks noChangeAspect="1" noGrp="1" noRot="1"/>
+            <a:spLocks noGrp="1" noRot="1" noChangeAspect="1"/>
           </p:cNvSpPr>
           <p:nvPr>
             <p:ph type="sldImg"/>
@@ -1337,7 +1353,7 @@
             </a:pPr>
             <a:fld id="{88900006-DE8E-E061-C9AE-0E64162B086A}" type="slidenum">
               <a:rPr/>
-              <a:t>1</a:t>
+              <a:t>18</a:t>
             </a:fld>
             <a:endParaRPr/>
           </a:p>
@@ -1352,8 +1368,8 @@
 </file>
 
 <file path=ppt/notesSlides/notesSlide2.xml><?xml version="1.0" encoding="utf-8"?>
-<p:notes xmlns:a="http://schemas.openxmlformats.org/drawingml/2006/main" xmlns:r="http://schemas.openxmlformats.org/officeDocument/2006/relationships" xmlns:p="http://schemas.openxmlformats.org/presentationml/2006/main" xmlns:m="http://schemas.openxmlformats.org/officeDocument/2006/math" xmlns:w="http://schemas.openxmlformats.org/wordprocessingml/2006/main">
-  <p:cSld name="">
+<p:notes xmlns:a="http://schemas.openxmlformats.org/drawingml/2006/main" xmlns:r="http://schemas.openxmlformats.org/officeDocument/2006/relationships" xmlns:p="http://schemas.openxmlformats.org/presentationml/2006/main">
+  <p:cSld>
     <p:spTree>
       <p:nvGrpSpPr>
         <p:cNvPr id="1" name=""/>
@@ -1372,7 +1388,7 @@
         <p:nvSpPr>
           <p:cNvPr id="1900417451" name="Slide Image Placeholder 1"/>
           <p:cNvSpPr>
-            <a:spLocks noChangeAspect="1" noGrp="1" noRot="1"/>
+            <a:spLocks noGrp="1" noRot="1" noChangeAspect="1"/>
           </p:cNvSpPr>
           <p:nvPr>
             <p:ph type="sldImg"/>
@@ -1437,8 +1453,8 @@
 </file>
 
 <file path=ppt/notesSlides/notesSlide3.xml><?xml version="1.0" encoding="utf-8"?>
-<p:notes xmlns:a="http://schemas.openxmlformats.org/drawingml/2006/main" xmlns:r="http://schemas.openxmlformats.org/officeDocument/2006/relationships" xmlns:p="http://schemas.openxmlformats.org/presentationml/2006/main" xmlns:m="http://schemas.openxmlformats.org/officeDocument/2006/math" xmlns:w="http://schemas.openxmlformats.org/wordprocessingml/2006/main">
-  <p:cSld name="">
+<p:notes xmlns:a="http://schemas.openxmlformats.org/drawingml/2006/main" xmlns:r="http://schemas.openxmlformats.org/officeDocument/2006/relationships" xmlns:p="http://schemas.openxmlformats.org/presentationml/2006/main">
+  <p:cSld>
     <p:spTree>
       <p:nvGrpSpPr>
         <p:cNvPr id="1" name=""/>
@@ -1457,7 +1473,7 @@
         <p:nvSpPr>
           <p:cNvPr id="798887161" name="Slide Image Placeholder 1"/>
           <p:cNvSpPr>
-            <a:spLocks noChangeAspect="1" noGrp="1" noRot="1"/>
+            <a:spLocks noGrp="1" noRot="1" noChangeAspect="1"/>
           </p:cNvSpPr>
           <p:nvPr>
             <p:ph type="sldImg"/>
@@ -1507,7 +1523,7 @@
             </a:pPr>
             <a:fld id="{B355F3D9-BDFF-EDB5-6FC0-3B806BA109F3}" type="slidenum">
               <a:rPr/>
-              <a:t>4</a:t>
+              <a:t>3</a:t>
             </a:fld>
             <a:endParaRPr/>
           </a:p>
@@ -1522,8 +1538,8 @@
 </file>
 
 <file path=ppt/notesSlides/notesSlide4.xml><?xml version="1.0" encoding="utf-8"?>
-<p:notes xmlns:a="http://schemas.openxmlformats.org/drawingml/2006/main" xmlns:r="http://schemas.openxmlformats.org/officeDocument/2006/relationships" xmlns:p="http://schemas.openxmlformats.org/presentationml/2006/main" xmlns:m="http://schemas.openxmlformats.org/officeDocument/2006/math" xmlns:w="http://schemas.openxmlformats.org/wordprocessingml/2006/main">
-  <p:cSld name="">
+<p:notes xmlns:a="http://schemas.openxmlformats.org/drawingml/2006/main" xmlns:r="http://schemas.openxmlformats.org/officeDocument/2006/relationships" xmlns:p="http://schemas.openxmlformats.org/presentationml/2006/main">
+  <p:cSld>
     <p:spTree>
       <p:nvGrpSpPr>
         <p:cNvPr id="1" name=""/>
@@ -1542,7 +1558,7 @@
         <p:nvSpPr>
           <p:cNvPr id="220610037" name="Slide Image Placeholder 1"/>
           <p:cNvSpPr>
-            <a:spLocks noChangeAspect="1" noGrp="1" noRot="1"/>
+            <a:spLocks noGrp="1" noRot="1" noChangeAspect="1"/>
           </p:cNvSpPr>
           <p:nvPr>
             <p:ph type="sldImg"/>
@@ -1592,7 +1608,7 @@
             </a:pPr>
             <a:fld id="{F20EB7B1-6B7D-5CE5-D95F-5ED0A7232503}" type="slidenum">
               <a:rPr/>
-              <a:t>3</a:t>
+              <a:t>4</a:t>
             </a:fld>
             <a:endParaRPr/>
           </a:p>
@@ -1607,8 +1623,8 @@
 </file>
 
 <file path=ppt/notesSlides/notesSlide5.xml><?xml version="1.0" encoding="utf-8"?>
-<p:notes xmlns:a="http://schemas.openxmlformats.org/drawingml/2006/main" xmlns:r="http://schemas.openxmlformats.org/officeDocument/2006/relationships" xmlns:p="http://schemas.openxmlformats.org/presentationml/2006/main" xmlns:m="http://schemas.openxmlformats.org/officeDocument/2006/math" xmlns:w="http://schemas.openxmlformats.org/wordprocessingml/2006/main">
-  <p:cSld name="">
+<p:notes xmlns:a="http://schemas.openxmlformats.org/drawingml/2006/main" xmlns:r="http://schemas.openxmlformats.org/officeDocument/2006/relationships" xmlns:p="http://schemas.openxmlformats.org/presentationml/2006/main">
+  <p:cSld>
     <p:spTree>
       <p:nvGrpSpPr>
         <p:cNvPr id="1" name=""/>
@@ -1627,7 +1643,7 @@
         <p:nvSpPr>
           <p:cNvPr id="1281688486" name="Slide Image Placeholder 1"/>
           <p:cNvSpPr>
-            <a:spLocks noChangeAspect="1" noGrp="1" noRot="1"/>
+            <a:spLocks noGrp="1" noRot="1" noChangeAspect="1"/>
           </p:cNvSpPr>
           <p:nvPr>
             <p:ph type="sldImg"/>
@@ -1677,7 +1693,7 @@
             </a:pPr>
             <a:fld id="{9F6C2A48-3D77-7BE2-EE5A-0222396F1E07}" type="slidenum">
               <a:rPr/>
-              <a:t>3</a:t>
+              <a:t>5</a:t>
             </a:fld>
             <a:endParaRPr/>
           </a:p>
@@ -1692,8 +1708,8 @@
 </file>
 
 <file path=ppt/notesSlides/notesSlide6.xml><?xml version="1.0" encoding="utf-8"?>
-<p:notes xmlns:a="http://schemas.openxmlformats.org/drawingml/2006/main" xmlns:r="http://schemas.openxmlformats.org/officeDocument/2006/relationships" xmlns:p="http://schemas.openxmlformats.org/presentationml/2006/main" xmlns:m="http://schemas.openxmlformats.org/officeDocument/2006/math" xmlns:w="http://schemas.openxmlformats.org/wordprocessingml/2006/main">
-  <p:cSld name="">
+<p:notes xmlns:a="http://schemas.openxmlformats.org/drawingml/2006/main" xmlns:r="http://schemas.openxmlformats.org/officeDocument/2006/relationships" xmlns:p="http://schemas.openxmlformats.org/presentationml/2006/main">
+  <p:cSld>
     <p:spTree>
       <p:nvGrpSpPr>
         <p:cNvPr id="1" name=""/>
@@ -1712,7 +1728,7 @@
         <p:nvSpPr>
           <p:cNvPr id="1873452942" name="Slide Image Placeholder 1"/>
           <p:cNvSpPr>
-            <a:spLocks noChangeAspect="1" noGrp="1" noRot="1"/>
+            <a:spLocks noGrp="1" noRot="1" noChangeAspect="1"/>
           </p:cNvSpPr>
           <p:nvPr>
             <p:ph type="sldImg"/>
@@ -1762,7 +1778,7 @@
             </a:pPr>
             <a:fld id="{18768EC4-D344-67C3-1C24-CF724D34C290}" type="slidenum">
               <a:rPr/>
-              <a:t>5</a:t>
+              <a:t>6</a:t>
             </a:fld>
             <a:endParaRPr/>
           </a:p>
@@ -1777,8 +1793,8 @@
 </file>
 
 <file path=ppt/notesSlides/notesSlide7.xml><?xml version="1.0" encoding="utf-8"?>
-<p:notes xmlns:a="http://schemas.openxmlformats.org/drawingml/2006/main" xmlns:r="http://schemas.openxmlformats.org/officeDocument/2006/relationships" xmlns:p="http://schemas.openxmlformats.org/presentationml/2006/main" xmlns:m="http://schemas.openxmlformats.org/officeDocument/2006/math" xmlns:w="http://schemas.openxmlformats.org/wordprocessingml/2006/main">
-  <p:cSld name="">
+<p:notes xmlns:a="http://schemas.openxmlformats.org/drawingml/2006/main" xmlns:r="http://schemas.openxmlformats.org/officeDocument/2006/relationships" xmlns:p="http://schemas.openxmlformats.org/presentationml/2006/main">
+  <p:cSld>
     <p:spTree>
       <p:nvGrpSpPr>
         <p:cNvPr id="1" name=""/>
@@ -1797,7 +1813,7 @@
         <p:nvSpPr>
           <p:cNvPr id="665538760" name="Slide Image Placeholder 1"/>
           <p:cNvSpPr>
-            <a:spLocks noChangeAspect="1" noGrp="1" noRot="1"/>
+            <a:spLocks noGrp="1" noRot="1" noChangeAspect="1"/>
           </p:cNvSpPr>
           <p:nvPr>
             <p:ph type="sldImg"/>
@@ -1847,7 +1863,7 @@
             </a:pPr>
             <a:fld id="{EADFCB82-4ABC-C1C4-5E79-18F3785DD755}" type="slidenum">
               <a:rPr/>
-              <a:t>5</a:t>
+              <a:t>7</a:t>
             </a:fld>
             <a:endParaRPr/>
           </a:p>
@@ -1862,8 +1878,8 @@
 </file>
 
 <file path=ppt/notesSlides/notesSlide8.xml><?xml version="1.0" encoding="utf-8"?>
-<p:notes xmlns:a="http://schemas.openxmlformats.org/drawingml/2006/main" xmlns:r="http://schemas.openxmlformats.org/officeDocument/2006/relationships" xmlns:p="http://schemas.openxmlformats.org/presentationml/2006/main" xmlns:m="http://schemas.openxmlformats.org/officeDocument/2006/math" xmlns:w="http://schemas.openxmlformats.org/wordprocessingml/2006/main">
-  <p:cSld name="">
+<p:notes xmlns:a="http://schemas.openxmlformats.org/drawingml/2006/main" xmlns:r="http://schemas.openxmlformats.org/officeDocument/2006/relationships" xmlns:p="http://schemas.openxmlformats.org/presentationml/2006/main">
+  <p:cSld>
     <p:spTree>
       <p:nvGrpSpPr>
         <p:cNvPr id="1" name=""/>
@@ -1882,7 +1898,7 @@
         <p:nvSpPr>
           <p:cNvPr id="339773094" name="Slide Image Placeholder 1"/>
           <p:cNvSpPr>
-            <a:spLocks noChangeAspect="1" noGrp="1" noRot="1"/>
+            <a:spLocks noGrp="1" noRot="1" noChangeAspect="1"/>
           </p:cNvSpPr>
           <p:nvPr>
             <p:ph type="sldImg"/>
@@ -1932,7 +1948,7 @@
             </a:pPr>
             <a:fld id="{C7A0886C-666E-9836-41C4-83E600BD9668}" type="slidenum">
               <a:rPr/>
-              <a:t>6</a:t>
+              <a:t>8</a:t>
             </a:fld>
             <a:endParaRPr/>
           </a:p>
@@ -1947,8 +1963,8 @@
 </file>
 
 <file path=ppt/notesSlides/notesSlide9.xml><?xml version="1.0" encoding="utf-8"?>
-<p:notes xmlns:a="http://schemas.openxmlformats.org/drawingml/2006/main" xmlns:r="http://schemas.openxmlformats.org/officeDocument/2006/relationships" xmlns:p="http://schemas.openxmlformats.org/presentationml/2006/main" xmlns:m="http://schemas.openxmlformats.org/officeDocument/2006/math" xmlns:w="http://schemas.openxmlformats.org/wordprocessingml/2006/main">
-  <p:cSld name="">
+<p:notes xmlns:a="http://schemas.openxmlformats.org/drawingml/2006/main" xmlns:r="http://schemas.openxmlformats.org/officeDocument/2006/relationships" xmlns:p="http://schemas.openxmlformats.org/presentationml/2006/main">
+  <p:cSld>
     <p:spTree>
       <p:nvGrpSpPr>
         <p:cNvPr id="1" name=""/>
@@ -1967,7 +1983,7 @@
         <p:nvSpPr>
           <p:cNvPr id="519179697" name="Slide Image Placeholder 1"/>
           <p:cNvSpPr>
-            <a:spLocks noChangeAspect="1" noGrp="1" noRot="1"/>
+            <a:spLocks noGrp="1" noRot="1" noChangeAspect="1"/>
           </p:cNvSpPr>
           <p:nvPr>
             <p:ph type="sldImg"/>
@@ -2017,7 +2033,7 @@
             </a:pPr>
             <a:fld id="{86902816-76A5-4AF4-1E9E-ABAE37AB74E6}" type="slidenum">
               <a:rPr/>
-              <a:t>7</a:t>
+              <a:t>9</a:t>
             </a:fld>
             <a:endParaRPr/>
           </a:p>
@@ -2032,7 +2048,7 @@
 </file>
 
 <file path=ppt/slideLayouts/slideLayout1.xml><?xml version="1.0" encoding="utf-8"?>
-<p:sldLayout xmlns:a="http://schemas.openxmlformats.org/drawingml/2006/main" xmlns:r="http://schemas.openxmlformats.org/officeDocument/2006/relationships" xmlns:p="http://schemas.openxmlformats.org/presentationml/2006/main" xmlns:m="http://schemas.openxmlformats.org/officeDocument/2006/math" xmlns:w="http://schemas.openxmlformats.org/wordprocessingml/2006/main" matchingName="" preserve="1" showMasterPhAnim="0" showMasterSp="1" type="title" userDrawn="1">
+<p:sldLayout xmlns:a="http://schemas.openxmlformats.org/drawingml/2006/main" xmlns:r="http://schemas.openxmlformats.org/officeDocument/2006/relationships" xmlns:p="http://schemas.openxmlformats.org/presentationml/2006/main" showMasterPhAnim="0" type="title" preserve="1" userDrawn="1">
   <p:cSld name="Титульный слайд">
     <p:spTree>
       <p:nvGrpSpPr>
@@ -2171,7 +2187,7 @@
             </a:pPr>
             <a:fld id="{464E949B-752F-4A71-A243-047E6613A32E}" type="datetime1">
               <a:rPr lang="ru-RU"/>
-              <a:t>02.06.2026</a:t>
+              <a:t>23.06.2026</a:t>
             </a:fld>
             <a:endParaRPr lang="ru-RU"/>
           </a:p>
@@ -2234,7 +2250,7 @@
 </file>
 
 <file path=ppt/slideLayouts/slideLayout10.xml><?xml version="1.0" encoding="utf-8"?>
-<p:sldLayout xmlns:a="http://schemas.openxmlformats.org/drawingml/2006/main" xmlns:r="http://schemas.openxmlformats.org/officeDocument/2006/relationships" xmlns:p="http://schemas.openxmlformats.org/presentationml/2006/main" xmlns:m="http://schemas.openxmlformats.org/officeDocument/2006/math" xmlns:w="http://schemas.openxmlformats.org/wordprocessingml/2006/main" matchingName="" preserve="1" showMasterPhAnim="0" showMasterSp="1" type="vertTx" userDrawn="1">
+<p:sldLayout xmlns:a="http://schemas.openxmlformats.org/drawingml/2006/main" xmlns:r="http://schemas.openxmlformats.org/officeDocument/2006/relationships" xmlns:p="http://schemas.openxmlformats.org/presentationml/2006/main" showMasterPhAnim="0" type="vertTx" preserve="1" userDrawn="1">
   <p:cSld name="Заголовок и вертикальный текст">
     <p:spTree>
       <p:nvGrpSpPr>
@@ -2362,7 +2378,7 @@
             </a:pPr>
             <a:fld id="{9A5CB82E-191B-43B0-A738-8B9909F88B35}" type="datetime1">
               <a:rPr lang="ru-RU"/>
-              <a:t>02.06.2026</a:t>
+              <a:t>23.06.2026</a:t>
             </a:fld>
             <a:endParaRPr lang="ru-RU"/>
           </a:p>
@@ -2425,7 +2441,7 @@
 </file>
 
 <file path=ppt/slideLayouts/slideLayout11.xml><?xml version="1.0" encoding="utf-8"?>
-<p:sldLayout xmlns:a="http://schemas.openxmlformats.org/drawingml/2006/main" xmlns:r="http://schemas.openxmlformats.org/officeDocument/2006/relationships" xmlns:p="http://schemas.openxmlformats.org/presentationml/2006/main" xmlns:m="http://schemas.openxmlformats.org/officeDocument/2006/math" xmlns:w="http://schemas.openxmlformats.org/wordprocessingml/2006/main" matchingName="" preserve="1" showMasterPhAnim="0" showMasterSp="1" type="vertTitleAndTx" userDrawn="1">
+<p:sldLayout xmlns:a="http://schemas.openxmlformats.org/drawingml/2006/main" xmlns:r="http://schemas.openxmlformats.org/officeDocument/2006/relationships" xmlns:p="http://schemas.openxmlformats.org/presentationml/2006/main" showMasterPhAnim="0" type="vertTitleAndTx" preserve="1" userDrawn="1">
   <p:cSld name="Вертикальный заголовок и текст">
     <p:spTree>
       <p:nvGrpSpPr>
@@ -2563,7 +2579,7 @@
             </a:pPr>
             <a:fld id="{9730D1F9-634A-465B-B25E-CF53749F388C}" type="datetime1">
               <a:rPr lang="ru-RU"/>
-              <a:t>02.06.2026</a:t>
+              <a:t>23.06.2026</a:t>
             </a:fld>
             <a:endParaRPr lang="ru-RU"/>
           </a:p>
@@ -2626,7 +2642,7 @@
 </file>
 
 <file path=ppt/slideLayouts/slideLayout12.xml><?xml version="1.0" encoding="utf-8"?>
-<p:sldLayout xmlns:a="http://schemas.openxmlformats.org/drawingml/2006/main" xmlns:r="http://schemas.openxmlformats.org/officeDocument/2006/relationships" xmlns:p="http://schemas.openxmlformats.org/presentationml/2006/main" xmlns:m="http://schemas.openxmlformats.org/officeDocument/2006/math" xmlns:w="http://schemas.openxmlformats.org/wordprocessingml/2006/main" matchingName="" preserve="1" showMasterPhAnim="0" showMasterSp="1" type="title" userDrawn="1">
+<p:sldLayout xmlns:a="http://schemas.openxmlformats.org/drawingml/2006/main" xmlns:r="http://schemas.openxmlformats.org/officeDocument/2006/relationships" xmlns:p="http://schemas.openxmlformats.org/presentationml/2006/main" showMasterPhAnim="0" type="title" preserve="1" userDrawn="1">
   <p:cSld name="1_Титульный слайд">
     <p:spTree>
       <p:nvGrpSpPr>
@@ -2892,7 +2908,7 @@
             </a:pPr>
             <a:fld id="{62D43468-8071-4A79-9713-FA03F2A56FC7}" type="datetime1">
               <a:rPr lang="ru-RU"/>
-              <a:t>02.06.2026</a:t>
+              <a:t>23.06.2026</a:t>
             </a:fld>
             <a:endParaRPr lang="ru-RU"/>
           </a:p>
@@ -2960,7 +2976,7 @@
 </file>
 
 <file path=ppt/slideLayouts/slideLayout13.xml><?xml version="1.0" encoding="utf-8"?>
-<p:sldLayout xmlns:a="http://schemas.openxmlformats.org/drawingml/2006/main" xmlns:r="http://schemas.openxmlformats.org/officeDocument/2006/relationships" xmlns:p="http://schemas.openxmlformats.org/presentationml/2006/main" xmlns:m="http://schemas.openxmlformats.org/officeDocument/2006/math" xmlns:w="http://schemas.openxmlformats.org/wordprocessingml/2006/main" matchingName="" preserve="1" showMasterPhAnim="0" showMasterSp="1" type="obj" userDrawn="1">
+<p:sldLayout xmlns:a="http://schemas.openxmlformats.org/drawingml/2006/main" xmlns:r="http://schemas.openxmlformats.org/officeDocument/2006/relationships" xmlns:p="http://schemas.openxmlformats.org/presentationml/2006/main" showMasterPhAnim="0" type="obj" preserve="1" userDrawn="1">
   <p:cSld name="1_Заголовок и объект">
     <p:spTree>
       <p:nvGrpSpPr>
@@ -3211,7 +3227,7 @@
             </a:pPr>
             <a:fld id="{3AAA47A0-2EBA-44E2-BFE5-02832F0BA229}" type="datetime1">
               <a:rPr lang="ru-RU"/>
-              <a:t>02.06.2026</a:t>
+              <a:t>23.06.2026</a:t>
             </a:fld>
             <a:endParaRPr lang="ru-RU"/>
           </a:p>
@@ -3274,7 +3290,7 @@
 </file>
 
 <file path=ppt/slideLayouts/slideLayout14.xml><?xml version="1.0" encoding="utf-8"?>
-<p:sldLayout xmlns:a="http://schemas.openxmlformats.org/drawingml/2006/main" xmlns:r="http://schemas.openxmlformats.org/officeDocument/2006/relationships" xmlns:p="http://schemas.openxmlformats.org/presentationml/2006/main" xmlns:m="http://schemas.openxmlformats.org/officeDocument/2006/math" xmlns:w="http://schemas.openxmlformats.org/wordprocessingml/2006/main" matchingName="" preserve="1" showMasterPhAnim="0" showMasterSp="1" type="secHead" userDrawn="1">
+<p:sldLayout xmlns:a="http://schemas.openxmlformats.org/drawingml/2006/main" xmlns:r="http://schemas.openxmlformats.org/officeDocument/2006/relationships" xmlns:p="http://schemas.openxmlformats.org/presentationml/2006/main" showMasterPhAnim="0" type="secHead" preserve="1" userDrawn="1">
   <p:cSld name="1_Заголовок раздела">
     <p:spTree>
       <p:nvGrpSpPr>
@@ -3594,7 +3610,7 @@
             </a:pPr>
             <a:fld id="{3E3FDA68-1834-4C1F-B2CC-B0A0766ED8A5}" type="datetime1">
               <a:rPr lang="ru-RU"/>
-              <a:t>02.06.2026</a:t>
+              <a:t>23.06.2026</a:t>
             </a:fld>
             <a:endParaRPr lang="ru-RU"/>
           </a:p>
@@ -3662,7 +3678,7 @@
 </file>
 
 <file path=ppt/slideLayouts/slideLayout15.xml><?xml version="1.0" encoding="utf-8"?>
-<p:sldLayout xmlns:a="http://schemas.openxmlformats.org/drawingml/2006/main" xmlns:r="http://schemas.openxmlformats.org/officeDocument/2006/relationships" xmlns:p="http://schemas.openxmlformats.org/presentationml/2006/main" xmlns:m="http://schemas.openxmlformats.org/officeDocument/2006/math" xmlns:w="http://schemas.openxmlformats.org/wordprocessingml/2006/main" matchingName="" preserve="1" showMasterPhAnim="0" showMasterSp="1" type="twoObj" userDrawn="1">
+<p:sldLayout xmlns:a="http://schemas.openxmlformats.org/drawingml/2006/main" xmlns:r="http://schemas.openxmlformats.org/officeDocument/2006/relationships" xmlns:p="http://schemas.openxmlformats.org/presentationml/2006/main" showMasterPhAnim="0" type="twoObj" preserve="1" userDrawn="1">
   <p:cSld name="1_Два объекта">
     <p:spTree>
       <p:nvGrpSpPr>
@@ -3989,7 +4005,7 @@
             </a:pPr>
             <a:fld id="{29303EE3-BBFB-41F4-B1FB-4E4CF27ED9D2}" type="datetime1">
               <a:rPr lang="ru-RU"/>
-              <a:t>02.06.2026</a:t>
+              <a:t>23.06.2026</a:t>
             </a:fld>
             <a:endParaRPr lang="ru-RU"/>
           </a:p>
@@ -4052,7 +4068,7 @@
 </file>
 
 <file path=ppt/slideLayouts/slideLayout16.xml><?xml version="1.0" encoding="utf-8"?>
-<p:sldLayout xmlns:a="http://schemas.openxmlformats.org/drawingml/2006/main" xmlns:r="http://schemas.openxmlformats.org/officeDocument/2006/relationships" xmlns:p="http://schemas.openxmlformats.org/presentationml/2006/main" xmlns:m="http://schemas.openxmlformats.org/officeDocument/2006/math" xmlns:w="http://schemas.openxmlformats.org/wordprocessingml/2006/main" matchingName="" preserve="1" showMasterPhAnim="0" showMasterSp="1" type="twoTxTwoObj" userDrawn="1">
+<p:sldLayout xmlns:a="http://schemas.openxmlformats.org/drawingml/2006/main" xmlns:r="http://schemas.openxmlformats.org/officeDocument/2006/relationships" xmlns:p="http://schemas.openxmlformats.org/presentationml/2006/main" showMasterPhAnim="0" type="twoTxTwoObj" preserve="1" userDrawn="1">
   <p:cSld name="1_Сравнение">
     <p:spTree>
       <p:nvGrpSpPr>
@@ -4520,7 +4536,7 @@
             </a:pPr>
             <a:fld id="{596D59AE-5854-4542-9FF1-1EC4E5A530D5}" type="datetime1">
               <a:rPr lang="ru-RU"/>
-              <a:t>02.06.2026</a:t>
+              <a:t>23.06.2026</a:t>
             </a:fld>
             <a:endParaRPr lang="ru-RU"/>
           </a:p>
@@ -4583,7 +4599,7 @@
 </file>
 
 <file path=ppt/slideLayouts/slideLayout17.xml><?xml version="1.0" encoding="utf-8"?>
-<p:sldLayout xmlns:a="http://schemas.openxmlformats.org/drawingml/2006/main" xmlns:r="http://schemas.openxmlformats.org/officeDocument/2006/relationships" xmlns:p="http://schemas.openxmlformats.org/presentationml/2006/main" xmlns:m="http://schemas.openxmlformats.org/officeDocument/2006/math" xmlns:w="http://schemas.openxmlformats.org/wordprocessingml/2006/main" matchingName="" preserve="1" showMasterPhAnim="0" showMasterSp="1" type="titleOnly" userDrawn="1">
+<p:sldLayout xmlns:a="http://schemas.openxmlformats.org/drawingml/2006/main" xmlns:r="http://schemas.openxmlformats.org/officeDocument/2006/relationships" xmlns:p="http://schemas.openxmlformats.org/presentationml/2006/main" showMasterPhAnim="0" type="titleOnly" preserve="1" userDrawn="1">
   <p:cSld name="1_Только заголовок">
     <p:spTree>
       <p:nvGrpSpPr>
@@ -4768,7 +4784,7 @@
             </a:pPr>
             <a:fld id="{0C785264-56B0-460E-A2C2-C886D7CC0782}" type="datetime1">
               <a:rPr lang="ru-RU"/>
-              <a:t>02.06.2026</a:t>
+              <a:t>23.06.2026</a:t>
             </a:fld>
             <a:endParaRPr lang="ru-RU"/>
           </a:p>
@@ -4831,7 +4847,7 @@
 </file>
 
 <file path=ppt/slideLayouts/slideLayout18.xml><?xml version="1.0" encoding="utf-8"?>
-<p:sldLayout xmlns:a="http://schemas.openxmlformats.org/drawingml/2006/main" xmlns:r="http://schemas.openxmlformats.org/officeDocument/2006/relationships" xmlns:p="http://schemas.openxmlformats.org/presentationml/2006/main" xmlns:m="http://schemas.openxmlformats.org/officeDocument/2006/math" xmlns:w="http://schemas.openxmlformats.org/wordprocessingml/2006/main" matchingName="" preserve="1" showMasterPhAnim="0" showMasterSp="1" type="blank" userDrawn="1">
+<p:sldLayout xmlns:a="http://schemas.openxmlformats.org/drawingml/2006/main" xmlns:r="http://schemas.openxmlformats.org/officeDocument/2006/relationships" xmlns:p="http://schemas.openxmlformats.org/presentationml/2006/main" showMasterPhAnim="0" type="blank" preserve="1" userDrawn="1">
   <p:cSld name="1_Пустой слайд">
     <p:spTree>
       <p:nvGrpSpPr>
@@ -4927,7 +4943,7 @@
             </a:pPr>
             <a:fld id="{0AAA0283-F641-48C8-BAB7-8AC6BD361923}" type="datetime1">
               <a:rPr lang="ru-RU"/>
-              <a:t>02.06.2026</a:t>
+              <a:t>23.06.2026</a:t>
             </a:fld>
             <a:endParaRPr lang="ru-RU"/>
           </a:p>
@@ -4990,7 +5006,7 @@
 </file>
 
 <file path=ppt/slideLayouts/slideLayout19.xml><?xml version="1.0" encoding="utf-8"?>
-<p:sldLayout xmlns:a="http://schemas.openxmlformats.org/drawingml/2006/main" xmlns:r="http://schemas.openxmlformats.org/officeDocument/2006/relationships" xmlns:p="http://schemas.openxmlformats.org/presentationml/2006/main" xmlns:m="http://schemas.openxmlformats.org/officeDocument/2006/math" xmlns:w="http://schemas.openxmlformats.org/wordprocessingml/2006/main" matchingName="" preserve="1" showMasterPhAnim="0" showMasterSp="1" type="objTx" userDrawn="1">
+<p:sldLayout xmlns:a="http://schemas.openxmlformats.org/drawingml/2006/main" xmlns:r="http://schemas.openxmlformats.org/officeDocument/2006/relationships" xmlns:p="http://schemas.openxmlformats.org/presentationml/2006/main" showMasterPhAnim="0" type="objTx" preserve="1" userDrawn="1">
   <p:cSld name="1_Объект с подписью">
     <p:spTree>
       <p:nvGrpSpPr>
@@ -5325,7 +5341,7 @@
             </a:pPr>
             <a:fld id="{8C10133D-16A4-41F1-B8F2-C1B694F00730}" type="datetime1">
               <a:rPr lang="ru-RU"/>
-              <a:t>02.06.2026</a:t>
+              <a:t>23.06.2026</a:t>
             </a:fld>
             <a:endParaRPr lang="ru-RU"/>
           </a:p>
@@ -5388,7 +5404,7 @@
 </file>
 
 <file path=ppt/slideLayouts/slideLayout2.xml><?xml version="1.0" encoding="utf-8"?>
-<p:sldLayout xmlns:a="http://schemas.openxmlformats.org/drawingml/2006/main" xmlns:r="http://schemas.openxmlformats.org/officeDocument/2006/relationships" xmlns:p="http://schemas.openxmlformats.org/presentationml/2006/main" xmlns:m="http://schemas.openxmlformats.org/officeDocument/2006/math" xmlns:w="http://schemas.openxmlformats.org/wordprocessingml/2006/main" matchingName="" preserve="1" showMasterPhAnim="0" showMasterSp="1" type="obj" userDrawn="1">
+<p:sldLayout xmlns:a="http://schemas.openxmlformats.org/drawingml/2006/main" xmlns:r="http://schemas.openxmlformats.org/officeDocument/2006/relationships" xmlns:p="http://schemas.openxmlformats.org/presentationml/2006/main" showMasterPhAnim="0" type="obj" preserve="1" userDrawn="1">
   <p:cSld name="Заголовок и объект">
     <p:spTree>
       <p:nvGrpSpPr>
@@ -5516,7 +5532,7 @@
             </a:pPr>
             <a:fld id="{DB2D18A6-5519-416E-A160-669FC8C75E20}" type="datetime1">
               <a:rPr lang="ru-RU"/>
-              <a:t>02.06.2026</a:t>
+              <a:t>23.06.2026</a:t>
             </a:fld>
             <a:endParaRPr lang="ru-RU"/>
           </a:p>
@@ -5579,7 +5595,7 @@
 </file>
 
 <file path=ppt/slideLayouts/slideLayout20.xml><?xml version="1.0" encoding="utf-8"?>
-<p:sldLayout xmlns:a="http://schemas.openxmlformats.org/drawingml/2006/main" xmlns:r="http://schemas.openxmlformats.org/officeDocument/2006/relationships" xmlns:p="http://schemas.openxmlformats.org/presentationml/2006/main" xmlns:m="http://schemas.openxmlformats.org/officeDocument/2006/math" xmlns:w="http://schemas.openxmlformats.org/wordprocessingml/2006/main" matchingName="" preserve="1" showMasterPhAnim="0" showMasterSp="1" type="picTx" userDrawn="1">
+<p:sldLayout xmlns:a="http://schemas.openxmlformats.org/drawingml/2006/main" xmlns:r="http://schemas.openxmlformats.org/officeDocument/2006/relationships" xmlns:p="http://schemas.openxmlformats.org/presentationml/2006/main" showMasterPhAnim="0" type="picTx" preserve="1" userDrawn="1">
   <p:cSld name="1_Рисунок с подписью">
     <p:spTree>
       <p:nvGrpSpPr>
@@ -5759,7 +5775,7 @@
         <p:nvSpPr>
           <p:cNvPr id="494512508" name="Picture Placeholder 2"/>
           <p:cNvSpPr>
-            <a:spLocks noChangeAspect="1" noGrp="1"/>
+            <a:spLocks noGrp="1" noChangeAspect="1"/>
           </p:cNvSpPr>
           <p:nvPr>
             <p:ph type="pic" idx="1"/>
@@ -5925,7 +5941,7 @@
             </a:pPr>
             <a:fld id="{665D9257-9E03-404F-95EE-486F8868E3F2}" type="datetime1">
               <a:rPr lang="ru-RU"/>
-              <a:t>02.06.2026</a:t>
+              <a:t>23.06.2026</a:t>
             </a:fld>
             <a:endParaRPr lang="ru-RU"/>
           </a:p>
@@ -5988,7 +6004,7 @@
 </file>
 
 <file path=ppt/slideLayouts/slideLayout21.xml><?xml version="1.0" encoding="utf-8"?>
-<p:sldLayout xmlns:a="http://schemas.openxmlformats.org/drawingml/2006/main" xmlns:r="http://schemas.openxmlformats.org/officeDocument/2006/relationships" xmlns:p="http://schemas.openxmlformats.org/presentationml/2006/main" xmlns:m="http://schemas.openxmlformats.org/officeDocument/2006/math" xmlns:w="http://schemas.openxmlformats.org/wordprocessingml/2006/main" matchingName="" preserve="1" showMasterPhAnim="0" showMasterSp="1" userDrawn="1">
+<p:sldLayout xmlns:a="http://schemas.openxmlformats.org/drawingml/2006/main" xmlns:r="http://schemas.openxmlformats.org/officeDocument/2006/relationships" xmlns:p="http://schemas.openxmlformats.org/presentationml/2006/main" showMasterPhAnim="0" preserve="1" userDrawn="1">
   <p:cSld name="Панорамная фотография с подписью">
     <p:spTree>
       <p:nvGrpSpPr>
@@ -6168,7 +6184,7 @@
         <p:nvSpPr>
           <p:cNvPr id="962049135" name="Picture Placeholder 2"/>
           <p:cNvSpPr>
-            <a:spLocks noChangeAspect="1" noGrp="1"/>
+            <a:spLocks noGrp="1" noChangeAspect="1"/>
           </p:cNvSpPr>
           <p:nvPr>
             <p:ph type="pic" idx="1"/>
@@ -6334,7 +6350,7 @@
             </a:pPr>
             <a:fld id="{8C6571D8-6559-4269-B7BA-EACD5F8873B8}" type="datetime1">
               <a:rPr lang="ru-RU"/>
-              <a:t>02.06.2026</a:t>
+              <a:t>23.06.2026</a:t>
             </a:fld>
             <a:endParaRPr lang="ru-RU"/>
           </a:p>
@@ -6402,7 +6418,7 @@
 </file>
 
 <file path=ppt/slideLayouts/slideLayout22.xml><?xml version="1.0" encoding="utf-8"?>
-<p:sldLayout xmlns:a="http://schemas.openxmlformats.org/drawingml/2006/main" xmlns:r="http://schemas.openxmlformats.org/officeDocument/2006/relationships" xmlns:p="http://schemas.openxmlformats.org/presentationml/2006/main" xmlns:m="http://schemas.openxmlformats.org/officeDocument/2006/math" xmlns:w="http://schemas.openxmlformats.org/wordprocessingml/2006/main" matchingName="" preserve="1" showMasterPhAnim="0" showMasterSp="1" userDrawn="1">
+<p:sldLayout xmlns:a="http://schemas.openxmlformats.org/drawingml/2006/main" xmlns:r="http://schemas.openxmlformats.org/officeDocument/2006/relationships" xmlns:p="http://schemas.openxmlformats.org/presentationml/2006/main" showMasterPhAnim="0" preserve="1" userDrawn="1">
   <p:cSld name="Заголовок и подпись">
     <p:spTree>
       <p:nvGrpSpPr>
@@ -6664,7 +6680,7 @@
             </a:pPr>
             <a:fld id="{952607F1-4CB0-4741-B752-77795AAFB6CE}" type="datetime1">
               <a:rPr lang="ru-RU"/>
-              <a:t>02.06.2026</a:t>
+              <a:t>23.06.2026</a:t>
             </a:fld>
             <a:endParaRPr lang="ru-RU"/>
           </a:p>
@@ -6732,7 +6748,7 @@
 </file>
 
 <file path=ppt/slideLayouts/slideLayout23.xml><?xml version="1.0" encoding="utf-8"?>
-<p:sldLayout xmlns:a="http://schemas.openxmlformats.org/drawingml/2006/main" xmlns:r="http://schemas.openxmlformats.org/officeDocument/2006/relationships" xmlns:p="http://schemas.openxmlformats.org/presentationml/2006/main" xmlns:m="http://schemas.openxmlformats.org/officeDocument/2006/math" xmlns:w="http://schemas.openxmlformats.org/wordprocessingml/2006/main" matchingName="" preserve="1" showMasterPhAnim="0" showMasterSp="1" userDrawn="1">
+<p:sldLayout xmlns:a="http://schemas.openxmlformats.org/drawingml/2006/main" xmlns:r="http://schemas.openxmlformats.org/officeDocument/2006/relationships" xmlns:p="http://schemas.openxmlformats.org/presentationml/2006/main" showMasterPhAnim="0" preserve="1" userDrawn="1">
   <p:cSld name="Цитата с подписью">
     <p:spTree>
       <p:nvGrpSpPr>
@@ -7066,7 +7082,7 @@
             </a:pPr>
             <a:fld id="{4D0F2E69-AF6B-4D0C-824F-3DADD254BF95}" type="datetime1">
               <a:rPr lang="ru-RU"/>
-              <a:t>02.06.2026</a:t>
+              <a:t>23.06.2026</a:t>
             </a:fld>
             <a:endParaRPr lang="ru-RU"/>
           </a:p>
@@ -7342,7 +7358,7 @@
 </file>
 
 <file path=ppt/slideLayouts/slideLayout24.xml><?xml version="1.0" encoding="utf-8"?>
-<p:sldLayout xmlns:a="http://schemas.openxmlformats.org/drawingml/2006/main" xmlns:r="http://schemas.openxmlformats.org/officeDocument/2006/relationships" xmlns:p="http://schemas.openxmlformats.org/presentationml/2006/main" xmlns:m="http://schemas.openxmlformats.org/officeDocument/2006/math" xmlns:w="http://schemas.openxmlformats.org/wordprocessingml/2006/main" matchingName="" preserve="1" showMasterPhAnim="0" showMasterSp="1" userDrawn="1">
+<p:sldLayout xmlns:a="http://schemas.openxmlformats.org/drawingml/2006/main" xmlns:r="http://schemas.openxmlformats.org/officeDocument/2006/relationships" xmlns:p="http://schemas.openxmlformats.org/presentationml/2006/main" showMasterPhAnim="0" preserve="1" userDrawn="1">
   <p:cSld name="Карточка имени">
     <p:spTree>
       <p:nvGrpSpPr>
@@ -7604,7 +7620,7 @@
             </a:pPr>
             <a:fld id="{7B61B190-EA0F-465A-8B4C-40AE0FF8CD42}" type="datetime1">
               <a:rPr lang="ru-RU"/>
-              <a:t>02.06.2026</a:t>
+              <a:t>23.06.2026</a:t>
             </a:fld>
             <a:endParaRPr lang="ru-RU"/>
           </a:p>
@@ -7672,7 +7688,7 @@
 </file>
 
 <file path=ppt/slideLayouts/slideLayout25.xml><?xml version="1.0" encoding="utf-8"?>
-<p:sldLayout xmlns:a="http://schemas.openxmlformats.org/drawingml/2006/main" xmlns:r="http://schemas.openxmlformats.org/officeDocument/2006/relationships" xmlns:p="http://schemas.openxmlformats.org/presentationml/2006/main" xmlns:m="http://schemas.openxmlformats.org/officeDocument/2006/math" xmlns:w="http://schemas.openxmlformats.org/wordprocessingml/2006/main" matchingName="" preserve="1" showMasterPhAnim="0" showMasterSp="1" userDrawn="1">
+<p:sldLayout xmlns:a="http://schemas.openxmlformats.org/drawingml/2006/main" xmlns:r="http://schemas.openxmlformats.org/officeDocument/2006/relationships" xmlns:p="http://schemas.openxmlformats.org/presentationml/2006/main" showMasterPhAnim="0" preserve="1" userDrawn="1">
   <p:cSld name="Три колонки">
     <p:spTree>
       <p:nvGrpSpPr>
@@ -8294,7 +8310,7 @@
             </a:pPr>
             <a:fld id="{EABFF2AA-51FD-495E-9B6C-53E0CCE8720E}" type="datetime1">
               <a:rPr lang="ru-RU"/>
-              <a:t>02.06.2026</a:t>
+              <a:t>23.06.2026</a:t>
             </a:fld>
             <a:endParaRPr lang="ru-RU"/>
           </a:p>
@@ -8357,7 +8373,7 @@
 </file>
 
 <file path=ppt/slideLayouts/slideLayout26.xml><?xml version="1.0" encoding="utf-8"?>
-<p:sldLayout xmlns:a="http://schemas.openxmlformats.org/drawingml/2006/main" xmlns:r="http://schemas.openxmlformats.org/officeDocument/2006/relationships" xmlns:p="http://schemas.openxmlformats.org/presentationml/2006/main" xmlns:m="http://schemas.openxmlformats.org/officeDocument/2006/math" xmlns:w="http://schemas.openxmlformats.org/wordprocessingml/2006/main" matchingName="" preserve="1" showMasterPhAnim="0" showMasterSp="1" userDrawn="1">
+<p:sldLayout xmlns:a="http://schemas.openxmlformats.org/drawingml/2006/main" xmlns:r="http://schemas.openxmlformats.org/officeDocument/2006/relationships" xmlns:p="http://schemas.openxmlformats.org/presentationml/2006/main" showMasterPhAnim="0" preserve="1" userDrawn="1">
   <p:cSld name="Столбец с тремя рисунками">
     <p:spTree>
       <p:nvGrpSpPr>
@@ -8605,7 +8621,7 @@
         <p:nvSpPr>
           <p:cNvPr id="289936537" name="Picture Placeholder 2"/>
           <p:cNvSpPr>
-            <a:spLocks noChangeAspect="1" noGrp="1"/>
+            <a:spLocks noGrp="1" noChangeAspect="1"/>
           </p:cNvSpPr>
           <p:nvPr>
             <p:ph type="pic" idx="15"/>
@@ -8831,7 +8847,7 @@
         <p:nvSpPr>
           <p:cNvPr id="1224020366" name="Picture Placeholder 2"/>
           <p:cNvSpPr>
-            <a:spLocks noChangeAspect="1" noGrp="1"/>
+            <a:spLocks noGrp="1" noChangeAspect="1"/>
           </p:cNvSpPr>
           <p:nvPr>
             <p:ph type="pic" idx="21"/>
@@ -9057,7 +9073,7 @@
         <p:nvSpPr>
           <p:cNvPr id="1892102309" name="Picture Placeholder 2"/>
           <p:cNvSpPr>
-            <a:spLocks noChangeAspect="1" noGrp="1"/>
+            <a:spLocks noGrp="1" noChangeAspect="1"/>
           </p:cNvSpPr>
           <p:nvPr>
             <p:ph type="pic" idx="22"/>
@@ -9225,7 +9241,7 @@
             </a:pPr>
             <a:fld id="{AA532452-DB40-464D-817C-83D7743D6F57}" type="datetime1">
               <a:rPr lang="ru-RU"/>
-              <a:t>02.06.2026</a:t>
+              <a:t>23.06.2026</a:t>
             </a:fld>
             <a:endParaRPr lang="ru-RU"/>
           </a:p>
@@ -9288,7 +9304,7 @@
 </file>
 
 <file path=ppt/slideLayouts/slideLayout27.xml><?xml version="1.0" encoding="utf-8"?>
-<p:sldLayout xmlns:a="http://schemas.openxmlformats.org/drawingml/2006/main" xmlns:r="http://schemas.openxmlformats.org/officeDocument/2006/relationships" xmlns:p="http://schemas.openxmlformats.org/presentationml/2006/main" xmlns:m="http://schemas.openxmlformats.org/officeDocument/2006/math" xmlns:w="http://schemas.openxmlformats.org/wordprocessingml/2006/main" matchingName="" preserve="1" showMasterPhAnim="0" showMasterSp="1" type="vertTx" userDrawn="1">
+<p:sldLayout xmlns:a="http://schemas.openxmlformats.org/drawingml/2006/main" xmlns:r="http://schemas.openxmlformats.org/officeDocument/2006/relationships" xmlns:p="http://schemas.openxmlformats.org/presentationml/2006/main" showMasterPhAnim="0" type="vertTx" preserve="1" userDrawn="1">
   <p:cSld name="1_Заголовок и вертикальный текст">
     <p:spTree>
       <p:nvGrpSpPr>
@@ -9543,7 +9559,7 @@
             </a:pPr>
             <a:fld id="{F87BE9EF-9137-4EC0-A2FE-700F392F3BEF}" type="datetime1">
               <a:rPr lang="ru-RU"/>
-              <a:t>02.06.2026</a:t>
+              <a:t>23.06.2026</a:t>
             </a:fld>
             <a:endParaRPr lang="ru-RU"/>
           </a:p>
@@ -9606,7 +9622,7 @@
 </file>
 
 <file path=ppt/slideLayouts/slideLayout28.xml><?xml version="1.0" encoding="utf-8"?>
-<p:sldLayout xmlns:a="http://schemas.openxmlformats.org/drawingml/2006/main" xmlns:r="http://schemas.openxmlformats.org/officeDocument/2006/relationships" xmlns:p="http://schemas.openxmlformats.org/presentationml/2006/main" xmlns:m="http://schemas.openxmlformats.org/officeDocument/2006/math" xmlns:w="http://schemas.openxmlformats.org/wordprocessingml/2006/main" matchingName="" preserve="1" showMasterPhAnim="0" showMasterSp="1" type="vertTitleAndTx" userDrawn="1">
+<p:sldLayout xmlns:a="http://schemas.openxmlformats.org/drawingml/2006/main" xmlns:r="http://schemas.openxmlformats.org/officeDocument/2006/relationships" xmlns:p="http://schemas.openxmlformats.org/presentationml/2006/main" showMasterPhAnim="0" type="vertTitleAndTx" preserve="1" userDrawn="1">
   <p:cSld name="1_Вертикальный заголовок и текст">
     <p:spTree>
       <p:nvGrpSpPr>
@@ -9828,7 +9844,7 @@
             </a:pPr>
             <a:fld id="{2BF7793B-D180-44C4-B91E-57912C70F4D0}" type="datetime1">
               <a:rPr lang="ru-RU"/>
-              <a:t>02.06.2026</a:t>
+              <a:t>23.06.2026</a:t>
             </a:fld>
             <a:endParaRPr lang="ru-RU"/>
           </a:p>
@@ -9905,7 +9921,7 @@
 </file>
 
 <file path=ppt/slideLayouts/slideLayout3.xml><?xml version="1.0" encoding="utf-8"?>
-<p:sldLayout xmlns:a="http://schemas.openxmlformats.org/drawingml/2006/main" xmlns:r="http://schemas.openxmlformats.org/officeDocument/2006/relationships" xmlns:p="http://schemas.openxmlformats.org/presentationml/2006/main" xmlns:m="http://schemas.openxmlformats.org/officeDocument/2006/math" xmlns:w="http://schemas.openxmlformats.org/wordprocessingml/2006/main" matchingName="" preserve="1" showMasterPhAnim="0" showMasterSp="1" type="secHead" userDrawn="1">
+<p:sldLayout xmlns:a="http://schemas.openxmlformats.org/drawingml/2006/main" xmlns:r="http://schemas.openxmlformats.org/officeDocument/2006/relationships" xmlns:p="http://schemas.openxmlformats.org/presentationml/2006/main" showMasterPhAnim="0" type="secHead" preserve="1" userDrawn="1">
   <p:cSld name="Заголовок раздела">
     <p:spTree>
       <p:nvGrpSpPr>
@@ -10098,7 +10114,7 @@
             </a:pPr>
             <a:fld id="{9FDFF63E-A7E5-4C7D-A2C9-DA69D5675040}" type="datetime1">
               <a:rPr lang="ru-RU"/>
-              <a:t>02.06.2026</a:t>
+              <a:t>23.06.2026</a:t>
             </a:fld>
             <a:endParaRPr lang="ru-RU"/>
           </a:p>
@@ -10161,7 +10177,7 @@
 </file>
 
 <file path=ppt/slideLayouts/slideLayout4.xml><?xml version="1.0" encoding="utf-8"?>
-<p:sldLayout xmlns:a="http://schemas.openxmlformats.org/drawingml/2006/main" xmlns:r="http://schemas.openxmlformats.org/officeDocument/2006/relationships" xmlns:p="http://schemas.openxmlformats.org/presentationml/2006/main" xmlns:m="http://schemas.openxmlformats.org/officeDocument/2006/math" xmlns:w="http://schemas.openxmlformats.org/wordprocessingml/2006/main" matchingName="" preserve="1" showMasterPhAnim="0" showMasterSp="1" type="twoObj" userDrawn="1">
+<p:sldLayout xmlns:a="http://schemas.openxmlformats.org/drawingml/2006/main" xmlns:r="http://schemas.openxmlformats.org/officeDocument/2006/relationships" xmlns:p="http://schemas.openxmlformats.org/presentationml/2006/main" showMasterPhAnim="0" type="twoObj" preserve="1" userDrawn="1">
   <p:cSld name="Два объекта">
     <p:spTree>
       <p:nvGrpSpPr>
@@ -10365,7 +10381,7 @@
             </a:pPr>
             <a:fld id="{8464CDE6-6F92-4C74-BFB3-7167DEA2EA4E}" type="datetime1">
               <a:rPr lang="ru-RU"/>
-              <a:t>02.06.2026</a:t>
+              <a:t>23.06.2026</a:t>
             </a:fld>
             <a:endParaRPr lang="ru-RU"/>
           </a:p>
@@ -10428,7 +10444,7 @@
 </file>
 
 <file path=ppt/slideLayouts/slideLayout5.xml><?xml version="1.0" encoding="utf-8"?>
-<p:sldLayout xmlns:a="http://schemas.openxmlformats.org/drawingml/2006/main" xmlns:r="http://schemas.openxmlformats.org/officeDocument/2006/relationships" xmlns:p="http://schemas.openxmlformats.org/presentationml/2006/main" xmlns:m="http://schemas.openxmlformats.org/officeDocument/2006/math" xmlns:w="http://schemas.openxmlformats.org/wordprocessingml/2006/main" matchingName="" preserve="1" showMasterPhAnim="0" showMasterSp="1" type="twoTxTwoObj" userDrawn="1">
+<p:sldLayout xmlns:a="http://schemas.openxmlformats.org/drawingml/2006/main" xmlns:r="http://schemas.openxmlformats.org/officeDocument/2006/relationships" xmlns:p="http://schemas.openxmlformats.org/presentationml/2006/main" showMasterPhAnim="0" type="twoTxTwoObj" preserve="1" userDrawn="1">
   <p:cSld name="Сравнение">
     <p:spTree>
       <p:nvGrpSpPr>
@@ -10773,7 +10789,7 @@
             </a:pPr>
             <a:fld id="{79B7B28A-94DD-44EC-83BF-F9E9490C49B9}" type="datetime1">
               <a:rPr lang="ru-RU"/>
-              <a:t>02.06.2026</a:t>
+              <a:t>23.06.2026</a:t>
             </a:fld>
             <a:endParaRPr lang="ru-RU"/>
           </a:p>
@@ -10836,7 +10852,7 @@
 </file>
 
 <file path=ppt/slideLayouts/slideLayout6.xml><?xml version="1.0" encoding="utf-8"?>
-<p:sldLayout xmlns:a="http://schemas.openxmlformats.org/drawingml/2006/main" xmlns:r="http://schemas.openxmlformats.org/officeDocument/2006/relationships" xmlns:p="http://schemas.openxmlformats.org/presentationml/2006/main" xmlns:m="http://schemas.openxmlformats.org/officeDocument/2006/math" xmlns:w="http://schemas.openxmlformats.org/wordprocessingml/2006/main" matchingName="" preserve="1" showMasterPhAnim="0" showMasterSp="1" type="titleOnly" userDrawn="1">
+<p:sldLayout xmlns:a="http://schemas.openxmlformats.org/drawingml/2006/main" xmlns:r="http://schemas.openxmlformats.org/officeDocument/2006/relationships" xmlns:p="http://schemas.openxmlformats.org/presentationml/2006/main" showMasterPhAnim="0" type="titleOnly" preserve="1" userDrawn="1">
   <p:cSld name="Только заголовок">
     <p:spTree>
       <p:nvGrpSpPr>
@@ -10898,7 +10914,7 @@
             </a:pPr>
             <a:fld id="{19CBEF87-A1CE-4AD3-B312-24E4060B669E}" type="datetime1">
               <a:rPr lang="ru-RU"/>
-              <a:t>02.06.2026</a:t>
+              <a:t>23.06.2026</a:t>
             </a:fld>
             <a:endParaRPr lang="ru-RU"/>
           </a:p>
@@ -10961,7 +10977,7 @@
 </file>
 
 <file path=ppt/slideLayouts/slideLayout7.xml><?xml version="1.0" encoding="utf-8"?>
-<p:sldLayout xmlns:a="http://schemas.openxmlformats.org/drawingml/2006/main" xmlns:r="http://schemas.openxmlformats.org/officeDocument/2006/relationships" xmlns:p="http://schemas.openxmlformats.org/presentationml/2006/main" xmlns:m="http://schemas.openxmlformats.org/officeDocument/2006/math" xmlns:w="http://schemas.openxmlformats.org/wordprocessingml/2006/main" matchingName="" preserve="1" showMasterPhAnim="0" showMasterSp="1" type="blank" userDrawn="1">
+<p:sldLayout xmlns:a="http://schemas.openxmlformats.org/drawingml/2006/main" xmlns:r="http://schemas.openxmlformats.org/officeDocument/2006/relationships" xmlns:p="http://schemas.openxmlformats.org/presentationml/2006/main" showMasterPhAnim="0" type="blank" preserve="1" userDrawn="1">
   <p:cSld name="Пустой слайд">
     <p:spTree>
       <p:nvGrpSpPr>
@@ -10997,7 +11013,7 @@
             </a:pPr>
             <a:fld id="{C1A3597E-B3B5-450E-90FE-FB59F904A164}" type="datetime1">
               <a:rPr lang="ru-RU"/>
-              <a:t>02.06.2026</a:t>
+              <a:t>23.06.2026</a:t>
             </a:fld>
             <a:endParaRPr lang="ru-RU"/>
           </a:p>
@@ -11060,7 +11076,7 @@
 </file>
 
 <file path=ppt/slideLayouts/slideLayout8.xml><?xml version="1.0" encoding="utf-8"?>
-<p:sldLayout xmlns:a="http://schemas.openxmlformats.org/drawingml/2006/main" xmlns:r="http://schemas.openxmlformats.org/officeDocument/2006/relationships" xmlns:p="http://schemas.openxmlformats.org/presentationml/2006/main" xmlns:m="http://schemas.openxmlformats.org/officeDocument/2006/math" xmlns:w="http://schemas.openxmlformats.org/wordprocessingml/2006/main" matchingName="" preserve="1" showMasterPhAnim="0" showMasterSp="1" type="objTx" userDrawn="1">
+<p:sldLayout xmlns:a="http://schemas.openxmlformats.org/drawingml/2006/main" xmlns:r="http://schemas.openxmlformats.org/officeDocument/2006/relationships" xmlns:p="http://schemas.openxmlformats.org/presentationml/2006/main" showMasterPhAnim="0" type="objTx" preserve="1" userDrawn="1">
   <p:cSld name="Объект с подписью">
     <p:spTree>
       <p:nvGrpSpPr>
@@ -11298,7 +11314,7 @@
             </a:pPr>
             <a:fld id="{51C926F4-5876-4D6C-B300-7031A7F64CBB}" type="datetime1">
               <a:rPr lang="ru-RU"/>
-              <a:t>02.06.2026</a:t>
+              <a:t>23.06.2026</a:t>
             </a:fld>
             <a:endParaRPr lang="ru-RU"/>
           </a:p>
@@ -11361,7 +11377,7 @@
 </file>
 
 <file path=ppt/slideLayouts/slideLayout9.xml><?xml version="1.0" encoding="utf-8"?>
-<p:sldLayout xmlns:a="http://schemas.openxmlformats.org/drawingml/2006/main" xmlns:r="http://schemas.openxmlformats.org/officeDocument/2006/relationships" xmlns:p="http://schemas.openxmlformats.org/presentationml/2006/main" xmlns:m="http://schemas.openxmlformats.org/officeDocument/2006/math" xmlns:w="http://schemas.openxmlformats.org/wordprocessingml/2006/main" matchingName="" preserve="1" showMasterPhAnim="0" showMasterSp="1" type="picTx" userDrawn="1">
+<p:sldLayout xmlns:a="http://schemas.openxmlformats.org/drawingml/2006/main" xmlns:r="http://schemas.openxmlformats.org/officeDocument/2006/relationships" xmlns:p="http://schemas.openxmlformats.org/presentationml/2006/main" showMasterPhAnim="0" type="picTx" preserve="1" userDrawn="1">
   <p:cSld name="Рисунок с подписью">
     <p:spTree>
       <p:nvGrpSpPr>
@@ -11564,7 +11580,7 @@
             </a:pPr>
             <a:fld id="{5C357E52-6772-44D2-9B1A-046730665B12}" type="datetime1">
               <a:rPr lang="ru-RU"/>
-              <a:t>02.06.2026</a:t>
+              <a:t>23.06.2026</a:t>
             </a:fld>
             <a:endParaRPr lang="ru-RU"/>
           </a:p>
@@ -11627,8 +11643,8 @@
 </file>
 
 <file path=ppt/slideMasters/slideMaster1.xml><?xml version="1.0" encoding="utf-8"?>
-<p:sldMaster xmlns:a="http://schemas.openxmlformats.org/drawingml/2006/main" xmlns:r="http://schemas.openxmlformats.org/officeDocument/2006/relationships" xmlns:p="http://schemas.openxmlformats.org/presentationml/2006/main" xmlns:m="http://schemas.openxmlformats.org/officeDocument/2006/math" xmlns:w="http://schemas.openxmlformats.org/wordprocessingml/2006/main" preserve="0">
-  <p:cSld name="">
+<p:sldMaster xmlns:a="http://schemas.openxmlformats.org/drawingml/2006/main" xmlns:r="http://schemas.openxmlformats.org/officeDocument/2006/relationships" xmlns:p="http://schemas.openxmlformats.org/presentationml/2006/main">
+  <p:cSld>
     <p:bg>
       <p:bgRef idx="1001">
         <a:schemeClr val="bg1"/>
@@ -11798,7 +11814,7 @@
             </a:pPr>
             <a:fld id="{E01D4F3A-ABC6-43DF-ACA3-965C94B45EAB}" type="datetime1">
               <a:rPr lang="ru-RU"/>
-              <a:t>02.06.2026</a:t>
+              <a:t>23.06.2026</a:t>
             </a:fld>
             <a:endParaRPr lang="ru-RU"/>
           </a:p>
@@ -11921,7 +11937,7 @@
     <p:sldLayoutId id="2147483675" r:id="rId27"/>
     <p:sldLayoutId id="2147483676" r:id="rId28"/>
   </p:sldLayoutIdLst>
-  <p:hf dt="0" ftr="0" hdr="0" sldNum="1"/>
+  <p:hf hdr="0" ftr="0" dt="0"/>
   <p:txStyles>
     <p:titleStyle>
       <a:lvl1pPr algn="l" defTabSz="914400" rtl="0">
@@ -12206,10 +12222,10 @@
 </file>
 
 <file path=ppt/slides/slide1.xml><?xml version="1.0" encoding="utf-8"?>
-<p:sld xmlns:a="http://schemas.openxmlformats.org/drawingml/2006/main" xmlns:r="http://schemas.openxmlformats.org/officeDocument/2006/relationships" xmlns:p="http://schemas.openxmlformats.org/presentationml/2006/main" xmlns:m="http://schemas.openxmlformats.org/officeDocument/2006/math" xmlns:w="http://schemas.openxmlformats.org/wordprocessingml/2006/main" xmlns:mc="http://schemas.openxmlformats.org/markup-compatibility/2006" showMasterPhAnim="0" showMasterSp="1" show="1">
-  <p:cSld name="">
+<p:sld xmlns:a="http://schemas.openxmlformats.org/drawingml/2006/main" xmlns:r="http://schemas.openxmlformats.org/officeDocument/2006/relationships" xmlns:p="http://schemas.openxmlformats.org/presentationml/2006/main" showMasterPhAnim="0">
+  <p:cSld>
     <p:bg>
-      <p:bgPr shadeToTitle="0">
+      <p:bgPr>
         <a:gradFill>
           <a:gsLst>
             <a:gs pos="0">
@@ -12239,6 +12255,7 @@
           </a:gsLst>
           <a:lin ang="5400000" scaled="1"/>
         </a:gradFill>
+        <a:effectLst/>
       </p:bgPr>
     </p:bg>
     <p:spTree>
@@ -12262,7 +12279,7 @@
           <p:nvPr/>
         </p:nvSpPr>
         <p:spPr bwMode="auto">
-          <a:xfrm flipH="0" flipV="0">
+          <a:xfrm>
             <a:off x="0" y="246891"/>
             <a:ext cx="12191999" cy="4221198"/>
           </a:xfrm>
@@ -12312,7 +12329,7 @@
           <p:nvPr/>
         </p:nvSpPr>
         <p:spPr bwMode="auto">
-          <a:xfrm flipH="0" flipV="0">
+          <a:xfrm>
             <a:off x="0" y="5021125"/>
             <a:ext cx="12191999" cy="1646373"/>
           </a:xfrm>
@@ -12386,15 +12403,7 @@
                   <a:schemeClr val="bg1"/>
                 </a:solidFill>
               </a:rPr>
-              <a:t>Разработка </a:t>
-            </a:r>
-            <a:r>
-              <a:rPr lang="ru-RU" sz="3200" b="1">
-                <a:solidFill>
-                  <a:schemeClr val="bg1"/>
-                </a:solidFill>
-              </a:rPr>
-              <a:t>ядра упрощенного графического ускорителя: </a:t>
+              <a:t>Разработка ядра упрощенного графического ускорителя: </a:t>
             </a:r>
             <a:r>
               <a:rPr lang="en-US" sz="3200" b="1">
@@ -12410,15 +12419,7 @@
                   <a:schemeClr val="bg1"/>
                 </a:solidFill>
               </a:rPr>
-              <a:t>модел</a:t>
-            </a:r>
-            <a:r>
-              <a:rPr lang="ru-RU" sz="3200" b="1">
-                <a:solidFill>
-                  <a:schemeClr val="bg1"/>
-                </a:solidFill>
-              </a:rPr>
-              <a:t>ь</a:t>
+              <a:t>модель</a:t>
             </a:r>
             <a:endParaRPr b="1">
               <a:solidFill>
@@ -12445,8 +12446,8 @@
           </a:xfrm>
         </p:spPr>
         <p:txBody>
-          <a:bodyPr vertOverflow="overflow" horzOverflow="overflow" vert="horz" wrap="square" lIns="91440" tIns="45720" rIns="91440" bIns="45720" numCol="1" spcCol="0" rtlCol="0" fromWordArt="0" anchor="t" anchorCtr="0" forceAA="0" upright="0" compatLnSpc="0">
-            <a:normAutofit fontScale="55000" lnSpcReduction="9000"/>
+          <a:bodyPr vertOverflow="overflow" horzOverflow="overflow" vert="horz" wrap="square" lIns="91440" tIns="45720" rIns="91440" bIns="45720" numCol="1" spcCol="0" rtlCol="0" fromWordArt="0" anchor="t" anchorCtr="0" forceAA="0" compatLnSpc="0">
+            <a:normAutofit fontScale="62500" lnSpcReduction="19000"/>
           </a:bodyPr>
           <a:lstStyle/>
           <a:p>
@@ -12516,7 +12517,7 @@
           <p:nvPr/>
         </p:nvSpPr>
         <p:spPr bwMode="auto">
-          <a:xfrm flipH="0" flipV="0">
+          <a:xfrm>
             <a:off x="1644243" y="383435"/>
             <a:ext cx="8345667" cy="766221"/>
           </a:xfrm>
@@ -12578,7 +12579,7 @@
           <p:nvPr/>
         </p:nvSpPr>
         <p:spPr bwMode="auto">
-          <a:xfrm flipH="0" flipV="0">
+          <a:xfrm>
             <a:off x="1644243" y="1149656"/>
             <a:ext cx="8345667" cy="766220"/>
           </a:xfrm>
@@ -12640,7 +12641,7 @@
           <p:nvPr/>
         </p:nvSpPr>
         <p:spPr bwMode="auto">
-          <a:xfrm flipH="0" flipV="0">
+          <a:xfrm>
             <a:off x="1644243" y="3544760"/>
             <a:ext cx="8345667" cy="766220"/>
           </a:xfrm>
@@ -12683,14 +12684,6 @@
               </a:rPr>
               <a:t>Магистерская диссертация</a:t>
             </a:r>
-            <a:endParaRPr lang="ru-RU" sz="1600" b="0" i="0" u="none">
-              <a:solidFill>
-                <a:schemeClr val="bg1"/>
-              </a:solidFill>
-              <a:latin typeface="Trebuchet MS"/>
-              <a:ea typeface="Trebuchet MS"/>
-              <a:cs typeface="Trebuchet MS"/>
-            </a:endParaRPr>
           </a:p>
           <a:p>
             <a:pPr>
@@ -12707,14 +12700,6 @@
               </a:rPr>
               <a:t>Направление 01.04.02 Прикладная математика и информатика</a:t>
             </a:r>
-            <a:endParaRPr lang="ru-RU" sz="1600" b="0" i="0" u="none">
-              <a:solidFill>
-                <a:schemeClr val="bg1"/>
-              </a:solidFill>
-              <a:latin typeface="Trebuchet MS"/>
-              <a:ea typeface="Trebuchet MS"/>
-              <a:cs typeface="Trebuchet MS"/>
-            </a:endParaRPr>
           </a:p>
         </p:txBody>
       </p:sp>
@@ -12727,7 +12712,7 @@
           <p:nvPr/>
         </p:nvSpPr>
         <p:spPr bwMode="auto">
-          <a:xfrm flipH="0" flipV="0">
+          <a:xfrm>
             <a:off x="5170877" y="5951875"/>
             <a:ext cx="1850245" cy="630957"/>
           </a:xfrm>
@@ -12785,11 +12770,11 @@
   <p:clrMapOvr>
     <a:masterClrMapping/>
   </p:clrMapOvr>
-  <mc:AlternateContent xmlns:mc="http://schemas.openxmlformats.org/markup-compatibility/2006">
-    <mc:Choice xmlns:p159="http://schemas.microsoft.com/office/powerpoint/2015/09/main" xmlns:p14="http://schemas.microsoft.com/office/powerpoint/2010/main" Requires="p159">
-      <p:transition p14:dur="500" advClick="1"/>
+  <mc:AlternateContent xmlns:mc="http://schemas.openxmlformats.org/markup-compatibility/2006" xmlns:p159="http://schemas.microsoft.com/office/powerpoint/2015/09/main">
+    <mc:Choice Requires="p159">
+      <p:transition/>
     </mc:Choice>
-    <mc:Fallback>
+    <mc:Fallback xmlns:w="http://schemas.openxmlformats.org/wordprocessingml/2006/main" xmlns:m="http://schemas.openxmlformats.org/officeDocument/2006/math" xmlns="">
       <p:transition advClick="1"/>
     </mc:Fallback>
   </mc:AlternateContent>
@@ -12797,10 +12782,10 @@
 </file>
 
 <file path=ppt/slides/slide10.xml><?xml version="1.0" encoding="utf-8"?>
-<p:sld xmlns:a="http://schemas.openxmlformats.org/drawingml/2006/main" xmlns:r="http://schemas.openxmlformats.org/officeDocument/2006/relationships" xmlns:p="http://schemas.openxmlformats.org/presentationml/2006/main" xmlns:m="http://schemas.openxmlformats.org/officeDocument/2006/math" xmlns:w="http://schemas.openxmlformats.org/wordprocessingml/2006/main" xmlns:mc="http://schemas.openxmlformats.org/markup-compatibility/2006" showMasterPhAnim="0" showMasterSp="1" show="1">
-  <p:cSld name="">
+<p:sld xmlns:a="http://schemas.openxmlformats.org/drawingml/2006/main" xmlns:r="http://schemas.openxmlformats.org/officeDocument/2006/relationships" xmlns:p="http://schemas.openxmlformats.org/presentationml/2006/main" showMasterPhAnim="0">
+  <p:cSld>
     <p:bg>
-      <p:bgPr shadeToTitle="0">
+      <p:bgPr>
         <a:gradFill>
           <a:gsLst>
             <a:gs pos="0">
@@ -12830,6 +12815,7 @@
           </a:gsLst>
           <a:lin ang="13500000" scaled="1"/>
         </a:gradFill>
+        <a:effectLst/>
       </p:bgPr>
     </p:bg>
     <p:spTree>
@@ -12857,13 +12843,13 @@
           </p:nvPr>
         </p:nvSpPr>
         <p:spPr bwMode="auto">
-          <a:xfrm flipH="0" flipV="0">
+          <a:xfrm>
             <a:off x="66674" y="1350173"/>
             <a:ext cx="4134825" cy="5142700"/>
           </a:xfrm>
         </p:spPr>
         <p:txBody>
-          <a:bodyPr vertOverflow="overflow" horzOverflow="overflow" vert="horz" wrap="square" lIns="91440" tIns="45720" rIns="91440" bIns="45720" numCol="1" spcCol="0" rtlCol="0" fromWordArt="0" anchor="t" anchorCtr="0" forceAA="0" upright="0" compatLnSpc="0">
+          <a:bodyPr vertOverflow="overflow" horzOverflow="overflow" vert="horz" wrap="square" lIns="91440" tIns="45720" rIns="91440" bIns="45720" numCol="1" spcCol="0" rtlCol="0" fromWordArt="0" anchor="t" anchorCtr="0" forceAA="0" compatLnSpc="0">
             <a:normAutofit/>
           </a:bodyPr>
           <a:lstStyle/>
@@ -12873,11 +12859,7 @@
             </a:pPr>
             <a:r>
               <a:rPr lang="ru-RU" sz="1600"/>
-              <a:t>Вычислительный </a:t>
-            </a:r>
-            <a:r>
-              <a:rPr lang="ru-RU" sz="1600"/>
-              <a:t>блок </a:t>
+              <a:t>Вычислительный блок </a:t>
             </a:r>
             <a:r>
               <a:rPr lang="en-US" sz="1600"/>
@@ -12885,11 +12867,7 @@
             </a:r>
             <a:r>
               <a:rPr lang="ru-RU" sz="1600"/>
-              <a:t>обрабатывает вещественные и целочисленные данные из регистрового файла</a:t>
-            </a:r>
-            <a:r>
-              <a:rPr lang="ru-RU" sz="1600"/>
-              <a:t> (</a:t>
+              <a:t>обрабатывает вещественные и целочисленные данные из регистрового файла (</a:t>
             </a:r>
             <a:r>
               <a:rPr lang="en-US" sz="1600"/>
@@ -12897,11 +12875,7 @@
             </a:r>
             <a:r>
               <a:rPr lang="ru-RU" sz="1600"/>
-              <a:t>) и сохраняет их обратно</a:t>
-            </a:r>
-            <a:r>
-              <a:rPr lang="ru-RU" sz="1600"/>
-              <a:t>;</a:t>
+              <a:t>) и сохраняет их обратно;</a:t>
             </a:r>
             <a:endParaRPr sz="1600"/>
           </a:p>
@@ -12997,7 +12971,7 @@
                 </a:solidFill>
                 <a:latin typeface="Trebuchet MS"/>
               </a:rPr>
-              <a:t>8</a:t>
+              <a:t>10</a:t>
             </a:fld>
             <a:endParaRPr lang="ru-RU" sz="1800">
               <a:solidFill>
@@ -13162,7 +13136,7 @@
       </p:sp>
       <p:pic>
         <p:nvPicPr>
-          <p:cNvPr id="672231900" name=""/>
+          <p:cNvPr id="672231900" name="Рисунок 672231899"/>
           <p:cNvPicPr>
             <a:picLocks noChangeAspect="1"/>
           </p:cNvPicPr>
@@ -13179,7 +13153,7 @@
           <a:stretch/>
         </p:blipFill>
         <p:spPr bwMode="auto">
-          <a:xfrm flipH="0" flipV="0">
+          <a:xfrm>
             <a:off x="5207840" y="1443556"/>
             <a:ext cx="5541424" cy="5157668"/>
           </a:xfrm>
@@ -13193,11 +13167,11 @@
   <p:clrMapOvr>
     <a:masterClrMapping/>
   </p:clrMapOvr>
-  <mc:AlternateContent xmlns:mc="http://schemas.openxmlformats.org/markup-compatibility/2006">
-    <mc:Choice xmlns:p159="http://schemas.microsoft.com/office/powerpoint/2015/09/main" xmlns:p14="http://schemas.microsoft.com/office/powerpoint/2010/main" Requires="p159">
-      <p:transition p14:dur="500" advClick="1"/>
+  <mc:AlternateContent xmlns:mc="http://schemas.openxmlformats.org/markup-compatibility/2006" xmlns:p159="http://schemas.microsoft.com/office/powerpoint/2015/09/main">
+    <mc:Choice Requires="p159">
+      <p:transition/>
     </mc:Choice>
-    <mc:Fallback>
+    <mc:Fallback xmlns:w="http://schemas.openxmlformats.org/wordprocessingml/2006/main" xmlns:m="http://schemas.openxmlformats.org/officeDocument/2006/math" xmlns="">
       <p:transition advClick="1"/>
     </mc:Fallback>
   </mc:AlternateContent>
@@ -13205,10 +13179,10 @@
 </file>
 
 <file path=ppt/slides/slide11.xml><?xml version="1.0" encoding="utf-8"?>
-<p:sld xmlns:a="http://schemas.openxmlformats.org/drawingml/2006/main" xmlns:r="http://schemas.openxmlformats.org/officeDocument/2006/relationships" xmlns:p="http://schemas.openxmlformats.org/presentationml/2006/main" xmlns:m="http://schemas.openxmlformats.org/officeDocument/2006/math" xmlns:w="http://schemas.openxmlformats.org/wordprocessingml/2006/main" xmlns:mc="http://schemas.openxmlformats.org/markup-compatibility/2006" showMasterPhAnim="0" showMasterSp="1" show="1">
-  <p:cSld name="">
+<p:sld xmlns:a="http://schemas.openxmlformats.org/drawingml/2006/main" xmlns:r="http://schemas.openxmlformats.org/officeDocument/2006/relationships" xmlns:p="http://schemas.openxmlformats.org/presentationml/2006/main" showMasterPhAnim="0">
+  <p:cSld>
     <p:bg>
-      <p:bgPr shadeToTitle="0">
+      <p:bgPr>
         <a:gradFill>
           <a:gsLst>
             <a:gs pos="0">
@@ -13238,6 +13212,7 @@
           </a:gsLst>
           <a:lin ang="13500000" scaled="1"/>
         </a:gradFill>
+        <a:effectLst/>
       </p:bgPr>
     </p:bg>
     <p:spTree>
@@ -13265,13 +13240,13 @@
           </p:nvPr>
         </p:nvSpPr>
         <p:spPr bwMode="auto">
-          <a:xfrm flipH="0" flipV="0">
+          <a:xfrm>
             <a:off x="208734" y="1552574"/>
             <a:ext cx="4736810" cy="4940299"/>
           </a:xfrm>
         </p:spPr>
         <p:txBody>
-          <a:bodyPr vertOverflow="overflow" horzOverflow="overflow" vert="horz" wrap="square" lIns="91440" tIns="45720" rIns="91440" bIns="45720" numCol="1" spcCol="0" rtlCol="0" fromWordArt="0" anchor="t" anchorCtr="0" forceAA="0" upright="0" compatLnSpc="0">
+          <a:bodyPr vertOverflow="overflow" horzOverflow="overflow" vert="horz" wrap="square" lIns="91440" tIns="45720" rIns="91440" bIns="45720" numCol="1" spcCol="0" rtlCol="0" fromWordArt="0" anchor="t" anchorCtr="0" forceAA="0" compatLnSpc="0">
             <a:normAutofit/>
           </a:bodyPr>
           <a:lstStyle/>
@@ -13307,11 +13282,7 @@
             </a:r>
             <a:r>
               <a:rPr lang="ru-RU"/>
-              <a:t> данные</a:t>
-            </a:r>
-            <a:r>
-              <a:rPr lang="ru-RU"/>
-              <a:t>;</a:t>
+              <a:t> данные;</a:t>
             </a:r>
             <a:endParaRPr/>
           </a:p>
@@ -13321,11 +13292,7 @@
             </a:pPr>
             <a:r>
               <a:rPr lang="ru-RU"/>
-              <a:t>Работает </a:t>
-            </a:r>
-            <a:r>
-              <a:rPr lang="ru-RU"/>
-              <a:t>только при получении </a:t>
+              <a:t>Работает только при получении </a:t>
             </a:r>
             <a:r>
               <a:rPr lang="en-US"/>
@@ -13333,11 +13300,7 @@
             </a:r>
             <a:r>
               <a:rPr lang="ru-RU"/>
-              <a:t>инструкции</a:t>
-            </a:r>
-            <a:r>
-              <a:rPr lang="ru-RU"/>
-              <a:t>.</a:t>
+              <a:t>инструкции.</a:t>
             </a:r>
             <a:endParaRPr/>
           </a:p>
@@ -13383,7 +13346,7 @@
                 </a:solidFill>
                 <a:latin typeface="Trebuchet MS"/>
               </a:rPr>
-              <a:t>9</a:t>
+              <a:t>11</a:t>
             </a:fld>
             <a:endParaRPr lang="ru-RU" sz="1800">
               <a:solidFill>
@@ -13533,7 +13496,7 @@
       </p:sp>
       <p:pic>
         <p:nvPicPr>
-          <p:cNvPr id="1840929737" name=""/>
+          <p:cNvPr id="1840929737" name="Рисунок 1840929736"/>
           <p:cNvPicPr>
             <a:picLocks noChangeAspect="1"/>
           </p:cNvPicPr>
@@ -13550,7 +13513,7 @@
           <a:stretch/>
         </p:blipFill>
         <p:spPr bwMode="auto">
-          <a:xfrm flipH="0" flipV="0">
+          <a:xfrm>
             <a:off x="5025437" y="1481884"/>
             <a:ext cx="7175859" cy="5010990"/>
           </a:xfrm>
@@ -13564,11 +13527,11 @@
   <p:clrMapOvr>
     <a:masterClrMapping/>
   </p:clrMapOvr>
-  <mc:AlternateContent xmlns:mc="http://schemas.openxmlformats.org/markup-compatibility/2006">
-    <mc:Choice xmlns:p159="http://schemas.microsoft.com/office/powerpoint/2015/09/main" xmlns:p14="http://schemas.microsoft.com/office/powerpoint/2010/main" Requires="p159">
-      <p:transition p14:dur="500" advClick="1"/>
+  <mc:AlternateContent xmlns:mc="http://schemas.openxmlformats.org/markup-compatibility/2006" xmlns:p159="http://schemas.microsoft.com/office/powerpoint/2015/09/main">
+    <mc:Choice Requires="p159">
+      <p:transition/>
     </mc:Choice>
-    <mc:Fallback>
+    <mc:Fallback xmlns:w="http://schemas.openxmlformats.org/wordprocessingml/2006/main" xmlns:m="http://schemas.openxmlformats.org/officeDocument/2006/math" xmlns="">
       <p:transition advClick="1"/>
     </mc:Fallback>
   </mc:AlternateContent>
@@ -13576,10 +13539,10 @@
 </file>
 
 <file path=ppt/slides/slide12.xml><?xml version="1.0" encoding="utf-8"?>
-<p:sld xmlns:a="http://schemas.openxmlformats.org/drawingml/2006/main" xmlns:r="http://schemas.openxmlformats.org/officeDocument/2006/relationships" xmlns:p="http://schemas.openxmlformats.org/presentationml/2006/main" xmlns:m="http://schemas.openxmlformats.org/officeDocument/2006/math" xmlns:w="http://schemas.openxmlformats.org/wordprocessingml/2006/main" xmlns:mc="http://schemas.openxmlformats.org/markup-compatibility/2006" showMasterPhAnim="0" showMasterSp="1" show="1">
-  <p:cSld name="">
+<p:sld xmlns:a="http://schemas.openxmlformats.org/drawingml/2006/main" xmlns:r="http://schemas.openxmlformats.org/officeDocument/2006/relationships" xmlns:p="http://schemas.openxmlformats.org/presentationml/2006/main" showMasterPhAnim="0">
+  <p:cSld>
     <p:bg>
-      <p:bgPr shadeToTitle="0">
+      <p:bgPr>
         <a:gradFill>
           <a:gsLst>
             <a:gs pos="0">
@@ -13609,6 +13572,7 @@
           </a:gsLst>
           <a:lin ang="13500000" scaled="1"/>
         </a:gradFill>
+        <a:effectLst/>
       </p:bgPr>
     </p:bg>
     <p:spTree>
@@ -13636,13 +13600,13 @@
           </p:nvPr>
         </p:nvSpPr>
         <p:spPr bwMode="auto">
-          <a:xfrm flipH="0" flipV="0">
+          <a:xfrm>
             <a:off x="0" y="1350173"/>
             <a:ext cx="5668349" cy="5507825"/>
           </a:xfrm>
         </p:spPr>
         <p:txBody>
-          <a:bodyPr vertOverflow="overflow" horzOverflow="overflow" vert="horz" wrap="square" lIns="91440" tIns="45720" rIns="91440" bIns="45720" numCol="1" spcCol="0" rtlCol="0" fromWordArt="0" anchor="t" anchorCtr="0" forceAA="0" upright="0" compatLnSpc="0">
+          <a:bodyPr vertOverflow="overflow" horzOverflow="overflow" vert="horz" wrap="square" lIns="91440" tIns="45720" rIns="91440" bIns="45720" numCol="1" spcCol="0" rtlCol="0" fromWordArt="0" anchor="t" anchorCtr="0" forceAA="0" compatLnSpc="0">
             <a:normAutofit/>
           </a:bodyPr>
           <a:lstStyle/>
@@ -13652,11 +13616,7 @@
             </a:pPr>
             <a:r>
               <a:rPr lang="ru-RU"/>
-              <a:t>Арбитр </a:t>
-            </a:r>
-            <a:r>
-              <a:rPr lang="ru-RU"/>
-              <a:t>отслеживает запросы к памяти данных от вычислительных блоков;</a:t>
+              <a:t>Арбитр отслеживает запросы к памяти данных от вычислительных блоков;</a:t>
             </a:r>
             <a:endParaRPr/>
           </a:p>
@@ -13680,7 +13640,6 @@
               <a:rPr lang="ru-RU"/>
               <a:t>);</a:t>
             </a:r>
-            <a:endParaRPr lang="ru-RU"/>
           </a:p>
           <a:p>
             <a:pPr>
@@ -13695,29 +13654,7 @@
                 <a:ea typeface="Arial"/>
                 <a:cs typeface="Arial"/>
               </a:rPr>
-              <a:t>Арбитр </a:t>
-            </a:r>
-            <a:r>
-              <a:rPr lang="ru-RU" sz="2800" b="0" i="0" u="none" strike="noStrike" cap="none" spc="0">
-                <a:solidFill>
-                  <a:schemeClr val="tx1"/>
-                </a:solidFill>
-                <a:latin typeface="Calibri"/>
-                <a:ea typeface="Arial"/>
-                <a:cs typeface="Arial"/>
-              </a:rPr>
-              <a:t>управляет </a:t>
-            </a:r>
-            <a:r>
-              <a:rPr lang="ru-RU" sz="2800" b="0" i="0" u="none" strike="noStrike" cap="none" spc="0">
-                <a:solidFill>
-                  <a:schemeClr val="tx1"/>
-                </a:solidFill>
-                <a:latin typeface="Calibri"/>
-                <a:ea typeface="Arial"/>
-                <a:cs typeface="Arial"/>
-              </a:rPr>
-              <a:t>демультиплексором считанных данных и мультиплексором записываемых данных.</a:t>
+              <a:t>Арбитр управляет демультиплексором считанных данных и мультиплексором записываемых данных.</a:t>
             </a:r>
             <a:endParaRPr/>
           </a:p>
@@ -13753,7 +13690,7 @@
                 </a:solidFill>
                 <a:latin typeface="Trebuchet MS"/>
               </a:rPr>
-              <a:t>10</a:t>
+              <a:t>12</a:t>
             </a:fld>
             <a:endParaRPr lang="ru-RU" sz="1800">
               <a:solidFill>
@@ -13895,15 +13832,7 @@
                   <a:schemeClr val="bg1"/>
                 </a:solidFill>
               </a:rPr>
-              <a:t>Интерконнект</a:t>
-            </a:r>
-            <a:r>
-              <a:rPr lang="ru-RU" sz="3600">
-                <a:solidFill>
-                  <a:schemeClr val="bg1"/>
-                </a:solidFill>
-              </a:rPr>
-              <a:t> между </a:t>
+              <a:t>Интерконнект между </a:t>
             </a:r>
             <a:r>
               <a:rPr lang="en-US" sz="3600">
@@ -13931,7 +13860,7 @@
       </p:sp>
       <p:pic>
         <p:nvPicPr>
-          <p:cNvPr id="1014880010" name=""/>
+          <p:cNvPr id="1014880010" name="Рисунок 1014880009"/>
           <p:cNvPicPr>
             <a:picLocks noChangeAspect="1"/>
           </p:cNvPicPr>
@@ -13948,7 +13877,7 @@
           <a:stretch/>
         </p:blipFill>
         <p:spPr bwMode="auto">
-          <a:xfrm flipH="0" flipV="0">
+          <a:xfrm>
             <a:off x="6868500" y="1437959"/>
             <a:ext cx="5268560" cy="5237478"/>
           </a:xfrm>
@@ -13962,11 +13891,11 @@
   <p:clrMapOvr>
     <a:masterClrMapping/>
   </p:clrMapOvr>
-  <mc:AlternateContent xmlns:mc="http://schemas.openxmlformats.org/markup-compatibility/2006">
-    <mc:Choice xmlns:p159="http://schemas.microsoft.com/office/powerpoint/2015/09/main" xmlns:p14="http://schemas.microsoft.com/office/powerpoint/2010/main" Requires="p159">
-      <p:transition p14:dur="500" advClick="1"/>
+  <mc:AlternateContent xmlns:mc="http://schemas.openxmlformats.org/markup-compatibility/2006" xmlns:p159="http://schemas.microsoft.com/office/powerpoint/2015/09/main">
+    <mc:Choice Requires="p159">
+      <p:transition/>
     </mc:Choice>
-    <mc:Fallback>
+    <mc:Fallback xmlns:w="http://schemas.openxmlformats.org/wordprocessingml/2006/main" xmlns:m="http://schemas.openxmlformats.org/officeDocument/2006/math" xmlns="">
       <p:transition advClick="1"/>
     </mc:Fallback>
   </mc:AlternateContent>
@@ -13974,10 +13903,10 @@
 </file>
 
 <file path=ppt/slides/slide13.xml><?xml version="1.0" encoding="utf-8"?>
-<p:sld xmlns:a="http://schemas.openxmlformats.org/drawingml/2006/main" xmlns:r="http://schemas.openxmlformats.org/officeDocument/2006/relationships" xmlns:p="http://schemas.openxmlformats.org/presentationml/2006/main" xmlns:m="http://schemas.openxmlformats.org/officeDocument/2006/math" xmlns:w="http://schemas.openxmlformats.org/wordprocessingml/2006/main" xmlns:mc="http://schemas.openxmlformats.org/markup-compatibility/2006" showMasterPhAnim="0" showMasterSp="1" show="1">
-  <p:cSld name="">
+<p:sld xmlns:a="http://schemas.openxmlformats.org/drawingml/2006/main" xmlns:r="http://schemas.openxmlformats.org/officeDocument/2006/relationships" xmlns:p="http://schemas.openxmlformats.org/presentationml/2006/main" showMasterPhAnim="0">
+  <p:cSld>
     <p:bg>
-      <p:bgPr shadeToTitle="0">
+      <p:bgPr>
         <a:gradFill>
           <a:gsLst>
             <a:gs pos="0">
@@ -14007,6 +13936,7 @@
           </a:gsLst>
           <a:lin ang="13500000" scaled="1"/>
         </a:gradFill>
+        <a:effectLst/>
       </p:bgPr>
     </p:bg>
     <p:spTree>
@@ -14034,13 +13964,13 @@
           </p:nvPr>
         </p:nvSpPr>
         <p:spPr bwMode="auto">
-          <a:xfrm flipH="0" flipV="0">
+          <a:xfrm>
             <a:off x="77173" y="1350172"/>
             <a:ext cx="4826355" cy="5507824"/>
           </a:xfrm>
         </p:spPr>
         <p:txBody>
-          <a:bodyPr vertOverflow="overflow" horzOverflow="overflow" vert="horz" wrap="square" lIns="91440" tIns="45720" rIns="91440" bIns="45720" numCol="1" spcCol="0" rtlCol="0" fromWordArt="0" anchor="t" anchorCtr="0" forceAA="0" upright="0" compatLnSpc="0">
+          <a:bodyPr vertOverflow="overflow" horzOverflow="overflow" vert="horz" wrap="square" lIns="91440" tIns="45720" rIns="91440" bIns="45720" numCol="1" spcCol="0" rtlCol="0" fromWordArt="0" anchor="t" anchorCtr="0" forceAA="0" compatLnSpc="0">
             <a:normAutofit/>
           </a:bodyPr>
           <a:lstStyle/>
@@ -14076,11 +14006,7 @@
             </a:r>
             <a:r>
               <a:rPr lang="ru-RU"/>
-              <a:t> – преобразование инструкций в </a:t>
-            </a:r>
-            <a:r>
-              <a:rPr lang="ru-RU"/>
-              <a:t>управляющие сигналы для исполнительных блоков (</a:t>
+              <a:t> – преобразование инструкций в управляющие сигналы для исполнительных блоков (</a:t>
             </a:r>
             <a:r>
               <a:rPr lang="en-US"/>
@@ -14128,7 +14054,7 @@
                 </a:solidFill>
                 <a:latin typeface="Trebuchet MS"/>
               </a:rPr>
-              <a:t>11</a:t>
+              <a:t>13</a:t>
             </a:fld>
             <a:endParaRPr lang="ru-RU">
               <a:solidFill>
@@ -14282,7 +14208,7 @@
       </p:sp>
       <p:pic>
         <p:nvPicPr>
-          <p:cNvPr id="1786174538" name=""/>
+          <p:cNvPr id="1786174538" name="Рисунок 1786174537"/>
           <p:cNvPicPr>
             <a:picLocks noChangeAspect="1"/>
           </p:cNvPicPr>
@@ -14299,7 +14225,7 @@
           <a:stretch/>
         </p:blipFill>
         <p:spPr bwMode="auto">
-          <a:xfrm flipH="0" flipV="0">
+          <a:xfrm>
             <a:off x="4996910" y="1396865"/>
             <a:ext cx="6875366" cy="5133470"/>
           </a:xfrm>
@@ -14313,11 +14239,11 @@
   <p:clrMapOvr>
     <a:masterClrMapping/>
   </p:clrMapOvr>
-  <mc:AlternateContent xmlns:mc="http://schemas.openxmlformats.org/markup-compatibility/2006">
-    <mc:Choice xmlns:p159="http://schemas.microsoft.com/office/powerpoint/2015/09/main" xmlns:p14="http://schemas.microsoft.com/office/powerpoint/2010/main" Requires="p159">
-      <p:transition p14:dur="500" advClick="1"/>
+  <mc:AlternateContent xmlns:mc="http://schemas.openxmlformats.org/markup-compatibility/2006" xmlns:p159="http://schemas.microsoft.com/office/powerpoint/2015/09/main">
+    <mc:Choice Requires="p159">
+      <p:transition/>
     </mc:Choice>
-    <mc:Fallback>
+    <mc:Fallback xmlns:w="http://schemas.openxmlformats.org/wordprocessingml/2006/main" xmlns:m="http://schemas.openxmlformats.org/officeDocument/2006/math" xmlns="">
       <p:transition advClick="1"/>
     </mc:Fallback>
   </mc:AlternateContent>
@@ -14325,10 +14251,10 @@
 </file>
 
 <file path=ppt/slides/slide14.xml><?xml version="1.0" encoding="utf-8"?>
-<p:sld xmlns:a="http://schemas.openxmlformats.org/drawingml/2006/main" xmlns:r="http://schemas.openxmlformats.org/officeDocument/2006/relationships" xmlns:p="http://schemas.openxmlformats.org/presentationml/2006/main" xmlns:m="http://schemas.openxmlformats.org/officeDocument/2006/math" xmlns:w="http://schemas.openxmlformats.org/wordprocessingml/2006/main" xmlns:mc="http://schemas.openxmlformats.org/markup-compatibility/2006" showMasterPhAnim="0" showMasterSp="1" show="1">
-  <p:cSld name="">
+<p:sld xmlns:a="http://schemas.openxmlformats.org/drawingml/2006/main" xmlns:r="http://schemas.openxmlformats.org/officeDocument/2006/relationships" xmlns:p="http://schemas.openxmlformats.org/presentationml/2006/main" showMasterPhAnim="0">
+  <p:cSld>
     <p:bg>
-      <p:bgPr shadeToTitle="0">
+      <p:bgPr>
         <a:gradFill>
           <a:gsLst>
             <a:gs pos="0">
@@ -14358,6 +14284,7 @@
           </a:gsLst>
           <a:lin ang="13500000" scaled="1"/>
         </a:gradFill>
+        <a:effectLst/>
       </p:bgPr>
     </p:bg>
     <p:spTree>
@@ -14385,13 +14312,13 @@
           </p:nvPr>
         </p:nvSpPr>
         <p:spPr bwMode="auto">
-          <a:xfrm flipH="0" flipV="0">
+          <a:xfrm>
             <a:off x="156445" y="1959773"/>
             <a:ext cx="4816578" cy="3599316"/>
           </a:xfrm>
         </p:spPr>
         <p:txBody>
-          <a:bodyPr vertOverflow="overflow" horzOverflow="overflow" vert="horz" wrap="square" lIns="91440" tIns="45720" rIns="91440" bIns="45720" numCol="1" spcCol="0" rtlCol="0" fromWordArt="0" anchor="t" anchorCtr="0" forceAA="0" upright="0" compatLnSpc="0">
+          <a:bodyPr vertOverflow="overflow" horzOverflow="overflow" vert="horz" wrap="square" lIns="91440" tIns="45720" rIns="91440" bIns="45720" numCol="1" spcCol="0" rtlCol="0" fromWordArt="0" anchor="t" anchorCtr="0" forceAA="0" compatLnSpc="0">
             <a:normAutofit/>
           </a:bodyPr>
           <a:lstStyle/>
@@ -14501,7 +14428,7 @@
                 </a:solidFill>
                 <a:latin typeface="Trebuchet MS"/>
               </a:rPr>
-              <a:t>13</a:t>
+              <a:t>14</a:t>
             </a:fld>
             <a:endParaRPr lang="ru-RU">
               <a:solidFill>
@@ -14653,7 +14580,7 @@
       </p:sp>
       <p:pic>
         <p:nvPicPr>
-          <p:cNvPr id="1113674391" name=""/>
+          <p:cNvPr id="1113674391" name="Рисунок 1113674390"/>
           <p:cNvPicPr>
             <a:picLocks noChangeAspect="1"/>
           </p:cNvPicPr>
@@ -14664,7 +14591,7 @@
           <a:stretch/>
         </p:blipFill>
         <p:spPr bwMode="auto">
-          <a:xfrm flipH="0" flipV="0">
+          <a:xfrm>
             <a:off x="4952470" y="1438274"/>
             <a:ext cx="7184591" cy="4905374"/>
           </a:xfrm>
@@ -14678,11 +14605,11 @@
   <p:clrMapOvr>
     <a:masterClrMapping/>
   </p:clrMapOvr>
-  <mc:AlternateContent xmlns:mc="http://schemas.openxmlformats.org/markup-compatibility/2006">
-    <mc:Choice xmlns:p159="http://schemas.microsoft.com/office/powerpoint/2015/09/main" xmlns:p14="http://schemas.microsoft.com/office/powerpoint/2010/main" Requires="p159">
-      <p:transition p14:dur="500" advClick="1"/>
+  <mc:AlternateContent xmlns:mc="http://schemas.openxmlformats.org/markup-compatibility/2006" xmlns:p159="http://schemas.microsoft.com/office/powerpoint/2015/09/main">
+    <mc:Choice Requires="p159">
+      <p:transition/>
     </mc:Choice>
-    <mc:Fallback>
+    <mc:Fallback xmlns:w="http://schemas.openxmlformats.org/wordprocessingml/2006/main" xmlns:m="http://schemas.openxmlformats.org/officeDocument/2006/math" xmlns="">
       <p:transition advClick="1"/>
     </mc:Fallback>
   </mc:AlternateContent>
@@ -14690,10 +14617,10 @@
 </file>
 
 <file path=ppt/slides/slide15.xml><?xml version="1.0" encoding="utf-8"?>
-<p:sld xmlns:a="http://schemas.openxmlformats.org/drawingml/2006/main" xmlns:r="http://schemas.openxmlformats.org/officeDocument/2006/relationships" xmlns:p="http://schemas.openxmlformats.org/presentationml/2006/main" xmlns:m="http://schemas.openxmlformats.org/officeDocument/2006/math" xmlns:w="http://schemas.openxmlformats.org/wordprocessingml/2006/main" xmlns:mc="http://schemas.openxmlformats.org/markup-compatibility/2006" showMasterPhAnim="0" showMasterSp="1" show="1">
-  <p:cSld name="">
+<p:sld xmlns:a="http://schemas.openxmlformats.org/drawingml/2006/main" xmlns:r="http://schemas.openxmlformats.org/officeDocument/2006/relationships" xmlns:p="http://schemas.openxmlformats.org/presentationml/2006/main" showMasterPhAnim="0">
+  <p:cSld>
     <p:bg>
-      <p:bgPr shadeToTitle="0">
+      <p:bgPr>
         <a:gradFill>
           <a:gsLst>
             <a:gs pos="0">
@@ -14723,6 +14650,7 @@
           </a:gsLst>
           <a:lin ang="13500000" scaled="1"/>
         </a:gradFill>
+        <a:effectLst/>
       </p:bgPr>
     </p:bg>
     <p:spTree>
@@ -14918,7 +14846,7 @@
                 </a:solidFill>
                 <a:latin typeface="Trebuchet MS"/>
               </a:rPr>
-              <a:t>14</a:t>
+              <a:t>15</a:t>
             </a:fld>
             <a:endParaRPr lang="ru-RU">
               <a:solidFill>
@@ -15073,11 +15001,11 @@
   <p:clrMapOvr>
     <a:masterClrMapping/>
   </p:clrMapOvr>
-  <mc:AlternateContent xmlns:mc="http://schemas.openxmlformats.org/markup-compatibility/2006">
-    <mc:Choice xmlns:p159="http://schemas.microsoft.com/office/powerpoint/2015/09/main" xmlns:p14="http://schemas.microsoft.com/office/powerpoint/2010/main" Requires="p159">
-      <p:transition p14:dur="500" advClick="1"/>
+  <mc:AlternateContent xmlns:mc="http://schemas.openxmlformats.org/markup-compatibility/2006" xmlns:p159="http://schemas.microsoft.com/office/powerpoint/2015/09/main">
+    <mc:Choice Requires="p159">
+      <p:transition/>
     </mc:Choice>
-    <mc:Fallback>
+    <mc:Fallback xmlns:w="http://schemas.openxmlformats.org/wordprocessingml/2006/main" xmlns:m="http://schemas.openxmlformats.org/officeDocument/2006/math" xmlns="">
       <p:transition advClick="1"/>
     </mc:Fallback>
   </mc:AlternateContent>
@@ -15085,10 +15013,10 @@
 </file>
 
 <file path=ppt/slides/slide16.xml><?xml version="1.0" encoding="utf-8"?>
-<p:sld xmlns:a="http://schemas.openxmlformats.org/drawingml/2006/main" xmlns:r="http://schemas.openxmlformats.org/officeDocument/2006/relationships" xmlns:p="http://schemas.openxmlformats.org/presentationml/2006/main" xmlns:m="http://schemas.openxmlformats.org/officeDocument/2006/math" xmlns:w="http://schemas.openxmlformats.org/wordprocessingml/2006/main" xmlns:mc="http://schemas.openxmlformats.org/markup-compatibility/2006" showMasterPhAnim="0" showMasterSp="1" show="1">
-  <p:cSld name="">
+<p:sld xmlns:a="http://schemas.openxmlformats.org/drawingml/2006/main" xmlns:r="http://schemas.openxmlformats.org/officeDocument/2006/relationships" xmlns:p="http://schemas.openxmlformats.org/presentationml/2006/main" showMasterPhAnim="0">
+  <p:cSld>
     <p:bg>
-      <p:bgPr shadeToTitle="0">
+      <p:bgPr>
         <a:gradFill>
           <a:gsLst>
             <a:gs pos="0">
@@ -15118,6 +15046,7 @@
           </a:gsLst>
           <a:lin ang="13500000" scaled="1"/>
         </a:gradFill>
+        <a:effectLst/>
       </p:bgPr>
     </p:bg>
     <p:spTree>
@@ -15205,7 +15134,7 @@
                 </a:solidFill>
                 <a:latin typeface="Trebuchet MS"/>
               </a:rPr>
-              <a:t>15</a:t>
+              <a:t>16</a:t>
             </a:fld>
             <a:endParaRPr lang="ru-RU">
               <a:solidFill>
@@ -15360,11 +15289,11 @@
   <p:clrMapOvr>
     <a:masterClrMapping/>
   </p:clrMapOvr>
-  <mc:AlternateContent xmlns:mc="http://schemas.openxmlformats.org/markup-compatibility/2006">
-    <mc:Choice xmlns:p159="http://schemas.microsoft.com/office/powerpoint/2015/09/main" xmlns:p14="http://schemas.microsoft.com/office/powerpoint/2010/main" Requires="p159">
-      <p:transition p14:dur="500" advClick="1"/>
+  <mc:AlternateContent xmlns:mc="http://schemas.openxmlformats.org/markup-compatibility/2006" xmlns:p159="http://schemas.microsoft.com/office/powerpoint/2015/09/main">
+    <mc:Choice Requires="p159">
+      <p:transition/>
     </mc:Choice>
-    <mc:Fallback>
+    <mc:Fallback xmlns:w="http://schemas.openxmlformats.org/wordprocessingml/2006/main" xmlns:m="http://schemas.openxmlformats.org/officeDocument/2006/math" xmlns="">
       <p:transition advClick="1"/>
     </mc:Fallback>
   </mc:AlternateContent>
@@ -15372,10 +15301,10 @@
 </file>
 
 <file path=ppt/slides/slide17.xml><?xml version="1.0" encoding="utf-8"?>
-<p:sld xmlns:a="http://schemas.openxmlformats.org/drawingml/2006/main" xmlns:r="http://schemas.openxmlformats.org/officeDocument/2006/relationships" xmlns:p="http://schemas.openxmlformats.org/presentationml/2006/main" xmlns:m="http://schemas.openxmlformats.org/officeDocument/2006/math" xmlns:w="http://schemas.openxmlformats.org/wordprocessingml/2006/main" xmlns:mc="http://schemas.openxmlformats.org/markup-compatibility/2006" showMasterPhAnim="0" showMasterSp="1" show="1">
-  <p:cSld name="">
+<p:sld xmlns:a="http://schemas.openxmlformats.org/drawingml/2006/main" xmlns:r="http://schemas.openxmlformats.org/officeDocument/2006/relationships" xmlns:p="http://schemas.openxmlformats.org/presentationml/2006/main" showMasterPhAnim="0">
+  <p:cSld>
     <p:bg>
-      <p:bgPr shadeToTitle="0">
+      <p:bgPr>
         <a:gradFill>
           <a:gsLst>
             <a:gs pos="0">
@@ -15405,6 +15334,7 @@
           </a:gsLst>
           <a:lin ang="13500000" scaled="1"/>
         </a:gradFill>
+        <a:effectLst/>
       </p:bgPr>
     </p:bg>
     <p:spTree>
@@ -15477,7 +15407,7 @@
                 </a:solidFill>
                 <a:latin typeface="Trebuchet MS"/>
               </a:rPr>
-              <a:t>15</a:t>
+              <a:t>17</a:t>
             </a:fld>
             <a:endParaRPr lang="ru-RU" sz="1800">
               <a:solidFill>
@@ -15632,11 +15562,11 @@
   <p:clrMapOvr>
     <a:masterClrMapping/>
   </p:clrMapOvr>
-  <mc:AlternateContent xmlns:mc="http://schemas.openxmlformats.org/markup-compatibility/2006">
-    <mc:Choice xmlns:p159="http://schemas.microsoft.com/office/powerpoint/2015/09/main" xmlns:p14="http://schemas.microsoft.com/office/powerpoint/2010/main" Requires="p159">
-      <p:transition p14:dur="500" advClick="1"/>
+  <mc:AlternateContent xmlns:mc="http://schemas.openxmlformats.org/markup-compatibility/2006" xmlns:p159="http://schemas.microsoft.com/office/powerpoint/2015/09/main">
+    <mc:Choice Requires="p159">
+      <p:transition/>
     </mc:Choice>
-    <mc:Fallback>
+    <mc:Fallback xmlns:w="http://schemas.openxmlformats.org/wordprocessingml/2006/main" xmlns:m="http://schemas.openxmlformats.org/officeDocument/2006/math" xmlns="">
       <p:transition advClick="1"/>
     </mc:Fallback>
   </mc:AlternateContent>
@@ -15644,10 +15574,10 @@
 </file>
 
 <file path=ppt/slides/slide18.xml><?xml version="1.0" encoding="utf-8"?>
-<p:sld xmlns:a="http://schemas.openxmlformats.org/drawingml/2006/main" xmlns:r="http://schemas.openxmlformats.org/officeDocument/2006/relationships" xmlns:p="http://schemas.openxmlformats.org/presentationml/2006/main" xmlns:m="http://schemas.openxmlformats.org/officeDocument/2006/math" xmlns:w="http://schemas.openxmlformats.org/wordprocessingml/2006/main" xmlns:mc="http://schemas.openxmlformats.org/markup-compatibility/2006" showMasterPhAnim="0" showMasterSp="1" show="1">
-  <p:cSld name="">
+<p:sld xmlns:a="http://schemas.openxmlformats.org/drawingml/2006/main" xmlns:r="http://schemas.openxmlformats.org/officeDocument/2006/relationships" xmlns:p="http://schemas.openxmlformats.org/presentationml/2006/main" showMasterPhAnim="0">
+  <p:cSld>
     <p:bg>
-      <p:bgPr shadeToTitle="0">
+      <p:bgPr>
         <a:gradFill>
           <a:gsLst>
             <a:gs pos="0">
@@ -15677,6 +15607,7 @@
           </a:gsLst>
           <a:lin ang="5400000" scaled="1"/>
         </a:gradFill>
+        <a:effectLst/>
       </p:bgPr>
     </p:bg>
     <p:spTree>
@@ -15700,7 +15631,7 @@
           <p:nvPr/>
         </p:nvSpPr>
         <p:spPr bwMode="auto">
-          <a:xfrm flipH="0" flipV="0">
+          <a:xfrm>
             <a:off x="0" y="246891"/>
             <a:ext cx="12191999" cy="4221198"/>
           </a:xfrm>
@@ -15750,7 +15681,7 @@
           <p:nvPr/>
         </p:nvSpPr>
         <p:spPr bwMode="auto">
-          <a:xfrm flipH="0" flipV="0">
+          <a:xfrm>
             <a:off x="0" y="5021125"/>
             <a:ext cx="12191999" cy="1646373"/>
           </a:xfrm>
@@ -15824,15 +15755,7 @@
                   <a:schemeClr val="bg1"/>
                 </a:solidFill>
               </a:rPr>
-              <a:t>Разработка </a:t>
-            </a:r>
-            <a:r>
-              <a:rPr lang="ru-RU" sz="3200" b="1">
-                <a:solidFill>
-                  <a:schemeClr val="bg1"/>
-                </a:solidFill>
-              </a:rPr>
-              <a:t>ядра упрощенного графического ускорителя. Разработка </a:t>
+              <a:t>Разработка ядра упрощенного графического ускорителя. Разработка </a:t>
             </a:r>
             <a:r>
               <a:rPr lang="en-US" sz="3200" b="1">
@@ -15875,8 +15798,8 @@
           </a:xfrm>
         </p:spPr>
         <p:txBody>
-          <a:bodyPr vertOverflow="overflow" horzOverflow="overflow" vert="horz" wrap="square" lIns="91440" tIns="45720" rIns="91440" bIns="45720" numCol="1" spcCol="0" rtlCol="0" fromWordArt="0" anchor="t" anchorCtr="0" forceAA="0" upright="0" compatLnSpc="0">
-            <a:normAutofit fontScale="55000" lnSpcReduction="9000"/>
+          <a:bodyPr vertOverflow="overflow" horzOverflow="overflow" vert="horz" wrap="square" lIns="91440" tIns="45720" rIns="91440" bIns="45720" numCol="1" spcCol="0" rtlCol="0" fromWordArt="0" anchor="t" anchorCtr="0" forceAA="0" compatLnSpc="0">
+            <a:normAutofit fontScale="62500" lnSpcReduction="19000"/>
           </a:bodyPr>
           <a:lstStyle/>
           <a:p>
@@ -15946,7 +15869,7 @@
           <p:nvPr/>
         </p:nvSpPr>
         <p:spPr bwMode="auto">
-          <a:xfrm flipH="0" flipV="0">
+          <a:xfrm>
             <a:off x="1644243" y="383435"/>
             <a:ext cx="8345667" cy="766221"/>
           </a:xfrm>
@@ -16008,7 +15931,7 @@
           <p:nvPr/>
         </p:nvSpPr>
         <p:spPr bwMode="auto">
-          <a:xfrm flipH="0" flipV="0">
+          <a:xfrm>
             <a:off x="1644243" y="1149656"/>
             <a:ext cx="8345667" cy="766220"/>
           </a:xfrm>
@@ -16070,7 +15993,7 @@
           <p:nvPr/>
         </p:nvSpPr>
         <p:spPr bwMode="auto">
-          <a:xfrm flipH="0" flipV="0">
+          <a:xfrm>
             <a:off x="1644243" y="3544760"/>
             <a:ext cx="8345667" cy="766220"/>
           </a:xfrm>
@@ -16113,14 +16036,6 @@
               </a:rPr>
               <a:t>Магистерская диссертация</a:t>
             </a:r>
-            <a:endParaRPr lang="ru-RU" sz="1600" b="0" i="0" u="none">
-              <a:solidFill>
-                <a:schemeClr val="bg1"/>
-              </a:solidFill>
-              <a:latin typeface="Trebuchet MS"/>
-              <a:ea typeface="Trebuchet MS"/>
-              <a:cs typeface="Trebuchet MS"/>
-            </a:endParaRPr>
           </a:p>
           <a:p>
             <a:pPr>
@@ -16137,14 +16052,6 @@
               </a:rPr>
               <a:t>Направление 01.04.02 Прикладная математика и информатика</a:t>
             </a:r>
-            <a:endParaRPr lang="ru-RU" sz="1600" b="0" i="0" u="none">
-              <a:solidFill>
-                <a:schemeClr val="bg1"/>
-              </a:solidFill>
-              <a:latin typeface="Trebuchet MS"/>
-              <a:ea typeface="Trebuchet MS"/>
-              <a:cs typeface="Trebuchet MS"/>
-            </a:endParaRPr>
           </a:p>
         </p:txBody>
       </p:sp>
@@ -16157,7 +16064,7 @@
           <p:nvPr/>
         </p:nvSpPr>
         <p:spPr bwMode="auto">
-          <a:xfrm flipH="0" flipV="0">
+          <a:xfrm>
             <a:off x="5170877" y="5951875"/>
             <a:ext cx="1850245" cy="630957"/>
           </a:xfrm>
@@ -16215,11 +16122,11 @@
   <p:clrMapOvr>
     <a:masterClrMapping/>
   </p:clrMapOvr>
-  <mc:AlternateContent xmlns:mc="http://schemas.openxmlformats.org/markup-compatibility/2006">
-    <mc:Choice xmlns:p159="http://schemas.microsoft.com/office/powerpoint/2015/09/main" xmlns:p14="http://schemas.microsoft.com/office/powerpoint/2010/main" Requires="p159">
-      <p:transition p14:dur="500" advClick="1"/>
+  <mc:AlternateContent xmlns:mc="http://schemas.openxmlformats.org/markup-compatibility/2006" xmlns:p159="http://schemas.microsoft.com/office/powerpoint/2015/09/main">
+    <mc:Choice Requires="p159">
+      <p:transition/>
     </mc:Choice>
-    <mc:Fallback>
+    <mc:Fallback xmlns:w="http://schemas.openxmlformats.org/wordprocessingml/2006/main" xmlns:m="http://schemas.openxmlformats.org/officeDocument/2006/math" xmlns="">
       <p:transition advClick="1"/>
     </mc:Fallback>
   </mc:AlternateContent>
@@ -16227,10 +16134,10 @@
 </file>
 
 <file path=ppt/slides/slide2.xml><?xml version="1.0" encoding="utf-8"?>
-<p:sld xmlns:a="http://schemas.openxmlformats.org/drawingml/2006/main" xmlns:r="http://schemas.openxmlformats.org/officeDocument/2006/relationships" xmlns:p="http://schemas.openxmlformats.org/presentationml/2006/main" xmlns:m="http://schemas.openxmlformats.org/officeDocument/2006/math" xmlns:w="http://schemas.openxmlformats.org/wordprocessingml/2006/main" xmlns:mc="http://schemas.openxmlformats.org/markup-compatibility/2006" showMasterPhAnim="0" showMasterSp="1" show="1">
-  <p:cSld name="">
+<p:sld xmlns:a="http://schemas.openxmlformats.org/drawingml/2006/main" xmlns:r="http://schemas.openxmlformats.org/officeDocument/2006/relationships" xmlns:p="http://schemas.openxmlformats.org/presentationml/2006/main" showMasterPhAnim="0">
+  <p:cSld>
     <p:bg>
-      <p:bgPr shadeToTitle="0">
+      <p:bgPr>
         <a:gradFill>
           <a:gsLst>
             <a:gs pos="0">
@@ -16260,6 +16167,7 @@
           </a:gsLst>
           <a:lin ang="13500000" scaled="1"/>
         </a:gradFill>
+        <a:effectLst/>
       </p:bgPr>
     </p:bg>
     <p:spTree>
@@ -16407,11 +16315,6 @@
               </a:rPr>
               <a:t> – это специализированный процессор, оптимизированный для параллельной обработки данных;</a:t>
             </a:r>
-            <a:endParaRPr lang="ru-RU">
-              <a:solidFill>
-                <a:schemeClr val="tx1"/>
-              </a:solidFill>
-            </a:endParaRPr>
           </a:p>
           <a:p>
             <a:pPr>
@@ -16425,11 +16328,6 @@
               </a:rPr>
               <a:t>Графическое ядро – это специализированный микропроцессор, созданный для математических вычислений, обработки изображений и рендеринга;</a:t>
             </a:r>
-            <a:endParaRPr lang="ru-RU">
-              <a:solidFill>
-                <a:schemeClr val="tx1"/>
-              </a:solidFill>
-            </a:endParaRPr>
           </a:p>
           <a:p>
             <a:pPr>
@@ -16491,11 +16389,6 @@
               </a:rPr>
               <a:t>.</a:t>
             </a:r>
-            <a:endParaRPr lang="ru-RU">
-              <a:solidFill>
-                <a:schemeClr val="tx1"/>
-              </a:solidFill>
-            </a:endParaRPr>
           </a:p>
         </p:txBody>
       </p:sp>
@@ -16595,11 +16488,11 @@
   <p:clrMapOvr>
     <a:masterClrMapping/>
   </p:clrMapOvr>
-  <mc:AlternateContent xmlns:mc="http://schemas.openxmlformats.org/markup-compatibility/2006">
-    <mc:Choice xmlns:p159="http://schemas.microsoft.com/office/powerpoint/2015/09/main" xmlns:p14="http://schemas.microsoft.com/office/powerpoint/2010/main" Requires="p159">
-      <p:transition p14:dur="500" advClick="1"/>
+  <mc:AlternateContent xmlns:mc="http://schemas.openxmlformats.org/markup-compatibility/2006" xmlns:p159="http://schemas.microsoft.com/office/powerpoint/2015/09/main">
+    <mc:Choice Requires="p159">
+      <p:transition/>
     </mc:Choice>
-    <mc:Fallback>
+    <mc:Fallback xmlns:w="http://schemas.openxmlformats.org/wordprocessingml/2006/main" xmlns:m="http://schemas.openxmlformats.org/officeDocument/2006/math" xmlns="">
       <p:transition advClick="1"/>
     </mc:Fallback>
   </mc:AlternateContent>
@@ -16607,10 +16500,10 @@
 </file>
 
 <file path=ppt/slides/slide3.xml><?xml version="1.0" encoding="utf-8"?>
-<p:sld xmlns:a="http://schemas.openxmlformats.org/drawingml/2006/main" xmlns:r="http://schemas.openxmlformats.org/officeDocument/2006/relationships" xmlns:p="http://schemas.openxmlformats.org/presentationml/2006/main" xmlns:m="http://schemas.openxmlformats.org/officeDocument/2006/math" xmlns:w="http://schemas.openxmlformats.org/wordprocessingml/2006/main" xmlns:mc="http://schemas.openxmlformats.org/markup-compatibility/2006" showMasterPhAnim="0" showMasterSp="1" show="1">
-  <p:cSld name="">
+<p:sld xmlns:a="http://schemas.openxmlformats.org/drawingml/2006/main" xmlns:r="http://schemas.openxmlformats.org/officeDocument/2006/relationships" xmlns:p="http://schemas.openxmlformats.org/presentationml/2006/main" showMasterPhAnim="0">
+  <p:cSld>
     <p:bg>
-      <p:bgPr shadeToTitle="0">
+      <p:bgPr>
         <a:gradFill>
           <a:gsLst>
             <a:gs pos="0">
@@ -16640,6 +16533,7 @@
           </a:gsLst>
           <a:lin ang="13500000" scaled="1"/>
         </a:gradFill>
+        <a:effectLst/>
       </p:bgPr>
     </p:bg>
     <p:spTree>
@@ -16668,7 +16562,7 @@
         </p:nvSpPr>
         <p:spPr bwMode="auto"/>
         <p:txBody>
-          <a:bodyPr vertOverflow="overflow" horzOverflow="overflow" vert="horz" wrap="square" lIns="91440" tIns="45720" rIns="91440" bIns="45720" numCol="1" spcCol="0" rtlCol="0" fromWordArt="0" anchor="t" anchorCtr="0" forceAA="0" upright="0" compatLnSpc="0">
+          <a:bodyPr vertOverflow="overflow" horzOverflow="overflow" vert="horz" wrap="square" lIns="91440" tIns="45720" rIns="91440" bIns="45720" numCol="1" spcCol="0" rtlCol="0" fromWordArt="0" anchor="t" anchorCtr="0" forceAA="0" compatLnSpc="0">
             <a:normAutofit fontScale="95000" lnSpcReduction="1000"/>
           </a:bodyPr>
           <a:lstStyle/>
@@ -16694,11 +16588,6 @@
               </a:rPr>
               <a:t>позволит:</a:t>
             </a:r>
-            <a:endParaRPr>
-              <a:solidFill>
-                <a:schemeClr val="tx1"/>
-              </a:solidFill>
-            </a:endParaRPr>
           </a:p>
           <a:p>
             <a:pPr>
@@ -16712,21 +16601,8 @@
                   <a:schemeClr val="tx1"/>
                 </a:solidFill>
               </a:rPr>
-              <a:t> Определить</a:t>
-            </a:r>
-            <a:r>
-              <a:rPr>
-                <a:solidFill>
-                  <a:schemeClr val="tx1"/>
-                </a:solidFill>
-              </a:rPr>
-              <a:t> требования для построения минимального графического ядра и минимальный набор инструкций;</a:t>
-            </a:r>
-            <a:endParaRPr>
-              <a:solidFill>
-                <a:schemeClr val="tx1"/>
-              </a:solidFill>
-            </a:endParaRPr>
+              <a:t> Определить требования для построения минимального графического ядра и минимальный набор инструкций;</a:t>
+            </a:r>
           </a:p>
           <a:p>
             <a:pPr>
@@ -16742,11 +16618,6 @@
               </a:rPr>
               <a:t> Разработать модель упрощенного графического ядра, которую можно модернизировать и изучать;</a:t>
             </a:r>
-            <a:endParaRPr>
-              <a:solidFill>
-                <a:schemeClr val="tx1"/>
-              </a:solidFill>
-            </a:endParaRPr>
           </a:p>
           <a:p>
             <a:pPr>
@@ -16776,15 +16647,7 @@
                   <a:schemeClr val="tx1"/>
                 </a:solidFill>
               </a:rPr>
-              <a:t>построения </a:t>
-            </a:r>
-            <a:r>
-              <a:rPr lang="ru-RU">
-                <a:solidFill>
-                  <a:schemeClr val="tx1"/>
-                </a:solidFill>
-              </a:rPr>
-              <a:t>архитектур процессорных систем</a:t>
+              <a:t>построения архитектур процессорных систем</a:t>
             </a:r>
             <a:r>
               <a:rPr>
@@ -16794,11 +16657,6 @@
               </a:rPr>
               <a:t>;</a:t>
             </a:r>
-            <a:endParaRPr>
-              <a:solidFill>
-                <a:schemeClr val="tx1"/>
-              </a:solidFill>
-            </a:endParaRPr>
           </a:p>
           <a:p>
             <a:pPr>
@@ -16814,11 +16672,6 @@
               </a:rPr>
               <a:t> Приблизиться к реализации полноценного графического ядра, а в перспективе и полноценного графического ускорителя.</a:t>
             </a:r>
-            <a:endParaRPr>
-              <a:solidFill>
-                <a:schemeClr val="tx1"/>
-              </a:solidFill>
-            </a:endParaRPr>
           </a:p>
         </p:txBody>
       </p:sp>
@@ -16852,7 +16705,7 @@
                 </a:solidFill>
                 <a:latin typeface="Trebuchet MS"/>
               </a:rPr>
-              <a:t>4</a:t>
+              <a:t>3</a:t>
             </a:fld>
             <a:endParaRPr lang="ru-RU">
               <a:solidFill>
@@ -17007,11 +16860,11 @@
   <p:clrMapOvr>
     <a:masterClrMapping/>
   </p:clrMapOvr>
-  <mc:AlternateContent xmlns:mc="http://schemas.openxmlformats.org/markup-compatibility/2006">
-    <mc:Choice xmlns:p159="http://schemas.microsoft.com/office/powerpoint/2015/09/main" xmlns:p14="http://schemas.microsoft.com/office/powerpoint/2010/main" Requires="p159">
-      <p:transition p14:dur="500" advClick="1"/>
+  <mc:AlternateContent xmlns:mc="http://schemas.openxmlformats.org/markup-compatibility/2006" xmlns:p159="http://schemas.microsoft.com/office/powerpoint/2015/09/main">
+    <mc:Choice Requires="p159">
+      <p:transition/>
     </mc:Choice>
-    <mc:Fallback>
+    <mc:Fallback xmlns:w="http://schemas.openxmlformats.org/wordprocessingml/2006/main" xmlns:m="http://schemas.openxmlformats.org/officeDocument/2006/math" xmlns="">
       <p:transition advClick="1"/>
     </mc:Fallback>
   </mc:AlternateContent>
@@ -17019,10 +16872,10 @@
 </file>
 
 <file path=ppt/slides/slide4.xml><?xml version="1.0" encoding="utf-8"?>
-<p:sld xmlns:a="http://schemas.openxmlformats.org/drawingml/2006/main" xmlns:r="http://schemas.openxmlformats.org/officeDocument/2006/relationships" xmlns:p="http://schemas.openxmlformats.org/presentationml/2006/main" xmlns:m="http://schemas.openxmlformats.org/officeDocument/2006/math" xmlns:w="http://schemas.openxmlformats.org/wordprocessingml/2006/main" xmlns:mc="http://schemas.openxmlformats.org/markup-compatibility/2006" showMasterPhAnim="0" showMasterSp="1" show="1">
-  <p:cSld name="">
+<p:sld xmlns:a="http://schemas.openxmlformats.org/drawingml/2006/main" xmlns:r="http://schemas.openxmlformats.org/officeDocument/2006/relationships" xmlns:p="http://schemas.openxmlformats.org/presentationml/2006/main" showMasterPhAnim="0">
+  <p:cSld>
     <p:bg>
-      <p:bgPr shadeToTitle="0">
+      <p:bgPr>
         <a:gradFill>
           <a:gsLst>
             <a:gs pos="0">
@@ -17052,6 +16905,7 @@
           </a:gsLst>
           <a:lin ang="13500000" scaled="1"/>
         </a:gradFill>
+        <a:effectLst/>
       </p:bgPr>
     </p:bg>
     <p:spTree>
@@ -17211,7 +17065,7 @@
                 </a:solidFill>
                 <a:latin typeface="Trebuchet MS"/>
               </a:rPr>
-              <a:t>3</a:t>
+              <a:t>4</a:t>
             </a:fld>
             <a:endParaRPr lang="ru-RU" sz="1800">
               <a:solidFill>
@@ -17366,11 +17220,11 @@
   <p:clrMapOvr>
     <a:masterClrMapping/>
   </p:clrMapOvr>
-  <mc:AlternateContent xmlns:mc="http://schemas.openxmlformats.org/markup-compatibility/2006">
-    <mc:Choice xmlns:p159="http://schemas.microsoft.com/office/powerpoint/2015/09/main" xmlns:p14="http://schemas.microsoft.com/office/powerpoint/2010/main" Requires="p159">
-      <p:transition p14:dur="500" advClick="1"/>
+  <mc:AlternateContent xmlns:mc="http://schemas.openxmlformats.org/markup-compatibility/2006" xmlns:p159="http://schemas.microsoft.com/office/powerpoint/2015/09/main">
+    <mc:Choice Requires="p159">
+      <p:transition/>
     </mc:Choice>
-    <mc:Fallback>
+    <mc:Fallback xmlns:w="http://schemas.openxmlformats.org/wordprocessingml/2006/main" xmlns:m="http://schemas.openxmlformats.org/officeDocument/2006/math" xmlns="">
       <p:transition advClick="1"/>
     </mc:Fallback>
   </mc:AlternateContent>
@@ -17378,10 +17232,10 @@
 </file>
 
 <file path=ppt/slides/slide5.xml><?xml version="1.0" encoding="utf-8"?>
-<p:sld xmlns:a="http://schemas.openxmlformats.org/drawingml/2006/main" xmlns:r="http://schemas.openxmlformats.org/officeDocument/2006/relationships" xmlns:p="http://schemas.openxmlformats.org/presentationml/2006/main" xmlns:m="http://schemas.openxmlformats.org/officeDocument/2006/math" xmlns:w="http://schemas.openxmlformats.org/wordprocessingml/2006/main" xmlns:mc="http://schemas.openxmlformats.org/markup-compatibility/2006" showMasterPhAnim="0" showMasterSp="1" show="1">
-  <p:cSld name="">
+<p:sld xmlns:a="http://schemas.openxmlformats.org/drawingml/2006/main" xmlns:r="http://schemas.openxmlformats.org/officeDocument/2006/relationships" xmlns:p="http://schemas.openxmlformats.org/presentationml/2006/main" showMasterPhAnim="0">
+  <p:cSld>
     <p:bg>
-      <p:bgPr shadeToTitle="0">
+      <p:bgPr>
         <a:gradFill>
           <a:gsLst>
             <a:gs pos="0">
@@ -17411,6 +17265,7 @@
           </a:gsLst>
           <a:lin ang="13500000" scaled="1"/>
         </a:gradFill>
+        <a:effectLst/>
       </p:bgPr>
     </p:bg>
     <p:spTree>
@@ -17438,7 +17293,7 @@
           </p:nvPr>
         </p:nvSpPr>
         <p:spPr bwMode="auto">
-          <a:xfrm flipH="0" flipV="0">
+          <a:xfrm>
             <a:off x="320620" y="1628766"/>
             <a:ext cx="2592336" cy="4864108"/>
           </a:xfrm>
@@ -17448,8 +17303,8 @@
           <a:noFill/>
         </p:spPr>
         <p:txBody>
-          <a:bodyPr vertOverflow="overflow" horzOverflow="overflow" vert="horz" wrap="square" lIns="91440" tIns="45720" rIns="91440" bIns="45720" numCol="1" spcCol="0" rtlCol="0" fromWordArt="0" anchor="t" anchorCtr="0" forceAA="0" upright="0" compatLnSpc="0">
-            <a:normAutofit fontScale="80000" lnSpcReduction="4000"/>
+          <a:bodyPr vertOverflow="overflow" horzOverflow="overflow" vert="horz" wrap="square" lIns="91440" tIns="45720" rIns="91440" bIns="45720" numCol="1" spcCol="0" rtlCol="0" fromWordArt="0" anchor="t" anchorCtr="0" forceAA="0" compatLnSpc="0">
+            <a:normAutofit fontScale="87500" lnSpcReduction="20000"/>
           </a:bodyPr>
           <a:lstStyle/>
           <a:p>
@@ -17457,17 +17312,14 @@
               <a:defRPr/>
             </a:pPr>
             <a:r>
-              <a:rPr/>
               <a:t>Работа является общим проектом по теме: разработка ядра упрощенного графического ускорителя;</a:t>
             </a:r>
-            <a:endParaRPr/>
-          </a:p>
-          <a:p>
-            <a:pPr>
-              <a:defRPr/>
-            </a:pPr>
-            <a:r>
-              <a:rPr/>
+          </a:p>
+          <a:p>
+            <a:pPr>
+              <a:defRPr/>
+            </a:pPr>
+            <a:r>
               <a:t>В данной работе выполнена конкретная часть проекта: </a:t>
             </a:r>
             <a:r>
@@ -17512,7 +17364,7 @@
                 </a:solidFill>
                 <a:latin typeface="Trebuchet MS"/>
               </a:rPr>
-              <a:t>4</a:t>
+              <a:t>5</a:t>
             </a:fld>
             <a:endParaRPr lang="ru-RU" sz="1800">
               <a:solidFill>
@@ -17664,7 +17516,7 @@
       </p:sp>
       <p:pic>
         <p:nvPicPr>
-          <p:cNvPr id="543394343" name=""/>
+          <p:cNvPr id="543394343" name="Рисунок 543394342"/>
           <p:cNvPicPr>
             <a:picLocks noChangeAspect="1"/>
           </p:cNvPicPr>
@@ -17681,7 +17533,7 @@
           <a:stretch/>
         </p:blipFill>
         <p:spPr bwMode="auto">
-          <a:xfrm flipH="0" flipV="0">
+          <a:xfrm>
             <a:off x="3328593" y="2135569"/>
             <a:ext cx="8156721" cy="3575954"/>
           </a:xfrm>
@@ -17695,11 +17547,11 @@
   <p:clrMapOvr>
     <a:masterClrMapping/>
   </p:clrMapOvr>
-  <mc:AlternateContent xmlns:mc="http://schemas.openxmlformats.org/markup-compatibility/2006">
-    <mc:Choice xmlns:p159="http://schemas.microsoft.com/office/powerpoint/2015/09/main" xmlns:p14="http://schemas.microsoft.com/office/powerpoint/2010/main" Requires="p159">
-      <p:transition p14:dur="500" advClick="1"/>
+  <mc:AlternateContent xmlns:mc="http://schemas.openxmlformats.org/markup-compatibility/2006" xmlns:p159="http://schemas.microsoft.com/office/powerpoint/2015/09/main">
+    <mc:Choice Requires="p159">
+      <p:transition/>
     </mc:Choice>
-    <mc:Fallback>
+    <mc:Fallback xmlns:w="http://schemas.openxmlformats.org/wordprocessingml/2006/main" xmlns:m="http://schemas.openxmlformats.org/officeDocument/2006/math" xmlns="">
       <p:transition advClick="1"/>
     </mc:Fallback>
   </mc:AlternateContent>
@@ -17707,10 +17559,10 @@
 </file>
 
 <file path=ppt/slides/slide6.xml><?xml version="1.0" encoding="utf-8"?>
-<p:sld xmlns:a="http://schemas.openxmlformats.org/drawingml/2006/main" xmlns:r="http://schemas.openxmlformats.org/officeDocument/2006/relationships" xmlns:p="http://schemas.openxmlformats.org/presentationml/2006/main" xmlns:m="http://schemas.openxmlformats.org/officeDocument/2006/math" xmlns:w="http://schemas.openxmlformats.org/wordprocessingml/2006/main" xmlns:mc="http://schemas.openxmlformats.org/markup-compatibility/2006" showMasterPhAnim="0" showMasterSp="1" show="1">
-  <p:cSld name="">
+<p:sld xmlns:a="http://schemas.openxmlformats.org/drawingml/2006/main" xmlns:r="http://schemas.openxmlformats.org/officeDocument/2006/relationships" xmlns:p="http://schemas.openxmlformats.org/presentationml/2006/main" showMasterPhAnim="0">
+  <p:cSld>
     <p:bg>
-      <p:bgPr shadeToTitle="0">
+      <p:bgPr>
         <a:gradFill>
           <a:gsLst>
             <a:gs pos="0">
@@ -17740,6 +17592,7 @@
           </a:gsLst>
           <a:lin ang="13500000" scaled="1"/>
         </a:gradFill>
+        <a:effectLst/>
       </p:bgPr>
     </p:bg>
     <p:spTree>
@@ -17929,14 +17782,14 @@
           </p:nvPr>
         </p:nvSpPr>
         <p:spPr bwMode="auto">
-          <a:xfrm flipH="0" flipV="0">
+          <a:xfrm>
             <a:off x="383823" y="1350173"/>
             <a:ext cx="3684326" cy="2802726"/>
           </a:xfrm>
         </p:spPr>
         <p:txBody>
-          <a:bodyPr vertOverflow="overflow" horzOverflow="overflow" vert="horz" wrap="square" lIns="91440" tIns="45720" rIns="91440" bIns="45720" numCol="1" spcCol="0" rtlCol="0" fromWordArt="0" anchor="t" anchorCtr="0" forceAA="0" upright="0" compatLnSpc="0">
-            <a:normAutofit fontScale="85000" lnSpcReduction="3000"/>
+          <a:bodyPr vertOverflow="overflow" horzOverflow="overflow" vert="horz" wrap="square" lIns="91440" tIns="45720" rIns="91440" bIns="45720" numCol="1" spcCol="0" rtlCol="0" fromWordArt="0" anchor="t" anchorCtr="0" forceAA="0" compatLnSpc="0">
+            <a:normAutofit fontScale="92500" lnSpcReduction="20000"/>
           </a:bodyPr>
           <a:lstStyle/>
           <a:p>
@@ -18019,11 +17872,7 @@
             </a:r>
             <a:r>
               <a:rPr lang="en-US" sz="2000"/>
-              <a:t> (</a:t>
-            </a:r>
-            <a:r>
-              <a:rPr lang="en-US" sz="2000"/>
-              <a:t>INT </a:t>
+              <a:t> (INT </a:t>
             </a:r>
             <a:r>
               <a:rPr lang="ru-RU" sz="2000"/>
@@ -18031,11 +17880,7 @@
             </a:r>
             <a:r>
               <a:rPr lang="en-US" sz="2000"/>
-              <a:t>FP</a:t>
-            </a:r>
-            <a:r>
-              <a:rPr lang="en-US" sz="2000"/>
-              <a:t>);</a:t>
+              <a:t>FP);</a:t>
             </a:r>
             <a:endParaRPr sz="2000"/>
           </a:p>
@@ -18047,11 +17892,7 @@
             </a:pPr>
             <a:r>
               <a:rPr lang="ru-RU" sz="2000"/>
-              <a:t>Блок получения, декодирования и планирования инструкций</a:t>
-            </a:r>
-            <a:r>
-              <a:rPr lang="ru-RU" sz="2000"/>
-              <a:t>;</a:t>
+              <a:t>Блок получения, декодирования и планирования инструкций;</a:t>
             </a:r>
             <a:endParaRPr sz="2000"/>
           </a:p>
@@ -18099,7 +17940,7 @@
                 </a:solidFill>
                 <a:latin typeface="Trebuchet MS"/>
               </a:rPr>
-              <a:t>5</a:t>
+              <a:t>6</a:t>
             </a:fld>
             <a:endParaRPr lang="ru-RU" sz="1800">
               <a:solidFill>
@@ -18123,7 +17964,7 @@
           <a:stretch/>
         </p:blipFill>
         <p:spPr bwMode="auto">
-          <a:xfrm flipH="0" flipV="0">
+          <a:xfrm>
             <a:off x="4152516" y="2208315"/>
             <a:ext cx="7854704" cy="4271176"/>
           </a:xfrm>
@@ -18146,7 +17987,7 @@
       </p:pic>
       <p:pic>
         <p:nvPicPr>
-          <p:cNvPr id="29648412" name=""/>
+          <p:cNvPr id="29648412" name="Рисунок 29648411"/>
           <p:cNvPicPr>
             <a:picLocks noChangeAspect="1"/>
           </p:cNvPicPr>
@@ -18157,7 +17998,7 @@
           <a:stretch/>
         </p:blipFill>
         <p:spPr bwMode="auto">
-          <a:xfrm flipH="0" flipV="0">
+          <a:xfrm>
             <a:off x="383823" y="4250145"/>
             <a:ext cx="3576543" cy="2229347"/>
           </a:xfrm>
@@ -18179,11 +18020,11 @@
   <p:clrMapOvr>
     <a:masterClrMapping/>
   </p:clrMapOvr>
-  <mc:AlternateContent xmlns:mc="http://schemas.openxmlformats.org/markup-compatibility/2006">
-    <mc:Choice xmlns:p159="http://schemas.microsoft.com/office/powerpoint/2015/09/main" xmlns:p14="http://schemas.microsoft.com/office/powerpoint/2010/main" Requires="p159">
-      <p:transition p14:dur="500" advClick="1"/>
+  <mc:AlternateContent xmlns:mc="http://schemas.openxmlformats.org/markup-compatibility/2006" xmlns:p159="http://schemas.microsoft.com/office/powerpoint/2015/09/main">
+    <mc:Choice Requires="p159">
+      <p:transition/>
     </mc:Choice>
-    <mc:Fallback>
+    <mc:Fallback xmlns:w="http://schemas.openxmlformats.org/wordprocessingml/2006/main" xmlns:m="http://schemas.openxmlformats.org/officeDocument/2006/math" xmlns="">
       <p:transition advClick="1"/>
     </mc:Fallback>
   </mc:AlternateContent>
@@ -18191,10 +18032,10 @@
 </file>
 
 <file path=ppt/slides/slide7.xml><?xml version="1.0" encoding="utf-8"?>
-<p:sld xmlns:a="http://schemas.openxmlformats.org/drawingml/2006/main" xmlns:r="http://schemas.openxmlformats.org/officeDocument/2006/relationships" xmlns:p="http://schemas.openxmlformats.org/presentationml/2006/main" xmlns:m="http://schemas.openxmlformats.org/officeDocument/2006/math" xmlns:w="http://schemas.openxmlformats.org/wordprocessingml/2006/main" xmlns:mc="http://schemas.openxmlformats.org/markup-compatibility/2006" showMasterPhAnim="0" showMasterSp="1" show="1">
-  <p:cSld name="">
+<p:sld xmlns:a="http://schemas.openxmlformats.org/drawingml/2006/main" xmlns:r="http://schemas.openxmlformats.org/officeDocument/2006/relationships" xmlns:p="http://schemas.openxmlformats.org/presentationml/2006/main" showMasterPhAnim="0">
+  <p:cSld>
     <p:bg>
-      <p:bgPr shadeToTitle="0">
+      <p:bgPr>
         <a:gradFill>
           <a:gsLst>
             <a:gs pos="0">
@@ -18224,6 +18065,7 @@
           </a:gsLst>
           <a:lin ang="13500000" scaled="1"/>
         </a:gradFill>
+        <a:effectLst/>
       </p:bgPr>
     </p:bg>
     <p:spTree>
@@ -18413,13 +18255,13 @@
           </p:nvPr>
         </p:nvSpPr>
         <p:spPr bwMode="auto">
-          <a:xfrm flipH="0" flipV="0">
+          <a:xfrm>
             <a:off x="285750" y="1444489"/>
             <a:ext cx="6925649" cy="5035002"/>
           </a:xfrm>
         </p:spPr>
         <p:txBody>
-          <a:bodyPr vertOverflow="overflow" horzOverflow="overflow" vert="horz" wrap="square" lIns="91440" tIns="45720" rIns="91440" bIns="45720" numCol="1" spcCol="0" rtlCol="0" fromWordArt="0" anchor="t" anchorCtr="0" forceAA="0" upright="0" compatLnSpc="0">
+          <a:bodyPr vertOverflow="overflow" horzOverflow="overflow" vert="horz" wrap="square" lIns="91440" tIns="45720" rIns="91440" bIns="45720" numCol="1" spcCol="0" rtlCol="0" fromWordArt="0" anchor="t" anchorCtr="0" forceAA="0" compatLnSpc="0">
             <a:normAutofit/>
           </a:bodyPr>
           <a:lstStyle/>
@@ -18431,7 +18273,6 @@
               <a:rPr lang="ru-RU"/>
               <a:t>Общий регистровый файл большого размера для множества ядер;</a:t>
             </a:r>
-            <a:endParaRPr lang="ru-RU"/>
           </a:p>
           <a:p>
             <a:pPr>
@@ -18441,7 +18282,6 @@
               <a:rPr lang="ru-RU"/>
               <a:t>Каждому ядру в регистровом файле выделена своя область;</a:t>
             </a:r>
-            <a:endParaRPr lang="ru-RU"/>
           </a:p>
           <a:p>
             <a:pPr>
@@ -18459,7 +18299,6 @@
               <a:rPr lang="ru-RU"/>
               <a:t>является однопоточным;</a:t>
             </a:r>
-            <a:endParaRPr lang="ru-RU"/>
           </a:p>
           <a:p>
             <a:pPr>
@@ -18497,11 +18336,7 @@
             </a:r>
             <a:r>
               <a:rPr lang="ru-RU"/>
-              <a:t>специализированный ускоритель, в частности для тригонометрических функций</a:t>
-            </a:r>
-            <a:r>
-              <a:rPr lang="ru-RU"/>
-              <a:t>.</a:t>
+              <a:t>специализированный ускоритель, в частности для тригонометрических функций.</a:t>
             </a:r>
             <a:endParaRPr/>
           </a:p>
@@ -18537,7 +18372,7 @@
                 </a:solidFill>
                 <a:latin typeface="Trebuchet MS"/>
               </a:rPr>
-              <a:t>5</a:t>
+              <a:t>7</a:t>
             </a:fld>
             <a:endParaRPr lang="ru-RU" sz="1800">
               <a:solidFill>
@@ -18558,11 +18393,11 @@
         </p:nvPicPr>
         <p:blipFill rotWithShape="1">
           <a:blip r:embed="rId3"/>
-          <a:srcRect l="0" t="0" r="33408" b="0"/>
+          <a:srcRect r="33408"/>
           <a:stretch/>
         </p:blipFill>
         <p:spPr bwMode="auto">
-          <a:xfrm flipH="0" flipV="0">
+          <a:xfrm>
             <a:off x="7284603" y="1568869"/>
             <a:ext cx="4326204" cy="4910622"/>
           </a:xfrm>
@@ -18588,11 +18423,11 @@
   <p:clrMapOvr>
     <a:masterClrMapping/>
   </p:clrMapOvr>
-  <mc:AlternateContent xmlns:mc="http://schemas.openxmlformats.org/markup-compatibility/2006">
-    <mc:Choice xmlns:p159="http://schemas.microsoft.com/office/powerpoint/2015/09/main" xmlns:p14="http://schemas.microsoft.com/office/powerpoint/2010/main" Requires="p159">
-      <p:transition p14:dur="500" advClick="1"/>
+  <mc:AlternateContent xmlns:mc="http://schemas.openxmlformats.org/markup-compatibility/2006" xmlns:p159="http://schemas.microsoft.com/office/powerpoint/2015/09/main">
+    <mc:Choice Requires="p159">
+      <p:transition/>
     </mc:Choice>
-    <mc:Fallback>
+    <mc:Fallback xmlns:w="http://schemas.openxmlformats.org/wordprocessingml/2006/main" xmlns:m="http://schemas.openxmlformats.org/officeDocument/2006/math" xmlns="">
       <p:transition advClick="1"/>
     </mc:Fallback>
   </mc:AlternateContent>
@@ -18600,10 +18435,10 @@
 </file>
 
 <file path=ppt/slides/slide8.xml><?xml version="1.0" encoding="utf-8"?>
-<p:sld xmlns:a="http://schemas.openxmlformats.org/drawingml/2006/main" xmlns:r="http://schemas.openxmlformats.org/officeDocument/2006/relationships" xmlns:p="http://schemas.openxmlformats.org/presentationml/2006/main" xmlns:m="http://schemas.openxmlformats.org/officeDocument/2006/math" xmlns:w="http://schemas.openxmlformats.org/wordprocessingml/2006/main" xmlns:mc="http://schemas.openxmlformats.org/markup-compatibility/2006" showMasterPhAnim="0" showMasterSp="1" show="1">
-  <p:cSld name="">
+<p:sld xmlns:a="http://schemas.openxmlformats.org/drawingml/2006/main" xmlns:r="http://schemas.openxmlformats.org/officeDocument/2006/relationships" xmlns:p="http://schemas.openxmlformats.org/presentationml/2006/main" showMasterPhAnim="0">
+  <p:cSld>
     <p:bg>
-      <p:bgPr shadeToTitle="0">
+      <p:bgPr>
         <a:gradFill>
           <a:gsLst>
             <a:gs pos="0">
@@ -18633,6 +18468,7 @@
           </a:gsLst>
           <a:lin ang="13500000" scaled="1"/>
         </a:gradFill>
+        <a:effectLst/>
       </p:bgPr>
     </p:bg>
     <p:spTree>
@@ -18660,14 +18496,14 @@
           </p:nvPr>
         </p:nvSpPr>
         <p:spPr bwMode="auto">
-          <a:xfrm flipH="0" flipV="0">
+          <a:xfrm>
             <a:off x="-9297" y="1350173"/>
             <a:ext cx="3310846" cy="3599316"/>
           </a:xfrm>
         </p:spPr>
         <p:txBody>
-          <a:bodyPr vertOverflow="overflow" horzOverflow="overflow" vert="horz" wrap="square" lIns="91440" tIns="45720" rIns="91440" bIns="45720" numCol="1" spcCol="0" rtlCol="0" fromWordArt="0" anchor="t" anchorCtr="0" forceAA="0" upright="0" compatLnSpc="0">
-            <a:normAutofit fontScale="90000" lnSpcReduction="2000"/>
+          <a:bodyPr vertOverflow="overflow" horzOverflow="overflow" vert="horz" wrap="square" lIns="91440" tIns="45720" rIns="91440" bIns="45720" numCol="1" spcCol="0" rtlCol="0" fromWordArt="0" anchor="t" anchorCtr="0" forceAA="0" compatLnSpc="0">
+            <a:normAutofit fontScale="97500" lnSpcReduction="12000"/>
           </a:bodyPr>
           <a:lstStyle/>
           <a:p>
@@ -18684,21 +18520,15 @@
             </a:r>
             <a:r>
               <a:rPr lang="ru-RU"/>
-              <a:t>шейдера </a:t>
-            </a:r>
-            <a:r>
-              <a:rPr lang="ru-RU"/>
-              <a:t>из </a:t>
+              <a:t>шейдера из </a:t>
             </a:r>
             <a:r>
               <a:rPr lang="en-US"/>
               <a:t>VKCUBE</a:t>
             </a:r>
             <a:r>
-              <a:rPr/>
               <a:t>;</a:t>
             </a:r>
-            <a:endParaRPr/>
           </a:p>
           <a:p>
             <a:pPr>
@@ -18716,7 +18546,6 @@
               <a:rPr lang="ru-RU"/>
               <a:t>.</a:t>
             </a:r>
-            <a:endParaRPr lang="ru-RU"/>
           </a:p>
         </p:txBody>
       </p:sp>
@@ -18750,7 +18579,7 @@
                 </a:solidFill>
                 <a:latin typeface="Trebuchet MS"/>
               </a:rPr>
-              <a:t>6</a:t>
+              <a:t>8</a:t>
             </a:fld>
             <a:endParaRPr lang="ru-RU" sz="1800">
               <a:solidFill>
@@ -18774,7 +18603,7 @@
           <a:stretch/>
         </p:blipFill>
         <p:spPr bwMode="auto">
-          <a:xfrm flipH="0" flipV="0">
+          <a:xfrm>
             <a:off x="2856290" y="4580893"/>
             <a:ext cx="4981510" cy="2094567"/>
           </a:xfrm>
@@ -18799,19 +18628,24 @@
           </p:cNvPicPr>
           <p:nvPr/>
         </p:nvPicPr>
-        <p:blipFill rotWithShape="1">
+        <p:blipFill>
           <a:blip r:embed="rId4">
             <a:extLst>
+              <a:ext uri="{28A0092B-C50C-407E-A947-70E740481C1C}">
+                <a14:useLocalDpi xmlns:a14="http://schemas.microsoft.com/office/drawing/2010/main" val="0"/>
+              </a:ext>
               <a:ext uri="{96DAC541-7B7A-43D3-8B79-37D633B846F1}">
                 <asvg:svgBlip xmlns:asvg="http://schemas.microsoft.com/office/drawing/2016/SVG/main" r:embed="rId5"/>
               </a:ext>
             </a:extLst>
           </a:blip>
+          <a:srcRect/>
+          <a:stretch/>
         </p:blipFill>
         <p:spPr bwMode="auto">
-          <a:xfrm flipH="0" flipV="0">
-            <a:off x="9204466" y="1593351"/>
-            <a:ext cx="2824299" cy="2035947"/>
+          <a:xfrm>
+            <a:off x="9272601" y="1593351"/>
+            <a:ext cx="2688029" cy="2035947"/>
           </a:xfrm>
           <a:prstGeom prst="rect">
             <a:avLst/>
@@ -18943,8 +18777,8 @@
           </a:xfrm>
         </p:spPr>
         <p:txBody>
-          <a:bodyPr vertOverflow="overflow" horzOverflow="overflow" vert="horz" wrap="square" lIns="91440" tIns="45720" rIns="91440" bIns="45720" numCol="1" spcCol="0" rtlCol="0" fromWordArt="0" anchor="ctr" anchorCtr="0" forceAA="0" upright="0" compatLnSpc="0">
-            <a:normAutofit fontScale="90000" lnSpcReduction="2000"/>
+          <a:bodyPr vertOverflow="overflow" horzOverflow="overflow" vert="horz" wrap="square" lIns="91440" tIns="45720" rIns="91440" bIns="45720" numCol="1" spcCol="0" rtlCol="0" fromWordArt="0" anchor="ctr" anchorCtr="0" forceAA="0" compatLnSpc="0">
+            <a:normAutofit fontScale="90000"/>
           </a:bodyPr>
           <a:lstStyle/>
           <a:p>
@@ -18983,19 +18817,24 @@
           </p:cNvPicPr>
           <p:nvPr/>
         </p:nvPicPr>
-        <p:blipFill rotWithShape="1">
+        <p:blipFill>
           <a:blip r:embed="rId6">
             <a:extLst>
+              <a:ext uri="{28A0092B-C50C-407E-A947-70E740481C1C}">
+                <a14:useLocalDpi xmlns:a14="http://schemas.microsoft.com/office/drawing/2010/main" val="0"/>
+              </a:ext>
               <a:ext uri="{96DAC541-7B7A-43D3-8B79-37D633B846F1}">
                 <asvg:svgBlip xmlns:asvg="http://schemas.microsoft.com/office/drawing/2016/SVG/main" r:embed="rId7"/>
               </a:ext>
             </a:extLst>
           </a:blip>
+          <a:srcRect/>
+          <a:stretch/>
         </p:blipFill>
         <p:spPr bwMode="auto">
-          <a:xfrm flipH="0" flipV="0">
-            <a:off x="8480073" y="5206830"/>
-            <a:ext cx="3548691" cy="1376882"/>
+          <a:xfrm>
+            <a:off x="8672115" y="5206830"/>
+            <a:ext cx="3164607" cy="1376882"/>
           </a:xfrm>
           <a:prstGeom prst="rect">
             <a:avLst/>
@@ -19004,7 +18843,7 @@
       </p:pic>
       <p:pic>
         <p:nvPicPr>
-          <p:cNvPr id="1736709910" name=""/>
+          <p:cNvPr id="1736709910" name="Рисунок 1736709909"/>
           <p:cNvPicPr>
             <a:picLocks noChangeAspect="1"/>
           </p:cNvPicPr>
@@ -19015,7 +18854,7 @@
           <a:stretch/>
         </p:blipFill>
         <p:spPr bwMode="auto">
-          <a:xfrm flipH="0" flipV="0">
+          <a:xfrm>
             <a:off x="3122609" y="1415540"/>
             <a:ext cx="5529106" cy="3009811"/>
           </a:xfrm>
@@ -19034,7 +18873,7 @@
       </p:pic>
       <p:cxnSp>
         <p:nvCxnSpPr>
-          <p:cNvPr id="1511808802" name=""/>
+          <p:cNvPr id="1511808802" name="Прямая соединительная линия 1511808801"/>
           <p:cNvCxnSpPr>
             <a:stCxn id="142624812" idx="3"/>
             <a:endCxn id="1528119454" idx="1"/>
@@ -19042,7 +18881,7 @@
           <p:nvPr/>
         </p:nvCxnSpPr>
         <p:spPr bwMode="auto">
-          <a:xfrm rot="0" flipH="0" flipV="0">
+          <a:xfrm>
             <a:off x="7837799" y="5628176"/>
             <a:ext cx="642272" cy="267095"/>
           </a:xfrm>
@@ -19077,7 +18916,7 @@
       </p:cxnSp>
       <p:cxnSp>
         <p:nvCxnSpPr>
-          <p:cNvPr id="873958203" name=""/>
+          <p:cNvPr id="873958203" name="Прямая соединительная линия 873958202"/>
           <p:cNvCxnSpPr>
             <a:stCxn id="142624812" idx="3"/>
             <a:endCxn id="1937440151" idx="2"/>
@@ -19085,7 +18924,7 @@
           <p:nvPr/>
         </p:nvCxnSpPr>
         <p:spPr bwMode="auto">
-          <a:xfrm rot="0" flipH="0" flipV="1">
+          <a:xfrm flipV="1">
             <a:off x="7837801" y="3629299"/>
             <a:ext cx="2778814" cy="1998876"/>
           </a:xfrm>
@@ -19120,7 +18959,7 @@
       </p:cxnSp>
       <p:cxnSp>
         <p:nvCxnSpPr>
-          <p:cNvPr id="1473911929" name=""/>
+          <p:cNvPr id="1473911929" name="Прямая соединительная линия 1473911928"/>
           <p:cNvCxnSpPr>
             <a:stCxn id="1736709910" idx="3"/>
             <a:endCxn id="1937440151" idx="1"/>
@@ -19128,7 +18967,7 @@
           <p:nvPr/>
         </p:nvCxnSpPr>
         <p:spPr bwMode="auto">
-          <a:xfrm rot="0" flipH="0" flipV="1">
+          <a:xfrm flipV="1">
             <a:off x="8651715" y="2611325"/>
             <a:ext cx="552751" cy="309120"/>
           </a:xfrm>
@@ -19163,7 +19002,7 @@
       </p:cxnSp>
       <p:cxnSp>
         <p:nvCxnSpPr>
-          <p:cNvPr id="120675869" name=""/>
+          <p:cNvPr id="120675869" name="Прямая соединительная линия 120675868"/>
           <p:cNvCxnSpPr>
             <a:stCxn id="1736709910" idx="3"/>
             <a:endCxn id="1528119454" idx="0"/>
@@ -19171,7 +19010,7 @@
           <p:nvPr/>
         </p:nvCxnSpPr>
         <p:spPr bwMode="auto">
-          <a:xfrm rot="0" flipH="0" flipV="0">
+          <a:xfrm>
             <a:off x="8651714" y="2920445"/>
             <a:ext cx="1602704" cy="2286385"/>
           </a:xfrm>
@@ -19209,11 +19048,11 @@
   <p:clrMapOvr>
     <a:masterClrMapping/>
   </p:clrMapOvr>
-  <mc:AlternateContent xmlns:mc="http://schemas.openxmlformats.org/markup-compatibility/2006">
-    <mc:Choice xmlns:p159="http://schemas.microsoft.com/office/powerpoint/2015/09/main" xmlns:p14="http://schemas.microsoft.com/office/powerpoint/2010/main" Requires="p159">
-      <p:transition p14:dur="500" advClick="1"/>
+  <mc:AlternateContent xmlns:mc="http://schemas.openxmlformats.org/markup-compatibility/2006" xmlns:p159="http://schemas.microsoft.com/office/powerpoint/2015/09/main">
+    <mc:Choice Requires="p159">
+      <p:transition/>
     </mc:Choice>
-    <mc:Fallback>
+    <mc:Fallback xmlns:w="http://schemas.openxmlformats.org/wordprocessingml/2006/main" xmlns:m="http://schemas.openxmlformats.org/officeDocument/2006/math" xmlns="">
       <p:transition advClick="1"/>
     </mc:Fallback>
   </mc:AlternateContent>
@@ -19221,10 +19060,10 @@
 </file>
 
 <file path=ppt/slides/slide9.xml><?xml version="1.0" encoding="utf-8"?>
-<p:sld xmlns:a="http://schemas.openxmlformats.org/drawingml/2006/main" xmlns:r="http://schemas.openxmlformats.org/officeDocument/2006/relationships" xmlns:p="http://schemas.openxmlformats.org/presentationml/2006/main" xmlns:m="http://schemas.openxmlformats.org/officeDocument/2006/math" xmlns:w="http://schemas.openxmlformats.org/wordprocessingml/2006/main" xmlns:mc="http://schemas.openxmlformats.org/markup-compatibility/2006" showMasterPhAnim="0" showMasterSp="1" show="1">
-  <p:cSld name="">
+<p:sld xmlns:a="http://schemas.openxmlformats.org/drawingml/2006/main" xmlns:r="http://schemas.openxmlformats.org/officeDocument/2006/relationships" xmlns:p="http://schemas.openxmlformats.org/presentationml/2006/main" showMasterPhAnim="0">
+  <p:cSld>
     <p:bg>
-      <p:bgPr shadeToTitle="0">
+      <p:bgPr>
         <a:gradFill>
           <a:gsLst>
             <a:gs pos="0">
@@ -19254,6 +19093,7 @@
           </a:gsLst>
           <a:lin ang="13500000" scaled="1"/>
         </a:gradFill>
+        <a:effectLst/>
       </p:bgPr>
     </p:bg>
     <p:spTree>
@@ -19281,14 +19121,14 @@
           </p:nvPr>
         </p:nvSpPr>
         <p:spPr bwMode="auto">
-          <a:xfrm flipH="0" flipV="0">
+          <a:xfrm>
             <a:off x="153374" y="1523999"/>
             <a:ext cx="5067299" cy="4762499"/>
           </a:xfrm>
         </p:spPr>
         <p:txBody>
-          <a:bodyPr vertOverflow="overflow" horzOverflow="overflow" vert="horz" wrap="square" lIns="91440" tIns="45720" rIns="91440" bIns="45720" numCol="1" spcCol="0" rtlCol="0" fromWordArt="0" anchor="t" anchorCtr="0" forceAA="0" upright="0" compatLnSpc="0">
-            <a:normAutofit fontScale="90000" lnSpcReduction="2000"/>
+          <a:bodyPr vertOverflow="overflow" horzOverflow="overflow" vert="horz" wrap="square" lIns="91440" tIns="45720" rIns="91440" bIns="45720" numCol="1" spcCol="0" rtlCol="0" fromWordArt="0" anchor="t" anchorCtr="0" forceAA="0" compatLnSpc="0">
+            <a:normAutofit fontScale="90000" lnSpcReduction="12000"/>
           </a:bodyPr>
           <a:lstStyle/>
           <a:p>
@@ -19345,11 +19185,7 @@
             </a:r>
             <a:r>
               <a:rPr lang="ru-RU"/>
-              <a:t> </a:t>
-            </a:r>
-            <a:r>
-              <a:rPr lang="ru-RU"/>
-              <a:t>– вычислительный блок;</a:t>
+              <a:t> – вычислительный блок;</a:t>
             </a:r>
             <a:endParaRPr/>
           </a:p>
@@ -19363,11 +19199,7 @@
             </a:r>
             <a:r>
               <a:rPr lang="ru-RU"/>
-              <a:t>блок загрузки/сохранения данных</a:t>
-            </a:r>
-            <a:r>
-              <a:rPr lang="ru-RU"/>
-              <a:t>;</a:t>
+              <a:t>блок загрузки/сохранения данных;</a:t>
             </a:r>
             <a:endParaRPr/>
           </a:p>
@@ -19381,13 +19213,8 @@
             </a:r>
             <a:r>
               <a:rPr lang="ru-RU"/>
-              <a:t>- контрольно-статусные регистры. </a:t>
-            </a:r>
-            <a:r>
-              <a:rPr lang="ru-RU"/>
-              <a:t>Содержат статусные и управляющие сигналы связанные с самим графическим ядром;</a:t>
-            </a:r>
-            <a:endParaRPr lang="ru-RU"/>
+              <a:t>- контрольно-статусные регистры. Содержат статусные и управляющие сигналы связанные с самим графическим ядром;</a:t>
+            </a:r>
           </a:p>
           <a:p>
             <a:pPr>
@@ -19399,11 +19226,7 @@
             </a:r>
             <a:r>
               <a:rPr lang="ru-RU"/>
-              <a:t>счётчик инструкций</a:t>
-            </a:r>
-            <a:r>
-              <a:rPr lang="ru-RU"/>
-              <a:t>.</a:t>
+              <a:t>счётчик инструкций.</a:t>
             </a:r>
             <a:endParaRPr lang="en-US"/>
           </a:p>
@@ -19439,7 +19262,7 @@
                 </a:solidFill>
                 <a:latin typeface="Trebuchet MS"/>
               </a:rPr>
-              <a:t>7</a:t>
+              <a:t>9</a:t>
             </a:fld>
             <a:endParaRPr lang="ru-RU" sz="1800">
               <a:solidFill>
@@ -19604,26 +19427,30 @@
       </p:sp>
       <p:pic>
         <p:nvPicPr>
-          <p:cNvPr id="1840874631" name=""/>
+          <p:cNvPr id="1840874631" name="Рисунок 1840874630"/>
           <p:cNvPicPr>
             <a:picLocks noChangeAspect="1"/>
           </p:cNvPicPr>
           <p:nvPr/>
         </p:nvPicPr>
-        <p:blipFill rotWithShape="1">
+        <p:blipFill>
           <a:blip r:embed="rId3">
             <a:extLst>
+              <a:ext uri="{28A0092B-C50C-407E-A947-70E740481C1C}">
+                <a14:useLocalDpi xmlns:a14="http://schemas.microsoft.com/office/drawing/2010/main" val="0"/>
+              </a:ext>
               <a:ext uri="{96DAC541-7B7A-43D3-8B79-37D633B846F1}">
                 <asvg:svgBlip xmlns:asvg="http://schemas.microsoft.com/office/drawing/2016/SVG/main" r:embed="rId4"/>
               </a:ext>
             </a:extLst>
           </a:blip>
+          <a:srcRect/>
           <a:stretch/>
         </p:blipFill>
         <p:spPr bwMode="auto">
-          <a:xfrm flipH="0" flipV="0">
-            <a:off x="5603317" y="1473409"/>
-            <a:ext cx="5766954" cy="5249527"/>
+          <a:xfrm>
+            <a:off x="5603317" y="1477684"/>
+            <a:ext cx="5766954" cy="5240977"/>
           </a:xfrm>
           <a:prstGeom prst="rect">
             <a:avLst/>
@@ -19635,11 +19462,11 @@
   <p:clrMapOvr>
     <a:masterClrMapping/>
   </p:clrMapOvr>
-  <mc:AlternateContent xmlns:mc="http://schemas.openxmlformats.org/markup-compatibility/2006">
-    <mc:Choice xmlns:p159="http://schemas.microsoft.com/office/powerpoint/2015/09/main" xmlns:p14="http://schemas.microsoft.com/office/powerpoint/2010/main" Requires="p159">
-      <p:transition p14:dur="500" advClick="1"/>
+  <mc:AlternateContent xmlns:mc="http://schemas.openxmlformats.org/markup-compatibility/2006" xmlns:p159="http://schemas.microsoft.com/office/powerpoint/2015/09/main">
+    <mc:Choice Requires="p159">
+      <p:transition/>
     </mc:Choice>
-    <mc:Fallback>
+    <mc:Fallback xmlns:w="http://schemas.openxmlformats.org/wordprocessingml/2006/main" xmlns:m="http://schemas.openxmlformats.org/officeDocument/2006/math" xmlns="">
       <p:transition advClick="1"/>
     </mc:Fallback>
   </mc:AlternateContent>
@@ -19647,7 +19474,7 @@
 </file>
 
 <file path=ppt/theme/theme1.xml><?xml version="1.0" encoding="utf-8"?>
-<a:theme xmlns:a="http://schemas.openxmlformats.org/drawingml/2006/main" xmlns:r="http://schemas.openxmlformats.org/officeDocument/2006/relationships" xmlns:p="http://schemas.openxmlformats.org/presentationml/2006/main" name="Тема Office">
+<a:theme xmlns:a="http://schemas.openxmlformats.org/drawingml/2006/main" name="Тема Office">
   <a:themeElements>
     <a:clrScheme name="Стандартная">
       <a:dk1>
@@ -19838,11 +19665,12 @@
     </a:fmtScheme>
   </a:themeElements>
   <a:objectDefaults/>
+  <a:extraClrSchemeLst/>
 </a:theme>
 </file>
 
 <file path=ppt/theme/theme2.xml><?xml version="1.0" encoding="utf-8"?>
-<a:theme xmlns:a="http://schemas.openxmlformats.org/drawingml/2006/main" xmlns:r="http://schemas.openxmlformats.org/officeDocument/2006/relationships" xmlns:p="http://schemas.openxmlformats.org/presentationml/2006/main" name="Тема Office">
+<a:theme xmlns:a="http://schemas.openxmlformats.org/drawingml/2006/main" name="Тема Office">
   <a:themeElements>
     <a:clrScheme name="Стандартная">
       <a:dk1>
@@ -20033,5 +19861,6 @@
     </a:fmtScheme>
   </a:themeElements>
   <a:objectDefaults/>
+  <a:extraClrSchemeLst/>
 </a:theme>
 </file>
</xml_diff>